<commit_message>
Aggiunto strategy nella presentazione
</commit_message>
<xml_diff>
--- a/doc/Presentazione/Presentazione_ingsw_parteB.pptx
+++ b/doc/Presentazione/Presentazione_ingsw_parteB.pptx
@@ -5,7 +5,7 @@
     <p:sldMasterId id="2147483648" r:id="rId1"/>
   </p:sldMasterIdLst>
   <p:notesMasterIdLst>
-    <p:notesMasterId r:id="rId29"/>
+    <p:notesMasterId r:id="rId31"/>
   </p:notesMasterIdLst>
   <p:sldIdLst>
     <p:sldId id="256" r:id="rId2"/>
@@ -21,20 +21,22 @@
     <p:sldId id="265" r:id="rId12"/>
     <p:sldId id="266" r:id="rId13"/>
     <p:sldId id="267" r:id="rId14"/>
-    <p:sldId id="281" r:id="rId15"/>
-    <p:sldId id="282" r:id="rId16"/>
-    <p:sldId id="268" r:id="rId17"/>
-    <p:sldId id="269" r:id="rId18"/>
-    <p:sldId id="270" r:id="rId19"/>
-    <p:sldId id="271" r:id="rId20"/>
-    <p:sldId id="272" r:id="rId21"/>
-    <p:sldId id="283" r:id="rId22"/>
-    <p:sldId id="273" r:id="rId23"/>
-    <p:sldId id="274" r:id="rId24"/>
-    <p:sldId id="275" r:id="rId25"/>
-    <p:sldId id="276" r:id="rId26"/>
-    <p:sldId id="277" r:id="rId27"/>
-    <p:sldId id="278" r:id="rId28"/>
+    <p:sldId id="284" r:id="rId15"/>
+    <p:sldId id="285" r:id="rId16"/>
+    <p:sldId id="281" r:id="rId17"/>
+    <p:sldId id="282" r:id="rId18"/>
+    <p:sldId id="268" r:id="rId19"/>
+    <p:sldId id="269" r:id="rId20"/>
+    <p:sldId id="270" r:id="rId21"/>
+    <p:sldId id="271" r:id="rId22"/>
+    <p:sldId id="272" r:id="rId23"/>
+    <p:sldId id="283" r:id="rId24"/>
+    <p:sldId id="273" r:id="rId25"/>
+    <p:sldId id="274" r:id="rId26"/>
+    <p:sldId id="275" r:id="rId27"/>
+    <p:sldId id="276" r:id="rId28"/>
+    <p:sldId id="277" r:id="rId29"/>
+    <p:sldId id="278" r:id="rId30"/>
   </p:sldIdLst>
   <p:sldSz cx="12192000" cy="6858000"/>
   <p:notesSz cx="6858000" cy="9144000"/>
@@ -240,7 +242,7 @@
             </a:pPr>
             <a:fld id="{3632E96E-41F7-40C5-8419-297958CC00FA}" type="datetimeFigureOut">
               <a:rPr lang="it-IT"/>
-              <a:t>21/10/2025</a:t>
+              <a:t>23/10/2025</a:t>
             </a:fld>
             <a:endParaRPr lang="it-IT"/>
           </a:p>
@@ -859,7 +861,7 @@
             </a:pPr>
             <a:fld id="{1CD94749-6FDA-4E9C-36AB-734731960A87}" type="slidenum">
               <a:rPr/>
-              <a:t>16</a:t>
+              <a:t>18</a:t>
             </a:fld>
             <a:endParaRPr/>
           </a:p>
@@ -944,7 +946,7 @@
             </a:pPr>
             <a:fld id="{E2F52480-0813-D9C9-E145-46E7CB451224}" type="slidenum">
               <a:rPr/>
-              <a:t>17</a:t>
+              <a:t>19</a:t>
             </a:fld>
             <a:endParaRPr/>
           </a:p>
@@ -1029,7 +1031,7 @@
             </a:pPr>
             <a:fld id="{2CB3A339-E4F5-9849-5159-B780C46036EF}" type="slidenum">
               <a:rPr/>
-              <a:t>18</a:t>
+              <a:t>20</a:t>
             </a:fld>
             <a:endParaRPr/>
           </a:p>
@@ -1114,7 +1116,7 @@
             </a:pPr>
             <a:fld id="{7754AAF7-24FB-4C7D-56D0-9F6828B47495}" type="slidenum">
               <a:rPr/>
-              <a:t>19</a:t>
+              <a:t>21</a:t>
             </a:fld>
             <a:endParaRPr/>
           </a:p>
@@ -1199,7 +1201,7 @@
             </a:pPr>
             <a:fld id="{ECC01B90-6EF3-4614-96E6-28D52D163363}" type="slidenum">
               <a:rPr/>
-              <a:t>20</a:t>
+              <a:t>22</a:t>
             </a:fld>
             <a:endParaRPr/>
           </a:p>
@@ -1308,7 +1310,7 @@
             </a:pPr>
             <a:fld id="{ECC01B90-6EF3-4614-96E6-28D52D163363}" type="slidenum">
               <a:rPr/>
-              <a:t>21</a:t>
+              <a:t>23</a:t>
             </a:fld>
             <a:endParaRPr/>
           </a:p>
@@ -1398,7 +1400,7 @@
             </a:pPr>
             <a:fld id="{C1B0ED42-154C-37AC-EA60-9CE5185831C2}" type="slidenum">
               <a:rPr/>
-              <a:t>22</a:t>
+              <a:t>24</a:t>
             </a:fld>
             <a:endParaRPr/>
           </a:p>
@@ -1483,7 +1485,7 @@
             </a:pPr>
             <a:fld id="{97CE3B5A-C7B8-C31E-D05F-021B77FFEF0E}" type="slidenum">
               <a:rPr/>
-              <a:t>23</a:t>
+              <a:t>25</a:t>
             </a:fld>
             <a:endParaRPr/>
           </a:p>
@@ -1653,7 +1655,7 @@
             </a:pPr>
             <a:fld id="{373A4F64-1DDB-898D-3141-351BAF57DA12}" type="slidenum">
               <a:rPr/>
-              <a:t>24</a:t>
+              <a:t>26</a:t>
             </a:fld>
             <a:endParaRPr/>
           </a:p>
@@ -1738,7 +1740,7 @@
             </a:pPr>
             <a:fld id="{E0EEA2AC-6940-83FF-9A62-FDE019F8CFBA}" type="slidenum">
               <a:rPr/>
-              <a:t>25</a:t>
+              <a:t>27</a:t>
             </a:fld>
             <a:endParaRPr/>
           </a:p>
@@ -1823,7 +1825,7 @@
             </a:pPr>
             <a:fld id="{34DDF272-15C9-97B8-0696-B071723A3A34}" type="slidenum">
               <a:rPr/>
-              <a:t>26</a:t>
+              <a:t>28</a:t>
             </a:fld>
             <a:endParaRPr/>
           </a:p>
@@ -1908,7 +1910,7 @@
             </a:pPr>
             <a:fld id="{63195650-B0F5-4319-E0B1-4A630F16C93D}" type="slidenum">
               <a:rPr/>
-              <a:t>27</a:t>
+              <a:t>29</a:t>
             </a:fld>
             <a:endParaRPr/>
           </a:p>
@@ -2655,7 +2657,7 @@
             </a:pPr>
             <a:fld id="{BCC18F51-09EC-435C-A3BA-64A766E099C0}" type="datetimeFigureOut">
               <a:rPr lang="it-IT"/>
-              <a:t>21/10/2025</a:t>
+              <a:t>23/10/2025</a:t>
             </a:fld>
             <a:endParaRPr lang="it-IT"/>
           </a:p>
@@ -2844,7 +2846,7 @@
             </a:pPr>
             <a:fld id="{BCC18F51-09EC-435C-A3BA-64A766E099C0}" type="datetimeFigureOut">
               <a:rPr lang="it-IT"/>
-              <a:t>21/10/2025</a:t>
+              <a:t>23/10/2025</a:t>
             </a:fld>
             <a:endParaRPr lang="it-IT"/>
           </a:p>
@@ -3043,7 +3045,7 @@
             </a:pPr>
             <a:fld id="{BCC18F51-09EC-435C-A3BA-64A766E099C0}" type="datetimeFigureOut">
               <a:rPr lang="it-IT"/>
-              <a:t>21/10/2025</a:t>
+              <a:t>23/10/2025</a:t>
             </a:fld>
             <a:endParaRPr lang="it-IT"/>
           </a:p>
@@ -3232,7 +3234,7 @@
             </a:pPr>
             <a:fld id="{BCC18F51-09EC-435C-A3BA-64A766E099C0}" type="datetimeFigureOut">
               <a:rPr lang="it-IT"/>
-              <a:t>21/10/2025</a:t>
+              <a:t>23/10/2025</a:t>
             </a:fld>
             <a:endParaRPr lang="it-IT"/>
           </a:p>
@@ -3487,7 +3489,7 @@
             </a:pPr>
             <a:fld id="{BCC18F51-09EC-435C-A3BA-64A766E099C0}" type="datetimeFigureOut">
               <a:rPr lang="it-IT"/>
-              <a:t>21/10/2025</a:t>
+              <a:t>23/10/2025</a:t>
             </a:fld>
             <a:endParaRPr lang="it-IT"/>
           </a:p>
@@ -3751,7 +3753,7 @@
             </a:pPr>
             <a:fld id="{BCC18F51-09EC-435C-A3BA-64A766E099C0}" type="datetimeFigureOut">
               <a:rPr lang="it-IT"/>
-              <a:t>21/10/2025</a:t>
+              <a:t>23/10/2025</a:t>
             </a:fld>
             <a:endParaRPr lang="it-IT"/>
           </a:p>
@@ -4156,7 +4158,7 @@
             </a:pPr>
             <a:fld id="{BCC18F51-09EC-435C-A3BA-64A766E099C0}" type="datetimeFigureOut">
               <a:rPr lang="it-IT"/>
-              <a:t>21/10/2025</a:t>
+              <a:t>23/10/2025</a:t>
             </a:fld>
             <a:endParaRPr lang="it-IT"/>
           </a:p>
@@ -4280,7 +4282,7 @@
             </a:pPr>
             <a:fld id="{BCC18F51-09EC-435C-A3BA-64A766E099C0}" type="datetimeFigureOut">
               <a:rPr lang="it-IT"/>
-              <a:t>21/10/2025</a:t>
+              <a:t>23/10/2025</a:t>
             </a:fld>
             <a:endParaRPr lang="it-IT"/>
           </a:p>
@@ -4379,7 +4381,7 @@
             </a:pPr>
             <a:fld id="{BCC18F51-09EC-435C-A3BA-64A766E099C0}" type="datetimeFigureOut">
               <a:rPr lang="it-IT"/>
-              <a:t>21/10/2025</a:t>
+              <a:t>23/10/2025</a:t>
             </a:fld>
             <a:endParaRPr lang="it-IT"/>
           </a:p>
@@ -4678,7 +4680,7 @@
             </a:pPr>
             <a:fld id="{BCC18F51-09EC-435C-A3BA-64A766E099C0}" type="datetimeFigureOut">
               <a:rPr lang="it-IT"/>
-              <a:t>21/10/2025</a:t>
+              <a:t>23/10/2025</a:t>
             </a:fld>
             <a:endParaRPr lang="it-IT"/>
           </a:p>
@@ -4946,7 +4948,7 @@
             </a:pPr>
             <a:fld id="{BCC18F51-09EC-435C-A3BA-64A766E099C0}" type="datetimeFigureOut">
               <a:rPr lang="it-IT"/>
-              <a:t>21/10/2025</a:t>
+              <a:t>23/10/2025</a:t>
             </a:fld>
             <a:endParaRPr lang="it-IT"/>
           </a:p>
@@ -5201,7 +5203,7 @@
             </a:pPr>
             <a:fld id="{BCC18F51-09EC-435C-A3BA-64A766E099C0}" type="datetimeFigureOut">
               <a:rPr lang="it-IT"/>
-              <a:t>21/10/2025</a:t>
+              <a:t>23/10/2025</a:t>
             </a:fld>
             <a:endParaRPr lang="it-IT"/>
           </a:p>
@@ -6409,7 +6411,7 @@
               <a:defRPr/>
             </a:pPr>
             <a:r>
-              <a:rPr lang="en" b="1" dirty="0">
+              <a:rPr lang="it-IT" b="1">
                 <a:solidFill>
                   <a:srgbClr val="0070C0"/>
                 </a:solidFill>
@@ -6419,7 +6421,7 @@
               </a:rPr>
               <a:t>GoF 1 – Strategy</a:t>
             </a:r>
-            <a:endParaRPr dirty="0"/>
+            <a:endParaRPr lang="it-IT" dirty="0"/>
           </a:p>
         </p:txBody>
       </p:sp>
@@ -6433,24 +6435,135 @@
             <p:ph idx="1"/>
           </p:nvPr>
         </p:nvSpPr>
-        <p:spPr bwMode="auto"/>
-        <p:txBody>
-          <a:bodyPr/>
+        <p:spPr bwMode="auto">
+          <a:xfrm>
+            <a:off x="838200" y="1825625"/>
+            <a:ext cx="4912264" cy="4524376"/>
+          </a:xfrm>
+        </p:spPr>
+        <p:txBody>
+          <a:bodyPr>
+            <a:normAutofit lnSpcReduction="10000"/>
+          </a:bodyPr>
           <a:lstStyle/>
           <a:p>
             <a:pPr marL="0" indent="0">
-              <a:buFont typeface="Arial"/>
               <a:buNone/>
               <a:defRPr/>
             </a:pPr>
             <a:r>
-              <a:rPr lang="en-GB" dirty="0"/>
-              <a:t>TODO</a:t>
-            </a:r>
-            <a:endParaRPr dirty="0"/>
-          </a:p>
-        </p:txBody>
-      </p:sp>
+              <a:rPr lang="it-IT" sz="2400" dirty="0"/>
+              <a:t>Per ogni caso d’uso è stata definita una classe di eccezione dedicata che estende una base comune.</a:t>
+            </a:r>
+          </a:p>
+          <a:p>
+            <a:pPr marL="0" indent="0">
+              <a:buNone/>
+              <a:defRPr/>
+            </a:pPr>
+            <a:br>
+              <a:rPr lang="it-IT" sz="2400" dirty="0"/>
+            </a:br>
+            <a:r>
+              <a:rPr lang="it-IT" sz="2400" dirty="0"/>
+              <a:t>La classe </a:t>
+            </a:r>
+            <a:r>
+              <a:rPr lang="it-IT" sz="2400" i="1" dirty="0" err="1"/>
+              <a:t>BaseUseCaseException</a:t>
+            </a:r>
+            <a:r>
+              <a:rPr lang="it-IT" sz="2400" dirty="0"/>
+              <a:t> fornisce un’interfaccia uniforme per identificare il tipo di caso d’uso e il relativo codice di errore.</a:t>
+            </a:r>
+          </a:p>
+          <a:p>
+            <a:pPr marL="0" indent="0">
+              <a:buNone/>
+              <a:defRPr/>
+            </a:pPr>
+            <a:endParaRPr lang="it-IT" sz="2400" dirty="0"/>
+          </a:p>
+          <a:p>
+            <a:pPr marL="0" indent="0">
+              <a:buNone/>
+              <a:defRPr/>
+            </a:pPr>
+            <a:r>
+              <a:rPr lang="it-IT" sz="2400" dirty="0"/>
+              <a:t>Ogni caso d’uso (es. booking, </a:t>
+            </a:r>
+            <a:r>
+              <a:rPr lang="it-IT" sz="2400" dirty="0" err="1"/>
+              <a:t>visit</a:t>
+            </a:r>
+            <a:r>
+              <a:rPr lang="it-IT" sz="2400" dirty="0"/>
+              <a:t>, user, ecc.) definisce la propria eccezione specializzata.</a:t>
+            </a:r>
+          </a:p>
+        </p:txBody>
+      </p:sp>
+      <p:pic>
+        <p:nvPicPr>
+          <p:cNvPr id="11" name="Immagine 10">
+            <a:extLst>
+              <a:ext uri="{FF2B5EF4-FFF2-40B4-BE49-F238E27FC236}">
+                <a16:creationId xmlns:a16="http://schemas.microsoft.com/office/drawing/2014/main" id="{C0AF5EEF-562C-0541-539D-7D56F7A46931}"/>
+              </a:ext>
+            </a:extLst>
+          </p:cNvPr>
+          <p:cNvPicPr>
+            <a:picLocks noChangeAspect="1"/>
+          </p:cNvPicPr>
+          <p:nvPr/>
+        </p:nvPicPr>
+        <p:blipFill>
+          <a:blip r:embed="rId3"/>
+          <a:stretch>
+            <a:fillRect/>
+          </a:stretch>
+        </p:blipFill>
+        <p:spPr>
+          <a:xfrm>
+            <a:off x="6095999" y="2101850"/>
+            <a:ext cx="5476875" cy="1066800"/>
+          </a:xfrm>
+          <a:prstGeom prst="rect">
+            <a:avLst/>
+          </a:prstGeom>
+        </p:spPr>
+      </p:pic>
+      <p:pic>
+        <p:nvPicPr>
+          <p:cNvPr id="13" name="Immagine 12">
+            <a:extLst>
+              <a:ext uri="{FF2B5EF4-FFF2-40B4-BE49-F238E27FC236}">
+                <a16:creationId xmlns:a16="http://schemas.microsoft.com/office/drawing/2014/main" id="{34EABFE9-C4A2-27F3-A14D-14259F443AFF}"/>
+              </a:ext>
+            </a:extLst>
+          </p:cNvPr>
+          <p:cNvPicPr>
+            <a:picLocks noChangeAspect="1"/>
+          </p:cNvPicPr>
+          <p:nvPr/>
+        </p:nvPicPr>
+        <p:blipFill>
+          <a:blip r:embed="rId4"/>
+          <a:stretch>
+            <a:fillRect/>
+          </a:stretch>
+        </p:blipFill>
+        <p:spPr>
+          <a:xfrm>
+            <a:off x="6095999" y="3995449"/>
+            <a:ext cx="5476875" cy="1417926"/>
+          </a:xfrm>
+          <a:prstGeom prst="rect">
+            <a:avLst/>
+          </a:prstGeom>
+        </p:spPr>
+      </p:pic>
     </p:spTree>
   </p:cSld>
   <p:clrMapOvr>
@@ -6478,6 +6591,276 @@
       </p:grpSpPr>
       <p:sp>
         <p:nvSpPr>
+          <p:cNvPr id="3" name="Segnaposto contenuto 2">
+            <a:extLst>
+              <a:ext uri="{FF2B5EF4-FFF2-40B4-BE49-F238E27FC236}">
+                <a16:creationId xmlns:a16="http://schemas.microsoft.com/office/drawing/2014/main" id="{7EA6502C-420E-A491-1174-69EA9BBC4B55}"/>
+              </a:ext>
+            </a:extLst>
+          </p:cNvPr>
+          <p:cNvSpPr>
+            <a:spLocks noGrp="1"/>
+          </p:cNvSpPr>
+          <p:nvPr>
+            <p:ph idx="1"/>
+          </p:nvPr>
+        </p:nvSpPr>
+        <p:spPr>
+          <a:xfrm>
+            <a:off x="965200" y="1012825"/>
+            <a:ext cx="4152900" cy="2657475"/>
+          </a:xfrm>
+        </p:spPr>
+        <p:txBody>
+          <a:bodyPr>
+            <a:normAutofit/>
+          </a:bodyPr>
+          <a:lstStyle/>
+          <a:p>
+            <a:pPr marL="0" indent="0">
+              <a:buNone/>
+            </a:pPr>
+            <a:r>
+              <a:rPr lang="it-IT" sz="2000" dirty="0"/>
+              <a:t>L’architettura utilizza il pattern Strategy per delegare la gestione di ogni eccezione alla strategia corrispondente.</a:t>
+            </a:r>
+          </a:p>
+          <a:p>
+            <a:pPr marL="0" indent="0">
+              <a:buNone/>
+            </a:pPr>
+            <a:endParaRPr lang="it-IT" sz="2000" dirty="0"/>
+          </a:p>
+          <a:p>
+            <a:pPr marL="0" indent="0">
+              <a:buNone/>
+            </a:pPr>
+            <a:r>
+              <a:rPr lang="it-IT" sz="2000" dirty="0" err="1"/>
+              <a:t>GlobalExceptionHandler</a:t>
+            </a:r>
+            <a:r>
+              <a:rPr lang="it-IT" sz="2000" dirty="0"/>
+              <a:t> individua la strategia appropriata e ne invoca il metodo </a:t>
+            </a:r>
+            <a:r>
+              <a:rPr lang="it-IT" sz="2000" dirty="0" err="1"/>
+              <a:t>handleException</a:t>
+            </a:r>
+            <a:r>
+              <a:rPr lang="it-IT" sz="2000" dirty="0"/>
+              <a:t>().</a:t>
+            </a:r>
+          </a:p>
+        </p:txBody>
+      </p:sp>
+      <p:pic>
+        <p:nvPicPr>
+          <p:cNvPr id="1026" name="Picture 2">
+            <a:extLst>
+              <a:ext uri="{FF2B5EF4-FFF2-40B4-BE49-F238E27FC236}">
+                <a16:creationId xmlns:a16="http://schemas.microsoft.com/office/drawing/2014/main" id="{60622C8F-0C43-9356-8300-A51DCCD9E0B9}"/>
+              </a:ext>
+            </a:extLst>
+          </p:cNvPr>
+          <p:cNvPicPr>
+            <a:picLocks noChangeAspect="1" noChangeArrowheads="1"/>
+          </p:cNvPicPr>
+          <p:nvPr/>
+        </p:nvPicPr>
+        <p:blipFill>
+          <a:blip r:embed="rId2">
+            <a:extLst>
+              <a:ext uri="{28A0092B-C50C-407E-A947-70E740481C1C}">
+                <a14:useLocalDpi xmlns:a14="http://schemas.microsoft.com/office/drawing/2010/main" val="0"/>
+              </a:ext>
+            </a:extLst>
+          </a:blip>
+          <a:srcRect/>
+          <a:stretch>
+            <a:fillRect/>
+          </a:stretch>
+        </p:blipFill>
+        <p:spPr bwMode="auto">
+          <a:xfrm>
+            <a:off x="1414504" y="4106368"/>
+            <a:ext cx="9134391" cy="1772213"/>
+          </a:xfrm>
+          <a:prstGeom prst="rect">
+            <a:avLst/>
+          </a:prstGeom>
+          <a:noFill/>
+          <a:extLst>
+            <a:ext uri="{909E8E84-426E-40DD-AFC4-6F175D3DCCD1}">
+              <a14:hiddenFill xmlns:a14="http://schemas.microsoft.com/office/drawing/2010/main">
+                <a:solidFill>
+                  <a:srgbClr val="FFFFFF"/>
+                </a:solidFill>
+              </a14:hiddenFill>
+            </a:ext>
+          </a:extLst>
+        </p:spPr>
+      </p:pic>
+      <p:pic>
+        <p:nvPicPr>
+          <p:cNvPr id="9" name="Immagine 8">
+            <a:extLst>
+              <a:ext uri="{FF2B5EF4-FFF2-40B4-BE49-F238E27FC236}">
+                <a16:creationId xmlns:a16="http://schemas.microsoft.com/office/drawing/2014/main" id="{59BF2B24-0B25-3F28-FB61-A430468AE576}"/>
+              </a:ext>
+            </a:extLst>
+          </p:cNvPr>
+          <p:cNvPicPr>
+            <a:picLocks noChangeAspect="1"/>
+          </p:cNvPicPr>
+          <p:nvPr/>
+        </p:nvPicPr>
+        <p:blipFill>
+          <a:blip r:embed="rId3"/>
+          <a:stretch>
+            <a:fillRect/>
+          </a:stretch>
+        </p:blipFill>
+        <p:spPr>
+          <a:xfrm>
+            <a:off x="5219700" y="979419"/>
+            <a:ext cx="6007100" cy="2449581"/>
+          </a:xfrm>
+          <a:prstGeom prst="rect">
+            <a:avLst/>
+          </a:prstGeom>
+        </p:spPr>
+      </p:pic>
+    </p:spTree>
+    <p:extLst>
+      <p:ext uri="{BB962C8B-B14F-4D97-AF65-F5344CB8AC3E}">
+        <p14:creationId xmlns:p14="http://schemas.microsoft.com/office/powerpoint/2010/main" val="3951014746"/>
+      </p:ext>
+    </p:extLst>
+  </p:cSld>
+  <p:clrMapOvr>
+    <a:masterClrMapping/>
+  </p:clrMapOvr>
+</p:sld>
+</file>
+
+<file path=ppt/slides/slide15.xml><?xml version="1.0" encoding="utf-8"?>
+<p:sld xmlns:a="http://schemas.openxmlformats.org/drawingml/2006/main" xmlns:r="http://schemas.openxmlformats.org/officeDocument/2006/relationships" xmlns:p="http://schemas.openxmlformats.org/presentationml/2006/main">
+  <p:cSld>
+    <p:spTree>
+      <p:nvGrpSpPr>
+        <p:cNvPr id="1" name=""/>
+        <p:cNvGrpSpPr/>
+        <p:nvPr/>
+      </p:nvGrpSpPr>
+      <p:grpSpPr>
+        <a:xfrm>
+          <a:off x="0" y="0"/>
+          <a:ext cx="0" cy="0"/>
+          <a:chOff x="0" y="0"/>
+          <a:chExt cx="0" cy="0"/>
+        </a:xfrm>
+      </p:grpSpPr>
+      <p:sp>
+        <p:nvSpPr>
+          <p:cNvPr id="3" name="Segnaposto contenuto 2">
+            <a:extLst>
+              <a:ext uri="{FF2B5EF4-FFF2-40B4-BE49-F238E27FC236}">
+                <a16:creationId xmlns:a16="http://schemas.microsoft.com/office/drawing/2014/main" id="{0FD045B2-527F-D4E0-3BC2-34C356DC7FCC}"/>
+              </a:ext>
+            </a:extLst>
+          </p:cNvPr>
+          <p:cNvSpPr>
+            <a:spLocks noGrp="1"/>
+          </p:cNvSpPr>
+          <p:nvPr>
+            <p:ph idx="1"/>
+          </p:nvPr>
+        </p:nvSpPr>
+        <p:spPr>
+          <a:xfrm>
+            <a:off x="863600" y="1725612"/>
+            <a:ext cx="4648200" cy="3406775"/>
+          </a:xfrm>
+        </p:spPr>
+        <p:txBody>
+          <a:bodyPr>
+            <a:normAutofit/>
+          </a:bodyPr>
+          <a:lstStyle/>
+          <a:p>
+            <a:pPr marL="0" indent="0">
+              <a:buNone/>
+            </a:pPr>
+            <a:r>
+              <a:rPr lang="it-IT" sz="2400" dirty="0"/>
+              <a:t>In base al codice d’errore, la strategia seleziona lo status HTTP più appropriato (es. 400, 404) e costruisce un messaggio chiaro e non tecnico per l’utente. I dettagli interni vengono registrati nei log di sistema; al client viene restituita solo l’informazione utile all’azione successiva.</a:t>
+            </a:r>
+          </a:p>
+        </p:txBody>
+      </p:sp>
+      <p:pic>
+        <p:nvPicPr>
+          <p:cNvPr id="9" name="Immagine 8">
+            <a:extLst>
+              <a:ext uri="{FF2B5EF4-FFF2-40B4-BE49-F238E27FC236}">
+                <a16:creationId xmlns:a16="http://schemas.microsoft.com/office/drawing/2014/main" id="{3FCD7598-BE01-71AC-8AE4-BE6FA7849BAC}"/>
+              </a:ext>
+            </a:extLst>
+          </p:cNvPr>
+          <p:cNvPicPr>
+            <a:picLocks noChangeAspect="1"/>
+          </p:cNvPicPr>
+          <p:nvPr/>
+        </p:nvPicPr>
+        <p:blipFill>
+          <a:blip r:embed="rId2"/>
+          <a:stretch>
+            <a:fillRect/>
+          </a:stretch>
+        </p:blipFill>
+        <p:spPr>
+          <a:xfrm>
+            <a:off x="6096000" y="862805"/>
+            <a:ext cx="5725238" cy="5132388"/>
+          </a:xfrm>
+          <a:prstGeom prst="rect">
+            <a:avLst/>
+          </a:prstGeom>
+        </p:spPr>
+      </p:pic>
+    </p:spTree>
+    <p:extLst>
+      <p:ext uri="{BB962C8B-B14F-4D97-AF65-F5344CB8AC3E}">
+        <p14:creationId xmlns:p14="http://schemas.microsoft.com/office/powerpoint/2010/main" val="2868949747"/>
+      </p:ext>
+    </p:extLst>
+  </p:cSld>
+  <p:clrMapOvr>
+    <a:masterClrMapping/>
+  </p:clrMapOvr>
+</p:sld>
+</file>
+
+<file path=ppt/slides/slide16.xml><?xml version="1.0" encoding="utf-8"?>
+<p:sld xmlns:a="http://schemas.openxmlformats.org/drawingml/2006/main" xmlns:r="http://schemas.openxmlformats.org/officeDocument/2006/relationships" xmlns:p="http://schemas.openxmlformats.org/presentationml/2006/main">
+  <p:cSld>
+    <p:spTree>
+      <p:nvGrpSpPr>
+        <p:cNvPr id="1" name=""/>
+        <p:cNvGrpSpPr/>
+        <p:nvPr/>
+      </p:nvGrpSpPr>
+      <p:grpSpPr>
+        <a:xfrm>
+          <a:off x="0" y="0"/>
+          <a:ext cx="0" cy="0"/>
+          <a:chOff x="0" y="0"/>
+          <a:chExt cx="0" cy="0"/>
+        </a:xfrm>
+      </p:grpSpPr>
+      <p:sp>
+        <p:nvSpPr>
           <p:cNvPr id="2" name="Titolo 1">
             <a:extLst>
               <a:ext uri="{FF2B5EF4-FFF2-40B4-BE49-F238E27FC236}">
@@ -6595,7 +6978,7 @@
 </p:sld>
 </file>
 
-<file path=ppt/slides/slide15.xml><?xml version="1.0" encoding="utf-8"?>
+<file path=ppt/slides/slide17.xml><?xml version="1.0" encoding="utf-8"?>
 <p:sld xmlns:a="http://schemas.openxmlformats.org/drawingml/2006/main" xmlns:r="http://schemas.openxmlformats.org/officeDocument/2006/relationships" xmlns:p="http://schemas.openxmlformats.org/presentationml/2006/main">
   <p:cSld>
     <p:spTree>
@@ -7307,7 +7690,7 @@
 </p:sld>
 </file>
 
-<file path=ppt/slides/slide16.xml><?xml version="1.0" encoding="utf-8"?>
+<file path=ppt/slides/slide18.xml><?xml version="1.0" encoding="utf-8"?>
 <p:sld xmlns:a="http://schemas.openxmlformats.org/drawingml/2006/main" xmlns:r="http://schemas.openxmlformats.org/officeDocument/2006/relationships" xmlns:p="http://schemas.openxmlformats.org/presentationml/2006/main" showMasterPhAnim="0">
   <p:cSld>
     <p:spTree>
@@ -7420,7 +7803,7 @@
 </p:sld>
 </file>
 
-<file path=ppt/slides/slide17.xml><?xml version="1.0" encoding="utf-8"?>
+<file path=ppt/slides/slide19.xml><?xml version="1.0" encoding="utf-8"?>
 <p:sld xmlns:a="http://schemas.openxmlformats.org/drawingml/2006/main" xmlns:r="http://schemas.openxmlformats.org/officeDocument/2006/relationships" xmlns:p="http://schemas.openxmlformats.org/presentationml/2006/main" showMasterPhAnim="0">
   <p:cSld>
     <p:spTree>
@@ -8019,7 +8402,316 @@
 </p:sld>
 </file>
 
-<file path=ppt/slides/slide18.xml><?xml version="1.0" encoding="utf-8"?>
+<file path=ppt/slides/slide2.xml><?xml version="1.0" encoding="utf-8"?>
+<p:sld xmlns:a="http://schemas.openxmlformats.org/drawingml/2006/main" xmlns:r="http://schemas.openxmlformats.org/officeDocument/2006/relationships" xmlns:p="http://schemas.openxmlformats.org/presentationml/2006/main" showMasterPhAnim="0">
+  <p:cSld>
+    <p:spTree>
+      <p:nvGrpSpPr>
+        <p:cNvPr id="1" name=""/>
+        <p:cNvGrpSpPr/>
+        <p:nvPr/>
+      </p:nvGrpSpPr>
+      <p:grpSpPr bwMode="auto">
+        <a:xfrm>
+          <a:off x="0" y="0"/>
+          <a:ext cx="0" cy="0"/>
+          <a:chOff x="0" y="0"/>
+          <a:chExt cx="0" cy="0"/>
+        </a:xfrm>
+      </p:grpSpPr>
+      <p:sp>
+        <p:nvSpPr>
+          <p:cNvPr id="594542285" name="Titolo 1"/>
+          <p:cNvSpPr>
+            <a:spLocks noGrp="1"/>
+          </p:cNvSpPr>
+          <p:nvPr>
+            <p:ph type="title"/>
+          </p:nvPr>
+        </p:nvSpPr>
+        <p:spPr bwMode="auto">
+          <a:prstGeom prst="rect">
+            <a:avLst/>
+          </a:prstGeom>
+          <a:ln w="12699">
+            <a:noFill/>
+            <a:prstDash val="solid"/>
+          </a:ln>
+        </p:spPr>
+        <p:txBody>
+          <a:bodyPr/>
+          <a:lstStyle/>
+          <a:p>
+            <a:pPr>
+              <a:defRPr/>
+            </a:pPr>
+            <a:r>
+              <a:rPr lang="en" b="1" dirty="0">
+                <a:ln w="6349">
+                  <a:noFill/>
+                  <a:prstDash val="solid"/>
+                </a:ln>
+                <a:solidFill>
+                  <a:srgbClr val="0070C0"/>
+                </a:solidFill>
+                <a:latin typeface="Noto Sans"/>
+                <a:ea typeface="Noto Sans"/>
+                <a:cs typeface="Noto Sans"/>
+              </a:rPr>
+              <a:t>Indice dei contenuti</a:t>
+            </a:r>
+            <a:endParaRPr dirty="0"/>
+          </a:p>
+        </p:txBody>
+      </p:sp>
+      <p:sp>
+        <p:nvSpPr>
+          <p:cNvPr id="324859497" name="Segnaposto contenuto 2"/>
+          <p:cNvSpPr>
+            <a:spLocks noGrp="1"/>
+          </p:cNvSpPr>
+          <p:nvPr>
+            <p:ph idx="1"/>
+          </p:nvPr>
+        </p:nvSpPr>
+        <p:spPr bwMode="auto"/>
+        <p:txBody>
+          <a:bodyPr vertOverflow="overflow" horzOverflow="overflow" vert="horz" wrap="square" lIns="91440" tIns="45720" rIns="91440" bIns="45720" numCol="1" spcCol="0" rtlCol="0" fromWordArt="0" anchor="t" anchorCtr="0" forceAA="0" compatLnSpc="0">
+            <a:normAutofit lnSpcReduction="13000"/>
+          </a:bodyPr>
+          <a:lstStyle/>
+          <a:p>
+            <a:pPr marL="394023" indent="-394023">
+              <a:buFont typeface="Arial"/>
+              <a:buAutoNum type="alphaUcPeriod"/>
+              <a:defRPr/>
+            </a:pPr>
+            <a:r>
+              <a:rPr lang="en" sz="1800" dirty="0">
+                <a:latin typeface="DejaVu Sans Condensed"/>
+                <a:ea typeface="DejaVu Sans Condensed"/>
+                <a:cs typeface="DejaVu Sans Condensed"/>
+              </a:rPr>
+              <a:t>Separazione modello-vista			</a:t>
+            </a:r>
+            <a:r>
+              <a:rPr lang="en-GB" sz="1800" dirty="0">
+                <a:latin typeface="DejaVu Sans Condensed"/>
+                <a:ea typeface="DejaVu Sans Condensed"/>
+                <a:cs typeface="DejaVu Sans Condensed"/>
+              </a:rPr>
+              <a:t>n slide</a:t>
+            </a:r>
+            <a:endParaRPr sz="1800" dirty="0">
+              <a:latin typeface="DejaVu Sans Condensed"/>
+              <a:cs typeface="DejaVu Sans Condensed"/>
+            </a:endParaRPr>
+          </a:p>
+          <a:p>
+            <a:pPr marL="394023" indent="-394023">
+              <a:buFont typeface="Arial"/>
+              <a:buAutoNum type="alphaUcPeriod"/>
+              <a:defRPr/>
+            </a:pPr>
+            <a:r>
+              <a:rPr lang="en" sz="1800" dirty="0">
+                <a:latin typeface="DejaVu Sans Condensed"/>
+                <a:ea typeface="DejaVu Sans Condensed"/>
+                <a:cs typeface="DejaVu Sans Condensed"/>
+              </a:rPr>
+              <a:t>Esempi di pattern GRASP		</a:t>
+            </a:r>
+            <a:endParaRPr sz="1800" dirty="0">
+              <a:latin typeface="DejaVu Sans Condensed"/>
+              <a:cs typeface="DejaVu Sans Condensed"/>
+            </a:endParaRPr>
+          </a:p>
+          <a:p>
+            <a:pPr marL="794073" lvl="1" indent="-394023">
+              <a:buFont typeface="Arial"/>
+              <a:buAutoNum type="alphaUcPeriod"/>
+              <a:defRPr/>
+            </a:pPr>
+            <a:r>
+              <a:rPr lang="en" sz="1800" dirty="0">
+                <a:latin typeface="DejaVu Sans Condensed"/>
+                <a:ea typeface="DejaVu Sans Condensed"/>
+                <a:cs typeface="DejaVu Sans Condensed"/>
+              </a:rPr>
+              <a:t>GRASP 1 – Information Expert		n slide</a:t>
+            </a:r>
+            <a:endParaRPr sz="1800" dirty="0">
+              <a:latin typeface="DejaVu Sans Condensed"/>
+              <a:cs typeface="DejaVu Sans Condensed"/>
+            </a:endParaRPr>
+          </a:p>
+          <a:p>
+            <a:pPr marL="794073" lvl="1" indent="-394023">
+              <a:buFont typeface="Arial"/>
+              <a:buAutoNum type="alphaUcPeriod"/>
+              <a:defRPr/>
+            </a:pPr>
+            <a:r>
+              <a:rPr lang="en" sz="1800" dirty="0">
+                <a:latin typeface="DejaVu Sans Condensed"/>
+                <a:ea typeface="DejaVu Sans Condensed"/>
+                <a:cs typeface="DejaVu Sans Condensed"/>
+              </a:rPr>
+              <a:t>GRASP 2 – Controller				n slide</a:t>
+            </a:r>
+            <a:endParaRPr sz="1800" dirty="0">
+              <a:latin typeface="DejaVu Sans Condensed"/>
+              <a:cs typeface="DejaVu Sans Condensed"/>
+            </a:endParaRPr>
+          </a:p>
+          <a:p>
+            <a:pPr marL="394023" lvl="0" indent="-394023">
+              <a:buFont typeface="Arial"/>
+              <a:buAutoNum type="alphaUcPeriod"/>
+              <a:defRPr/>
+            </a:pPr>
+            <a:r>
+              <a:rPr lang="en" sz="1800" dirty="0">
+                <a:latin typeface="DejaVu Sans Condensed"/>
+                <a:ea typeface="DejaVu Sans Condensed"/>
+                <a:cs typeface="DejaVu Sans Condensed"/>
+              </a:rPr>
+              <a:t>Esempi di pattern SOLID			</a:t>
+            </a:r>
+            <a:endParaRPr sz="1800" dirty="0">
+              <a:latin typeface="DejaVu Sans Condensed"/>
+              <a:cs typeface="DejaVu Sans Condensed"/>
+            </a:endParaRPr>
+          </a:p>
+          <a:p>
+            <a:pPr marL="794073" lvl="1" indent="-394023">
+              <a:buFont typeface="Arial"/>
+              <a:buAutoNum type="alphaUcPeriod"/>
+              <a:defRPr/>
+            </a:pPr>
+            <a:r>
+              <a:rPr lang="en" sz="1800" dirty="0">
+                <a:latin typeface="DejaVu Sans Condensed"/>
+                <a:ea typeface="DejaVu Sans Condensed"/>
+                <a:cs typeface="DejaVu Sans Condensed"/>
+              </a:rPr>
+              <a:t>SOLID 1 – Dependency Inversion 		n slide</a:t>
+            </a:r>
+            <a:endParaRPr sz="1800" dirty="0">
+              <a:latin typeface="DejaVu Sans Condensed"/>
+              <a:cs typeface="DejaVu Sans Condensed"/>
+            </a:endParaRPr>
+          </a:p>
+          <a:p>
+            <a:pPr marL="794073" lvl="1" indent="-394023">
+              <a:buFont typeface="Arial"/>
+              <a:buAutoNum type="alphaUcPeriod"/>
+              <a:defRPr/>
+            </a:pPr>
+            <a:r>
+              <a:rPr lang="en" sz="1800" dirty="0">
+                <a:latin typeface="DejaVu Sans Condensed"/>
+                <a:ea typeface="DejaVu Sans Condensed"/>
+                <a:cs typeface="DejaVu Sans Condensed"/>
+              </a:rPr>
+              <a:t>SOLID 2 – Interface Segregation		n slide</a:t>
+            </a:r>
+          </a:p>
+          <a:p>
+            <a:pPr marL="336873" indent="-394023">
+              <a:buFont typeface="Arial"/>
+              <a:buAutoNum type="alphaUcPeriod"/>
+              <a:defRPr/>
+            </a:pPr>
+            <a:r>
+              <a:rPr lang="en" sz="1800" dirty="0">
+                <a:latin typeface="DejaVu Sans Condensed"/>
+                <a:cs typeface="DejaVu Sans Condensed"/>
+              </a:rPr>
+              <a:t>Esempi di pattern GoF</a:t>
+            </a:r>
+          </a:p>
+          <a:p>
+            <a:pPr marL="794073" lvl="1" indent="-394023">
+              <a:buFont typeface="Arial"/>
+              <a:buAutoNum type="alphaUcPeriod"/>
+              <a:defRPr/>
+            </a:pPr>
+            <a:r>
+              <a:rPr lang="en" sz="1800" dirty="0">
+                <a:latin typeface="DejaVu Sans Condensed"/>
+                <a:cs typeface="DejaVu Sans Condensed"/>
+              </a:rPr>
+              <a:t>GoF 1 – Strategy				n slide</a:t>
+            </a:r>
+          </a:p>
+          <a:p>
+            <a:pPr marL="794073" lvl="1" indent="-394023">
+              <a:buFont typeface="Arial"/>
+              <a:buAutoNum type="alphaUcPeriod"/>
+              <a:defRPr/>
+            </a:pPr>
+            <a:r>
+              <a:rPr lang="en" sz="1800" dirty="0">
+                <a:latin typeface="DejaVu Sans Condensed"/>
+                <a:cs typeface="DejaVu Sans Condensed"/>
+              </a:rPr>
+              <a:t>GoF 2 – Adapter				n slide</a:t>
+            </a:r>
+            <a:endParaRPr sz="1800" dirty="0">
+              <a:latin typeface="DejaVu Sans Condensed"/>
+              <a:cs typeface="DejaVu Sans Condensed"/>
+            </a:endParaRPr>
+          </a:p>
+          <a:p>
+            <a:pPr marL="394023" lvl="0" indent="-394023">
+              <a:buFont typeface="Arial"/>
+              <a:buAutoNum type="alphaUcPeriod"/>
+              <a:defRPr/>
+            </a:pPr>
+            <a:r>
+              <a:rPr lang="en" sz="1800" dirty="0">
+                <a:latin typeface="DejaVu Sans Condensed"/>
+                <a:ea typeface="DejaVu Sans Condensed"/>
+                <a:cs typeface="DejaVu Sans Condensed"/>
+              </a:rPr>
+              <a:t>Esempi di testing					n slide</a:t>
+            </a:r>
+            <a:endParaRPr sz="1800" dirty="0">
+              <a:latin typeface="DejaVu Sans Condensed"/>
+              <a:cs typeface="DejaVu Sans Condensed"/>
+            </a:endParaRPr>
+          </a:p>
+          <a:p>
+            <a:pPr marL="394023" lvl="0" indent="-394023">
+              <a:buFont typeface="Arial"/>
+              <a:buAutoNum type="alphaUcPeriod"/>
+              <a:defRPr/>
+            </a:pPr>
+            <a:r>
+              <a:rPr lang="en" sz="1800" dirty="0">
+                <a:latin typeface="DejaVu Sans Condensed"/>
+                <a:ea typeface="DejaVu Sans Condensed"/>
+                <a:cs typeface="DejaVu Sans Condensed"/>
+              </a:rPr>
+              <a:t>Esempi di refactoring				n slide</a:t>
+            </a:r>
+            <a:endParaRPr sz="1800" dirty="0">
+              <a:latin typeface="Cantarell"/>
+              <a:cs typeface="Cantarell"/>
+            </a:endParaRPr>
+          </a:p>
+        </p:txBody>
+      </p:sp>
+    </p:spTree>
+  </p:cSld>
+  <p:clrMapOvr>
+    <a:masterClrMapping/>
+  </p:clrMapOvr>
+</p:sld>
+</file>
+
+<file path=ppt/slides/slide20.xml><?xml version="1.0" encoding="utf-8"?>
 <p:sld xmlns:a="http://schemas.openxmlformats.org/drawingml/2006/main" xmlns:r="http://schemas.openxmlformats.org/officeDocument/2006/relationships" xmlns:p="http://schemas.openxmlformats.org/presentationml/2006/main" showMasterPhAnim="0">
   <p:cSld>
     <p:spTree>
@@ -8557,7 +9249,7 @@
 </p:sld>
 </file>
 
-<file path=ppt/slides/slide19.xml><?xml version="1.0" encoding="utf-8"?>
+<file path=ppt/slides/slide21.xml><?xml version="1.0" encoding="utf-8"?>
 <p:sld xmlns:a="http://schemas.openxmlformats.org/drawingml/2006/main" xmlns:r="http://schemas.openxmlformats.org/officeDocument/2006/relationships" xmlns:p="http://schemas.openxmlformats.org/presentationml/2006/main" showMasterPhAnim="0">
   <p:cSld>
     <p:spTree>
@@ -9245,316 +9937,7 @@
 </p:sld>
 </file>
 
-<file path=ppt/slides/slide2.xml><?xml version="1.0" encoding="utf-8"?>
-<p:sld xmlns:a="http://schemas.openxmlformats.org/drawingml/2006/main" xmlns:r="http://schemas.openxmlformats.org/officeDocument/2006/relationships" xmlns:p="http://schemas.openxmlformats.org/presentationml/2006/main" showMasterPhAnim="0">
-  <p:cSld>
-    <p:spTree>
-      <p:nvGrpSpPr>
-        <p:cNvPr id="1" name=""/>
-        <p:cNvGrpSpPr/>
-        <p:nvPr/>
-      </p:nvGrpSpPr>
-      <p:grpSpPr bwMode="auto">
-        <a:xfrm>
-          <a:off x="0" y="0"/>
-          <a:ext cx="0" cy="0"/>
-          <a:chOff x="0" y="0"/>
-          <a:chExt cx="0" cy="0"/>
-        </a:xfrm>
-      </p:grpSpPr>
-      <p:sp>
-        <p:nvSpPr>
-          <p:cNvPr id="594542285" name="Titolo 1"/>
-          <p:cNvSpPr>
-            <a:spLocks noGrp="1"/>
-          </p:cNvSpPr>
-          <p:nvPr>
-            <p:ph type="title"/>
-          </p:nvPr>
-        </p:nvSpPr>
-        <p:spPr bwMode="auto">
-          <a:prstGeom prst="rect">
-            <a:avLst/>
-          </a:prstGeom>
-          <a:ln w="12699">
-            <a:noFill/>
-            <a:prstDash val="solid"/>
-          </a:ln>
-        </p:spPr>
-        <p:txBody>
-          <a:bodyPr/>
-          <a:lstStyle/>
-          <a:p>
-            <a:pPr>
-              <a:defRPr/>
-            </a:pPr>
-            <a:r>
-              <a:rPr lang="en" b="1" dirty="0">
-                <a:ln w="6349">
-                  <a:noFill/>
-                  <a:prstDash val="solid"/>
-                </a:ln>
-                <a:solidFill>
-                  <a:srgbClr val="0070C0"/>
-                </a:solidFill>
-                <a:latin typeface="Noto Sans"/>
-                <a:ea typeface="Noto Sans"/>
-                <a:cs typeface="Noto Sans"/>
-              </a:rPr>
-              <a:t>Indice dei contenuti</a:t>
-            </a:r>
-            <a:endParaRPr dirty="0"/>
-          </a:p>
-        </p:txBody>
-      </p:sp>
-      <p:sp>
-        <p:nvSpPr>
-          <p:cNvPr id="324859497" name="Segnaposto contenuto 2"/>
-          <p:cNvSpPr>
-            <a:spLocks noGrp="1"/>
-          </p:cNvSpPr>
-          <p:nvPr>
-            <p:ph idx="1"/>
-          </p:nvPr>
-        </p:nvSpPr>
-        <p:spPr bwMode="auto"/>
-        <p:txBody>
-          <a:bodyPr vertOverflow="overflow" horzOverflow="overflow" vert="horz" wrap="square" lIns="91440" tIns="45720" rIns="91440" bIns="45720" numCol="1" spcCol="0" rtlCol="0" fromWordArt="0" anchor="t" anchorCtr="0" forceAA="0" compatLnSpc="0">
-            <a:normAutofit lnSpcReduction="13000"/>
-          </a:bodyPr>
-          <a:lstStyle/>
-          <a:p>
-            <a:pPr marL="394023" indent="-394023">
-              <a:buFont typeface="Arial"/>
-              <a:buAutoNum type="alphaUcPeriod"/>
-              <a:defRPr/>
-            </a:pPr>
-            <a:r>
-              <a:rPr lang="en" sz="1800" dirty="0">
-                <a:latin typeface="DejaVu Sans Condensed"/>
-                <a:ea typeface="DejaVu Sans Condensed"/>
-                <a:cs typeface="DejaVu Sans Condensed"/>
-              </a:rPr>
-              <a:t>Separazione modello-vista			</a:t>
-            </a:r>
-            <a:r>
-              <a:rPr lang="en-GB" sz="1800" dirty="0">
-                <a:latin typeface="DejaVu Sans Condensed"/>
-                <a:ea typeface="DejaVu Sans Condensed"/>
-                <a:cs typeface="DejaVu Sans Condensed"/>
-              </a:rPr>
-              <a:t>n slide</a:t>
-            </a:r>
-            <a:endParaRPr sz="1800" dirty="0">
-              <a:latin typeface="DejaVu Sans Condensed"/>
-              <a:cs typeface="DejaVu Sans Condensed"/>
-            </a:endParaRPr>
-          </a:p>
-          <a:p>
-            <a:pPr marL="394023" indent="-394023">
-              <a:buFont typeface="Arial"/>
-              <a:buAutoNum type="alphaUcPeriod"/>
-              <a:defRPr/>
-            </a:pPr>
-            <a:r>
-              <a:rPr lang="en" sz="1800" dirty="0">
-                <a:latin typeface="DejaVu Sans Condensed"/>
-                <a:ea typeface="DejaVu Sans Condensed"/>
-                <a:cs typeface="DejaVu Sans Condensed"/>
-              </a:rPr>
-              <a:t>Esempi di pattern GRASP		</a:t>
-            </a:r>
-            <a:endParaRPr sz="1800" dirty="0">
-              <a:latin typeface="DejaVu Sans Condensed"/>
-              <a:cs typeface="DejaVu Sans Condensed"/>
-            </a:endParaRPr>
-          </a:p>
-          <a:p>
-            <a:pPr marL="794073" lvl="1" indent="-394023">
-              <a:buFont typeface="Arial"/>
-              <a:buAutoNum type="alphaUcPeriod"/>
-              <a:defRPr/>
-            </a:pPr>
-            <a:r>
-              <a:rPr lang="en" sz="1800" dirty="0">
-                <a:latin typeface="DejaVu Sans Condensed"/>
-                <a:ea typeface="DejaVu Sans Condensed"/>
-                <a:cs typeface="DejaVu Sans Condensed"/>
-              </a:rPr>
-              <a:t>GRASP 1 – Information Expert		n slide</a:t>
-            </a:r>
-            <a:endParaRPr sz="1800" dirty="0">
-              <a:latin typeface="DejaVu Sans Condensed"/>
-              <a:cs typeface="DejaVu Sans Condensed"/>
-            </a:endParaRPr>
-          </a:p>
-          <a:p>
-            <a:pPr marL="794073" lvl="1" indent="-394023">
-              <a:buFont typeface="Arial"/>
-              <a:buAutoNum type="alphaUcPeriod"/>
-              <a:defRPr/>
-            </a:pPr>
-            <a:r>
-              <a:rPr lang="en" sz="1800" dirty="0">
-                <a:latin typeface="DejaVu Sans Condensed"/>
-                <a:ea typeface="DejaVu Sans Condensed"/>
-                <a:cs typeface="DejaVu Sans Condensed"/>
-              </a:rPr>
-              <a:t>GRASP 2 – Controller				n slide</a:t>
-            </a:r>
-            <a:endParaRPr sz="1800" dirty="0">
-              <a:latin typeface="DejaVu Sans Condensed"/>
-              <a:cs typeface="DejaVu Sans Condensed"/>
-            </a:endParaRPr>
-          </a:p>
-          <a:p>
-            <a:pPr marL="394023" lvl="0" indent="-394023">
-              <a:buFont typeface="Arial"/>
-              <a:buAutoNum type="alphaUcPeriod"/>
-              <a:defRPr/>
-            </a:pPr>
-            <a:r>
-              <a:rPr lang="en" sz="1800" dirty="0">
-                <a:latin typeface="DejaVu Sans Condensed"/>
-                <a:ea typeface="DejaVu Sans Condensed"/>
-                <a:cs typeface="DejaVu Sans Condensed"/>
-              </a:rPr>
-              <a:t>Esempi di pattern SOLID			</a:t>
-            </a:r>
-            <a:endParaRPr sz="1800" dirty="0">
-              <a:latin typeface="DejaVu Sans Condensed"/>
-              <a:cs typeface="DejaVu Sans Condensed"/>
-            </a:endParaRPr>
-          </a:p>
-          <a:p>
-            <a:pPr marL="794073" lvl="1" indent="-394023">
-              <a:buFont typeface="Arial"/>
-              <a:buAutoNum type="alphaUcPeriod"/>
-              <a:defRPr/>
-            </a:pPr>
-            <a:r>
-              <a:rPr lang="en" sz="1800" dirty="0">
-                <a:latin typeface="DejaVu Sans Condensed"/>
-                <a:ea typeface="DejaVu Sans Condensed"/>
-                <a:cs typeface="DejaVu Sans Condensed"/>
-              </a:rPr>
-              <a:t>SOLID 1 – Dependency Inversion 		n slide</a:t>
-            </a:r>
-            <a:endParaRPr sz="1800" dirty="0">
-              <a:latin typeface="DejaVu Sans Condensed"/>
-              <a:cs typeface="DejaVu Sans Condensed"/>
-            </a:endParaRPr>
-          </a:p>
-          <a:p>
-            <a:pPr marL="794073" lvl="1" indent="-394023">
-              <a:buFont typeface="Arial"/>
-              <a:buAutoNum type="alphaUcPeriod"/>
-              <a:defRPr/>
-            </a:pPr>
-            <a:r>
-              <a:rPr lang="en" sz="1800" dirty="0">
-                <a:latin typeface="DejaVu Sans Condensed"/>
-                <a:ea typeface="DejaVu Sans Condensed"/>
-                <a:cs typeface="DejaVu Sans Condensed"/>
-              </a:rPr>
-              <a:t>SOLID 2 – Interface Segregation		n slide</a:t>
-            </a:r>
-          </a:p>
-          <a:p>
-            <a:pPr marL="336873" indent="-394023">
-              <a:buFont typeface="Arial"/>
-              <a:buAutoNum type="alphaUcPeriod"/>
-              <a:defRPr/>
-            </a:pPr>
-            <a:r>
-              <a:rPr lang="en" sz="1800" dirty="0">
-                <a:latin typeface="DejaVu Sans Condensed"/>
-                <a:cs typeface="DejaVu Sans Condensed"/>
-              </a:rPr>
-              <a:t>Esempi di pattern GoF</a:t>
-            </a:r>
-          </a:p>
-          <a:p>
-            <a:pPr marL="794073" lvl="1" indent="-394023">
-              <a:buFont typeface="Arial"/>
-              <a:buAutoNum type="alphaUcPeriod"/>
-              <a:defRPr/>
-            </a:pPr>
-            <a:r>
-              <a:rPr lang="en" sz="1800" dirty="0">
-                <a:latin typeface="DejaVu Sans Condensed"/>
-                <a:cs typeface="DejaVu Sans Condensed"/>
-              </a:rPr>
-              <a:t>GoF 1 – Strategy				n slide</a:t>
-            </a:r>
-          </a:p>
-          <a:p>
-            <a:pPr marL="794073" lvl="1" indent="-394023">
-              <a:buFont typeface="Arial"/>
-              <a:buAutoNum type="alphaUcPeriod"/>
-              <a:defRPr/>
-            </a:pPr>
-            <a:r>
-              <a:rPr lang="en" sz="1800" dirty="0">
-                <a:latin typeface="DejaVu Sans Condensed"/>
-                <a:cs typeface="DejaVu Sans Condensed"/>
-              </a:rPr>
-              <a:t>GoF 2 – Adapter				n slide</a:t>
-            </a:r>
-            <a:endParaRPr sz="1800" dirty="0">
-              <a:latin typeface="DejaVu Sans Condensed"/>
-              <a:cs typeface="DejaVu Sans Condensed"/>
-            </a:endParaRPr>
-          </a:p>
-          <a:p>
-            <a:pPr marL="394023" lvl="0" indent="-394023">
-              <a:buFont typeface="Arial"/>
-              <a:buAutoNum type="alphaUcPeriod"/>
-              <a:defRPr/>
-            </a:pPr>
-            <a:r>
-              <a:rPr lang="en" sz="1800" dirty="0">
-                <a:latin typeface="DejaVu Sans Condensed"/>
-                <a:ea typeface="DejaVu Sans Condensed"/>
-                <a:cs typeface="DejaVu Sans Condensed"/>
-              </a:rPr>
-              <a:t>Esempi di testing					n slide</a:t>
-            </a:r>
-            <a:endParaRPr sz="1800" dirty="0">
-              <a:latin typeface="DejaVu Sans Condensed"/>
-              <a:cs typeface="DejaVu Sans Condensed"/>
-            </a:endParaRPr>
-          </a:p>
-          <a:p>
-            <a:pPr marL="394023" lvl="0" indent="-394023">
-              <a:buFont typeface="Arial"/>
-              <a:buAutoNum type="alphaUcPeriod"/>
-              <a:defRPr/>
-            </a:pPr>
-            <a:r>
-              <a:rPr lang="en" sz="1800" dirty="0">
-                <a:latin typeface="DejaVu Sans Condensed"/>
-                <a:ea typeface="DejaVu Sans Condensed"/>
-                <a:cs typeface="DejaVu Sans Condensed"/>
-              </a:rPr>
-              <a:t>Esempi di refactoring				n slide</a:t>
-            </a:r>
-            <a:endParaRPr sz="1800" dirty="0">
-              <a:latin typeface="Cantarell"/>
-              <a:cs typeface="Cantarell"/>
-            </a:endParaRPr>
-          </a:p>
-        </p:txBody>
-      </p:sp>
-    </p:spTree>
-  </p:cSld>
-  <p:clrMapOvr>
-    <a:masterClrMapping/>
-  </p:clrMapOvr>
-</p:sld>
-</file>
-
-<file path=ppt/slides/slide20.xml><?xml version="1.0" encoding="utf-8"?>
+<file path=ppt/slides/slide22.xml><?xml version="1.0" encoding="utf-8"?>
 <p:sld xmlns:a="http://schemas.openxmlformats.org/drawingml/2006/main" xmlns:r="http://schemas.openxmlformats.org/officeDocument/2006/relationships" xmlns:p="http://schemas.openxmlformats.org/presentationml/2006/main" showMasterPhAnim="0">
   <p:cSld>
     <p:spTree>
@@ -10426,7 +10809,7 @@
 </p:sld>
 </file>
 
-<file path=ppt/slides/slide21.xml><?xml version="1.0" encoding="utf-8"?>
+<file path=ppt/slides/slide23.xml><?xml version="1.0" encoding="utf-8"?>
 <p:sld xmlns:a="http://schemas.openxmlformats.org/drawingml/2006/main" xmlns:r="http://schemas.openxmlformats.org/officeDocument/2006/relationships" xmlns:p="http://schemas.openxmlformats.org/presentationml/2006/main" showMasterPhAnim="0">
   <p:cSld>
     <p:spTree>
@@ -10637,933 +11020,6 @@
 </p:sld>
 </file>
 
-<file path=ppt/slides/slide22.xml><?xml version="1.0" encoding="utf-8"?>
-<p:sld xmlns:a="http://schemas.openxmlformats.org/drawingml/2006/main" xmlns:r="http://schemas.openxmlformats.org/officeDocument/2006/relationships" xmlns:p="http://schemas.openxmlformats.org/presentationml/2006/main" showMasterPhAnim="0">
-  <p:cSld>
-    <p:spTree>
-      <p:nvGrpSpPr>
-        <p:cNvPr id="1" name=""/>
-        <p:cNvGrpSpPr/>
-        <p:nvPr/>
-      </p:nvGrpSpPr>
-      <p:grpSpPr bwMode="auto">
-        <a:xfrm>
-          <a:off x="0" y="0"/>
-          <a:ext cx="0" cy="0"/>
-          <a:chOff x="0" y="0"/>
-          <a:chExt cx="0" cy="0"/>
-        </a:xfrm>
-      </p:grpSpPr>
-      <p:sp>
-        <p:nvSpPr>
-          <p:cNvPr id="59495650" name="Titolo 1"/>
-          <p:cNvSpPr>
-            <a:spLocks noGrp="1"/>
-          </p:cNvSpPr>
-          <p:nvPr>
-            <p:ph type="title"/>
-          </p:nvPr>
-        </p:nvSpPr>
-        <p:spPr bwMode="auto">
-          <a:xfrm>
-            <a:off x="838198" y="365123"/>
-            <a:ext cx="5555216" cy="1325561"/>
-          </a:xfrm>
-        </p:spPr>
-        <p:txBody>
-          <a:bodyPr/>
-          <a:lstStyle/>
-          <a:p>
-            <a:pPr>
-              <a:defRPr/>
-            </a:pPr>
-            <a:r>
-              <a:rPr lang="en" b="1">
-                <a:solidFill>
-                  <a:srgbClr val="0070C0"/>
-                </a:solidFill>
-                <a:latin typeface="Noto Sans"/>
-                <a:ea typeface="Noto Sans"/>
-                <a:cs typeface="Noto Sans"/>
-              </a:rPr>
-              <a:t>Refactoring</a:t>
-            </a:r>
-            <a:endParaRPr/>
-          </a:p>
-        </p:txBody>
-      </p:sp>
-      <p:sp>
-        <p:nvSpPr>
-          <p:cNvPr id="104998061" name="Segnaposto contenuto 2"/>
-          <p:cNvSpPr>
-            <a:spLocks noGrp="1"/>
-          </p:cNvSpPr>
-          <p:nvPr>
-            <p:ph idx="1"/>
-          </p:nvPr>
-        </p:nvSpPr>
-        <p:spPr bwMode="auto"/>
-        <p:txBody>
-          <a:bodyPr/>
-          <a:lstStyle/>
-          <a:p>
-            <a:pPr marL="0" indent="0">
-              <a:buFont typeface="Arial"/>
-              <a:buNone/>
-              <a:defRPr/>
-            </a:pPr>
-            <a:r>
-              <a:rPr lang="en"/>
-              <a:t>Il refactoring della classe VisitPlanService si é reso necessario perché:</a:t>
-            </a:r>
-          </a:p>
-          <a:p>
-            <a:pPr>
-              <a:defRPr/>
-            </a:pPr>
-            <a:r>
-              <a:rPr lang="en"/>
-              <a:t>contiene l’algoritmo fondamentale per il funzionamento del programma</a:t>
-            </a:r>
-          </a:p>
-          <a:p>
-            <a:pPr>
-              <a:defRPr/>
-            </a:pPr>
-            <a:r>
-              <a:rPr lang="en"/>
-              <a:t>é probabile che possa subire modifiche/aggiunte in futuro</a:t>
-            </a:r>
-          </a:p>
-          <a:p>
-            <a:pPr>
-              <a:defRPr/>
-            </a:pPr>
-            <a:r>
-              <a:rPr lang="en"/>
-              <a:t>combina molte informazioni diverse: visite, tipi di visite, date non disponibili, volontari e relative disponibilitá</a:t>
-            </a:r>
-          </a:p>
-          <a:p>
-            <a:pPr marL="0" indent="0">
-              <a:buFont typeface="Arial"/>
-              <a:buNone/>
-              <a:defRPr/>
-            </a:pPr>
-            <a:r>
-              <a:rPr lang="en"/>
-              <a:t>Di seguito i pattern di refactoring applicati</a:t>
-            </a:r>
-            <a:endParaRPr/>
-          </a:p>
-        </p:txBody>
-      </p:sp>
-      <p:sp>
-        <p:nvSpPr>
-          <p:cNvPr id="27321058" name="CasellaDiTesto 27321057"/>
-          <p:cNvSpPr txBox="1"/>
-          <p:nvPr/>
-        </p:nvSpPr>
-        <p:spPr bwMode="auto">
-          <a:xfrm>
-            <a:off x="5753406" y="844844"/>
-            <a:ext cx="5851705" cy="518519"/>
-          </a:xfrm>
-          <a:prstGeom prst="rect">
-            <a:avLst/>
-          </a:prstGeom>
-          <a:noFill/>
-        </p:spPr>
-        <p:txBody>
-          <a:bodyPr vertOverflow="overflow" horzOverflow="overflow" vert="horz" wrap="square" lIns="91440" tIns="45720" rIns="91440" bIns="45720" numCol="1" spcCol="0" rtlCol="0" fromWordArt="0" anchor="t" anchorCtr="0" forceAA="0" compatLnSpc="0">
-            <a:spAutoFit/>
-          </a:bodyPr>
-          <a:lstStyle/>
-          <a:p>
-            <a:pPr algn="ctr">
-              <a:defRPr/>
-            </a:pPr>
-            <a:r>
-              <a:rPr lang="en" sz="2800" b="1">
-                <a:solidFill>
-                  <a:srgbClr val="0070C0"/>
-                </a:solidFill>
-                <a:latin typeface="DejaVu Sans Condensed"/>
-                <a:ea typeface="DejaVu Sans Condensed"/>
-                <a:cs typeface="DejaVu Sans Condensed"/>
-              </a:rPr>
-              <a:t>Caso di VisitPlanService</a:t>
-            </a:r>
-            <a:endParaRPr b="1">
-              <a:solidFill>
-                <a:srgbClr val="0070C0"/>
-              </a:solidFill>
-            </a:endParaRPr>
-          </a:p>
-        </p:txBody>
-      </p:sp>
-    </p:spTree>
-  </p:cSld>
-  <p:clrMapOvr>
-    <a:masterClrMapping/>
-  </p:clrMapOvr>
-</p:sld>
-</file>
-
-<file path=ppt/slides/slide23.xml><?xml version="1.0" encoding="utf-8"?>
-<p:sld xmlns:a="http://schemas.openxmlformats.org/drawingml/2006/main" xmlns:r="http://schemas.openxmlformats.org/officeDocument/2006/relationships" xmlns:p="http://schemas.openxmlformats.org/presentationml/2006/main" showMasterPhAnim="0">
-  <p:cSld>
-    <p:spTree>
-      <p:nvGrpSpPr>
-        <p:cNvPr id="1" name=""/>
-        <p:cNvGrpSpPr/>
-        <p:nvPr/>
-      </p:nvGrpSpPr>
-      <p:grpSpPr bwMode="auto">
-        <a:xfrm>
-          <a:off x="0" y="0"/>
-          <a:ext cx="0" cy="0"/>
-          <a:chOff x="0" y="0"/>
-          <a:chExt cx="0" cy="0"/>
-        </a:xfrm>
-      </p:grpSpPr>
-      <p:sp>
-        <p:nvSpPr>
-          <p:cNvPr id="149416002" name="Titolo 1"/>
-          <p:cNvSpPr>
-            <a:spLocks noGrp="1"/>
-          </p:cNvSpPr>
-          <p:nvPr>
-            <p:ph type="title"/>
-          </p:nvPr>
-        </p:nvSpPr>
-        <p:spPr bwMode="auto">
-          <a:xfrm>
-            <a:off x="839459" y="37802"/>
-            <a:ext cx="10515600" cy="1325562"/>
-          </a:xfrm>
-        </p:spPr>
-        <p:txBody>
-          <a:bodyPr/>
-          <a:lstStyle/>
-          <a:p>
-            <a:pPr>
-              <a:defRPr/>
-            </a:pPr>
-            <a:r>
-              <a:rPr lang="en" b="1">
-                <a:solidFill>
-                  <a:srgbClr val="0070C0"/>
-                </a:solidFill>
-                <a:latin typeface="Noto Sans"/>
-                <a:ea typeface="Noto Sans"/>
-                <a:cs typeface="Noto Sans"/>
-              </a:rPr>
-              <a:t>Refactoring</a:t>
-            </a:r>
-            <a:endParaRPr b="1">
-              <a:solidFill>
-                <a:srgbClr val="0070C0"/>
-              </a:solidFill>
-              <a:latin typeface="Noto Sans"/>
-              <a:cs typeface="Noto Sans"/>
-            </a:endParaRPr>
-          </a:p>
-        </p:txBody>
-      </p:sp>
-      <p:sp>
-        <p:nvSpPr>
-          <p:cNvPr id="1040471417" name="CasellaDiTesto 1040471416"/>
-          <p:cNvSpPr txBox="1"/>
-          <p:nvPr/>
-        </p:nvSpPr>
-        <p:spPr bwMode="auto">
-          <a:xfrm>
-            <a:off x="4915206" y="441324"/>
-            <a:ext cx="5860344" cy="518519"/>
-          </a:xfrm>
-          <a:prstGeom prst="rect">
-            <a:avLst/>
-          </a:prstGeom>
-          <a:noFill/>
-        </p:spPr>
-        <p:txBody>
-          <a:bodyPr vertOverflow="overflow" horzOverflow="overflow" vert="horz" wrap="square" lIns="91440" tIns="45720" rIns="91440" bIns="45720" numCol="1" spcCol="0" rtlCol="0" fromWordArt="0" anchor="t" anchorCtr="0" forceAA="0" compatLnSpc="0">
-            <a:spAutoFit/>
-          </a:bodyPr>
-          <a:lstStyle/>
-          <a:p>
-            <a:pPr algn="ctr">
-              <a:defRPr/>
-            </a:pPr>
-            <a:r>
-              <a:rPr lang="en" sz="2800" b="1">
-                <a:solidFill>
-                  <a:srgbClr val="0070C0"/>
-                </a:solidFill>
-                <a:latin typeface="DejaVu Sans Condensed"/>
-                <a:ea typeface="DejaVu Sans Condensed"/>
-                <a:cs typeface="DejaVu Sans Condensed"/>
-              </a:rPr>
-              <a:t>Extract Method - 1</a:t>
-            </a:r>
-            <a:endParaRPr b="1">
-              <a:solidFill>
-                <a:srgbClr val="0070C0"/>
-              </a:solidFill>
-            </a:endParaRPr>
-          </a:p>
-        </p:txBody>
-      </p:sp>
-      <p:sp>
-        <p:nvSpPr>
-          <p:cNvPr id="1689386774" name="CasellaDiTesto 1689386773"/>
-          <p:cNvSpPr txBox="1"/>
-          <p:nvPr/>
-        </p:nvSpPr>
-        <p:spPr bwMode="auto">
-          <a:xfrm>
-            <a:off x="457916" y="1160462"/>
-            <a:ext cx="11276167" cy="2524456"/>
-          </a:xfrm>
-          <a:prstGeom prst="roundRect">
-            <a:avLst>
-              <a:gd name="adj" fmla="val 5796"/>
-            </a:avLst>
-          </a:prstGeom>
-          <a:solidFill>
-            <a:schemeClr val="bg1">
-              <a:alpha val="49999"/>
-            </a:schemeClr>
-          </a:solidFill>
-          <a:ln w="12699">
-            <a:solidFill>
-              <a:schemeClr val="tx1"/>
-            </a:solidFill>
-            <a:prstDash val="solid"/>
-          </a:ln>
-        </p:spPr>
-        <p:txBody>
-          <a:bodyPr vertOverflow="overflow" horzOverflow="overflow" vert="horz" wrap="square" lIns="91440" tIns="45720" rIns="91440" bIns="45720" numCol="1" spcCol="0" rtlCol="0" fromWordArt="0" anchor="t" anchorCtr="0" forceAA="0" compatLnSpc="0">
-            <a:spAutoFit/>
-          </a:bodyPr>
-          <a:lstStyle/>
-          <a:p>
-            <a:pPr>
-              <a:defRPr/>
-            </a:pPr>
-            <a:r>
-              <a:rPr lang="it-IT" sz="1400" b="0" i="0" u="none" strike="noStrike" cap="none" spc="0">
-                <a:solidFill>
-                  <a:schemeClr val="tx1"/>
-                </a:solidFill>
-                <a:latin typeface="Liberation Mono"/>
-                <a:ea typeface="Liberation Mono"/>
-                <a:cs typeface="Liberation Mono"/>
-              </a:rPr>
-              <a:t>for (Visit visit : monthVisits) {</a:t>
-            </a:r>
-            <a:endParaRPr sz="1400" b="0" i="0" u="none" strike="noStrike" cap="none" spc="0">
-              <a:solidFill>
-                <a:schemeClr val="tx1"/>
-              </a:solidFill>
-              <a:latin typeface="Liberation Mono"/>
-              <a:cs typeface="Liberation Mono"/>
-            </a:endParaRPr>
-          </a:p>
-          <a:p>
-            <a:pPr>
-              <a:defRPr/>
-            </a:pPr>
-            <a:r>
-              <a:rPr lang="it-IT" sz="1400" b="0" i="0" u="none" strike="noStrike" cap="none" spc="0">
-                <a:solidFill>
-                  <a:schemeClr val="tx1"/>
-                </a:solidFill>
-                <a:latin typeface="Liberation Mono"/>
-                <a:ea typeface="Liberation Mono"/>
-                <a:cs typeface="Liberation Mono"/>
-              </a:rPr>
-              <a:t>            LocalDate day = visit.getDate();</a:t>
-            </a:r>
-            <a:endParaRPr sz="1400" b="0" i="0" u="none" strike="noStrike" cap="none" spc="0">
-              <a:solidFill>
-                <a:schemeClr val="tx1"/>
-              </a:solidFill>
-              <a:latin typeface="Liberation Mono"/>
-              <a:cs typeface="Liberation Mono"/>
-            </a:endParaRPr>
-          </a:p>
-          <a:p>
-            <a:pPr>
-              <a:defRPr/>
-            </a:pPr>
-            <a:r>
-              <a:rPr lang="it-IT" sz="1400" b="0" i="0" u="none" strike="noStrike" cap="none" spc="0">
-                <a:solidFill>
-                  <a:schemeClr val="tx1"/>
-                </a:solidFill>
-                <a:latin typeface="Liberation Mono"/>
-                <a:ea typeface="Liberation Mono"/>
-                <a:cs typeface="Liberation Mono"/>
-              </a:rPr>
-              <a:t>            List&lt;User&gt; availableVolunteers = new ArrayList&lt;&gt;();</a:t>
-            </a:r>
-            <a:endParaRPr sz="1400" b="0" i="0" u="none" strike="noStrike" cap="none" spc="0">
-              <a:solidFill>
-                <a:schemeClr val="tx1"/>
-              </a:solidFill>
-              <a:latin typeface="Liberation Mono"/>
-              <a:cs typeface="Liberation Mono"/>
-            </a:endParaRPr>
-          </a:p>
-          <a:p>
-            <a:pPr>
-              <a:defRPr/>
-            </a:pPr>
-            <a:endParaRPr sz="1400" b="0" i="0" u="none" strike="noStrike" cap="none" spc="0">
-              <a:solidFill>
-                <a:schemeClr val="tx1"/>
-              </a:solidFill>
-              <a:latin typeface="Liberation Mono"/>
-              <a:cs typeface="Liberation Mono"/>
-            </a:endParaRPr>
-          </a:p>
-          <a:p>
-            <a:pPr>
-              <a:defRPr/>
-            </a:pPr>
-            <a:r>
-              <a:rPr lang="it-IT" sz="1400" b="0" i="0" u="none" strike="noStrike" cap="none" spc="0">
-                <a:solidFill>
-                  <a:schemeClr val="tx1"/>
-                </a:solidFill>
-                <a:latin typeface="Liberation Mono"/>
-                <a:ea typeface="Liberation Mono"/>
-                <a:cs typeface="Liberation Mono"/>
-              </a:rPr>
-              <a:t>            // aggiunge alla lista availableVolunteers tutti i volontari che hanno dato</a:t>
-            </a:r>
-            <a:endParaRPr sz="1400" b="0" i="0" u="none" strike="noStrike" cap="none" spc="0">
-              <a:solidFill>
-                <a:schemeClr val="tx1"/>
-              </a:solidFill>
-              <a:latin typeface="Liberation Mono"/>
-              <a:cs typeface="Liberation Mono"/>
-            </a:endParaRPr>
-          </a:p>
-          <a:p>
-            <a:pPr>
-              <a:defRPr/>
-            </a:pPr>
-            <a:r>
-              <a:rPr lang="it-IT" sz="1400" b="0" i="0" u="none" strike="noStrike" cap="none" spc="0">
-                <a:solidFill>
-                  <a:schemeClr val="tx1"/>
-                </a:solidFill>
-                <a:latin typeface="Liberation Mono"/>
-                <a:ea typeface="Liberation Mono"/>
-                <a:cs typeface="Liberation Mono"/>
-              </a:rPr>
-              <a:t>            // disponibilitá per il</a:t>
-            </a:r>
-            <a:endParaRPr sz="1400" b="0" i="0" u="none" strike="noStrike" cap="none" spc="0">
-              <a:solidFill>
-                <a:schemeClr val="tx1"/>
-              </a:solidFill>
-              <a:latin typeface="Liberation Mono"/>
-              <a:cs typeface="Liberation Mono"/>
-            </a:endParaRPr>
-          </a:p>
-          <a:p>
-            <a:pPr>
-              <a:defRPr/>
-            </a:pPr>
-            <a:r>
-              <a:rPr lang="it-IT" sz="1400" b="0" i="0" u="none" strike="noStrike" cap="none" spc="0">
-                <a:solidFill>
-                  <a:schemeClr val="tx1"/>
-                </a:solidFill>
-                <a:latin typeface="Liberation Mono"/>
-                <a:ea typeface="Liberation Mono"/>
-                <a:cs typeface="Liberation Mono"/>
-              </a:rPr>
-              <a:t>            // giorno 'day'</a:t>
-            </a:r>
-            <a:endParaRPr sz="1400" b="0" i="0" u="none" strike="noStrike" cap="none" spc="0">
-              <a:solidFill>
-                <a:schemeClr val="tx1"/>
-              </a:solidFill>
-              <a:latin typeface="Liberation Mono"/>
-              <a:cs typeface="Liberation Mono"/>
-            </a:endParaRPr>
-          </a:p>
-          <a:p>
-            <a:pPr>
-              <a:defRPr/>
-            </a:pPr>
-            <a:r>
-              <a:rPr lang="it-IT" sz="1400" b="0" i="0" u="none" strike="noStrike" cap="none" spc="0">
-                <a:solidFill>
-                  <a:schemeClr val="tx1"/>
-                </a:solidFill>
-                <a:latin typeface="Liberation Mono"/>
-                <a:ea typeface="Liberation Mono"/>
-                <a:cs typeface="Liberation Mono"/>
-              </a:rPr>
-              <a:t>            monthAvailabilities.stream().filter(av -&gt; av.getAvailableDate().equals(day)) //</a:t>
-            </a:r>
-            <a:endParaRPr sz="1400" b="0" i="0" u="none" strike="noStrike" cap="none" spc="0">
-              <a:solidFill>
-                <a:schemeClr val="tx1"/>
-              </a:solidFill>
-              <a:latin typeface="Liberation Mono"/>
-              <a:cs typeface="Liberation Mono"/>
-            </a:endParaRPr>
-          </a:p>
-          <a:p>
-            <a:pPr>
-              <a:defRPr/>
-            </a:pPr>
-            <a:r>
-              <a:rPr lang="it-IT" sz="1400" b="0" i="0" u="none" strike="noStrike" cap="none" spc="0">
-                <a:solidFill>
-                  <a:schemeClr val="tx1"/>
-                </a:solidFill>
-                <a:latin typeface="Liberation Mono"/>
-                <a:ea typeface="Liberation Mono"/>
-                <a:cs typeface="Liberation Mono"/>
-              </a:rPr>
-              <a:t>                    // mappa le disponibilitá VolunteerAvailableDate con gli oggetti USER volontari</a:t>
-            </a:r>
-            <a:endParaRPr sz="1400" b="0" i="0" u="none" strike="noStrike" cap="none" spc="0">
-              <a:solidFill>
-                <a:schemeClr val="tx1"/>
-              </a:solidFill>
-              <a:latin typeface="Liberation Mono"/>
-              <a:cs typeface="Liberation Mono"/>
-            </a:endParaRPr>
-          </a:p>
-          <a:p>
-            <a:pPr>
-              <a:defRPr/>
-            </a:pPr>
-            <a:r>
-              <a:rPr lang="it-IT" sz="1400" b="0" i="0" u="none" strike="noStrike" cap="none" spc="0">
-                <a:solidFill>
-                  <a:schemeClr val="tx1"/>
-                </a:solidFill>
-                <a:latin typeface="Liberation Mono"/>
-                <a:ea typeface="Liberation Mono"/>
-                <a:cs typeface="Liberation Mono"/>
-              </a:rPr>
-              <a:t>                    .map(av -&gt; volunteerById(av.getVolunteerId(), volunteers)) //</a:t>
-            </a:r>
-            <a:endParaRPr sz="1400" b="0" i="0" u="none" strike="noStrike" cap="none" spc="0">
-              <a:solidFill>
-                <a:schemeClr val="tx1"/>
-              </a:solidFill>
-              <a:latin typeface="Liberation Mono"/>
-              <a:cs typeface="Liberation Mono"/>
-            </a:endParaRPr>
-          </a:p>
-          <a:p>
-            <a:pPr>
-              <a:defRPr/>
-            </a:pPr>
-            <a:r>
-              <a:rPr lang="it-IT" sz="1400" b="0" i="0" u="none" strike="noStrike" cap="none" spc="0">
-                <a:solidFill>
-                  <a:schemeClr val="tx1"/>
-                </a:solidFill>
-                <a:latin typeface="Liberation Mono"/>
-                <a:ea typeface="Liberation Mono"/>
-                <a:cs typeface="Liberation Mono"/>
-              </a:rPr>
-              <a:t>                    .forEach(availableVolunteers::add);</a:t>
-            </a:r>
-            <a:endParaRPr/>
-          </a:p>
-        </p:txBody>
-      </p:sp>
-      <p:sp>
-        <p:nvSpPr>
-          <p:cNvPr id="58203512" name="CasellaDiTesto 58203511"/>
-          <p:cNvSpPr txBox="1"/>
-          <p:nvPr/>
-        </p:nvSpPr>
-        <p:spPr bwMode="auto">
-          <a:xfrm>
-            <a:off x="457916" y="3827462"/>
-            <a:ext cx="11278686" cy="2966174"/>
-          </a:xfrm>
-          <a:prstGeom prst="roundRect">
-            <a:avLst>
-              <a:gd name="adj" fmla="val 5796"/>
-            </a:avLst>
-          </a:prstGeom>
-          <a:solidFill>
-            <a:schemeClr val="bg1">
-              <a:alpha val="49999"/>
-            </a:schemeClr>
-          </a:solidFill>
-          <a:ln w="12699">
-            <a:solidFill>
-              <a:schemeClr val="tx1"/>
-            </a:solidFill>
-            <a:prstDash val="solid"/>
-          </a:ln>
-        </p:spPr>
-        <p:txBody>
-          <a:bodyPr vertOverflow="overflow" horzOverflow="overflow" vert="horz" wrap="square" lIns="91440" tIns="45720" rIns="91440" bIns="45720" numCol="1" spcCol="0" rtlCol="0" fromWordArt="0" anchor="t" anchorCtr="0" forceAA="0" compatLnSpc="0">
-            <a:spAutoFit/>
-          </a:bodyPr>
-          <a:lstStyle/>
-          <a:p>
-            <a:pPr>
-              <a:defRPr/>
-            </a:pPr>
-            <a:r>
-              <a:rPr lang="en" sz="1400" b="0" i="0" u="none" strike="noStrike" cap="none" spc="0">
-                <a:solidFill>
-                  <a:schemeClr val="tx1"/>
-                </a:solidFill>
-                <a:latin typeface="Liberation Mono"/>
-                <a:ea typeface="Liberation Mono"/>
-                <a:cs typeface="Liberation Mono"/>
-              </a:rPr>
-              <a:t>for (Visit visit : nextMonthSortedVisits) {</a:t>
-            </a:r>
-            <a:endParaRPr sz="1400" b="0" i="0" u="none" strike="noStrike" cap="none" spc="0">
-              <a:solidFill>
-                <a:schemeClr val="tx1"/>
-              </a:solidFill>
-              <a:latin typeface="Liberation Mono"/>
-              <a:cs typeface="Liberation Mono"/>
-            </a:endParaRPr>
-          </a:p>
-          <a:p>
-            <a:pPr>
-              <a:defRPr/>
-            </a:pPr>
-            <a:r>
-              <a:rPr lang="en" sz="1400" b="0" i="0" u="none" strike="noStrike" cap="none" spc="0">
-                <a:solidFill>
-                  <a:schemeClr val="tx1"/>
-                </a:solidFill>
-                <a:latin typeface="Liberation Mono"/>
-                <a:ea typeface="Liberation Mono"/>
-                <a:cs typeface="Liberation Mono"/>
-              </a:rPr>
-              <a:t>    List&lt;Integer&gt; availableVolunteerIds = </a:t>
-            </a:r>
-            <a:endParaRPr sz="1400" b="0" i="0" u="none" strike="noStrike" cap="none" spc="0">
-              <a:solidFill>
-                <a:schemeClr val="tx1"/>
-              </a:solidFill>
-              <a:latin typeface="Liberation Mono"/>
-              <a:cs typeface="Liberation Mono"/>
-            </a:endParaRPr>
-          </a:p>
-          <a:p>
-            <a:pPr>
-              <a:defRPr/>
-            </a:pPr>
-            <a:r>
-              <a:rPr lang="en" sz="1400" b="0" i="0" u="none" strike="noStrike" cap="none" spc="0">
-                <a:solidFill>
-                  <a:schemeClr val="tx1"/>
-                </a:solidFill>
-                <a:latin typeface="Liberation Mono"/>
-                <a:ea typeface="Liberation Mono"/>
-                <a:cs typeface="Liberation Mono"/>
-              </a:rPr>
-              <a:t>	getAvailableVolunteersForVisitDate(visit, volunteerAvailabilitiesNextMonth);</a:t>
-            </a:r>
-            <a:endParaRPr sz="1400">
-              <a:latin typeface="Liberation Mono"/>
-              <a:cs typeface="Liberation Mono"/>
-            </a:endParaRPr>
-          </a:p>
-          <a:p>
-            <a:pPr>
-              <a:defRPr/>
-            </a:pPr>
-            <a:r>
-              <a:rPr lang="en" sz="1400" b="0" i="0" u="none" strike="noStrike" cap="none" spc="0">
-                <a:solidFill>
-                  <a:schemeClr val="tx1"/>
-                </a:solidFill>
-                <a:latin typeface="Liberation Mono"/>
-                <a:ea typeface="Liberation Mono"/>
-                <a:cs typeface="Liberation Mono"/>
-              </a:rPr>
-              <a:t>...</a:t>
-            </a:r>
-            <a:endParaRPr sz="1400">
-              <a:latin typeface="Liberation Mono"/>
-              <a:cs typeface="Liberation Mono"/>
-            </a:endParaRPr>
-          </a:p>
-          <a:p>
-            <a:pPr>
-              <a:defRPr/>
-            </a:pPr>
-            <a:endParaRPr sz="1400">
-              <a:latin typeface="Liberation Mono"/>
-              <a:cs typeface="Liberation Mono"/>
-            </a:endParaRPr>
-          </a:p>
-          <a:p>
-            <a:pPr>
-              <a:defRPr/>
-            </a:pPr>
-            <a:r>
-              <a:rPr lang="en" sz="1400" b="0" i="0" u="none" strike="noStrike" cap="none" spc="0">
-                <a:solidFill>
-                  <a:schemeClr val="tx1"/>
-                </a:solidFill>
-                <a:latin typeface="Liberation Mono"/>
-                <a:ea typeface="Liberation Mono"/>
-                <a:cs typeface="Liberation Mono"/>
-              </a:rPr>
-              <a:t>private List&lt;Integer&gt; getAvailableVolunteersForVisitDate(Visit visit, List&lt;VolunteerAvailableDate&gt; volunteerAvailabilitiesNextMonth) {</a:t>
-            </a:r>
-            <a:endParaRPr sz="1400" b="0" i="0" u="none" strike="noStrike" cap="none" spc="0">
-              <a:solidFill>
-                <a:schemeClr val="tx1"/>
-              </a:solidFill>
-              <a:latin typeface="Liberation Mono"/>
-              <a:cs typeface="Liberation Mono"/>
-            </a:endParaRPr>
-          </a:p>
-          <a:p>
-            <a:pPr>
-              <a:defRPr/>
-            </a:pPr>
-            <a:r>
-              <a:rPr lang="en" sz="1400" b="0" i="0" u="none" strike="noStrike" cap="none" spc="0">
-                <a:solidFill>
-                  <a:schemeClr val="tx1"/>
-                </a:solidFill>
-                <a:latin typeface="Liberation Mono"/>
-                <a:ea typeface="Liberation Mono"/>
-                <a:cs typeface="Liberation Mono"/>
-              </a:rPr>
-              <a:t>        return volunteerAvailabilitiesNextMonth.stream() //</a:t>
-            </a:r>
-            <a:endParaRPr sz="1400" b="0" i="0" u="none" strike="noStrike" cap="none" spc="0">
-              <a:solidFill>
-                <a:schemeClr val="tx1"/>
-              </a:solidFill>
-              <a:latin typeface="Liberation Mono"/>
-              <a:cs typeface="Liberation Mono"/>
-            </a:endParaRPr>
-          </a:p>
-          <a:p>
-            <a:pPr>
-              <a:defRPr/>
-            </a:pPr>
-            <a:r>
-              <a:rPr lang="en" sz="1400" b="0" i="0" u="none" strike="noStrike" cap="none" spc="0">
-                <a:solidFill>
-                  <a:schemeClr val="tx1"/>
-                </a:solidFill>
-                <a:latin typeface="Liberation Mono"/>
-                <a:ea typeface="Liberation Mono"/>
-                <a:cs typeface="Liberation Mono"/>
-              </a:rPr>
-              <a:t>                .filter(volunteerAvailableDate -&gt; volunteerAvailableDate.getAvailableDate().equals(visit.getDate())) //</a:t>
-            </a:r>
-            <a:endParaRPr sz="1400" b="0" i="0" u="none" strike="noStrike" cap="none" spc="0">
-              <a:solidFill>
-                <a:schemeClr val="tx1"/>
-              </a:solidFill>
-              <a:latin typeface="Liberation Mono"/>
-              <a:cs typeface="Liberation Mono"/>
-            </a:endParaRPr>
-          </a:p>
-          <a:p>
-            <a:pPr>
-              <a:defRPr/>
-            </a:pPr>
-            <a:r>
-              <a:rPr lang="en" sz="1400" b="0" i="0" u="none" strike="noStrike" cap="none" spc="0">
-                <a:solidFill>
-                  <a:schemeClr val="tx1"/>
-                </a:solidFill>
-                <a:latin typeface="Liberation Mono"/>
-                <a:ea typeface="Liberation Mono"/>
-                <a:cs typeface="Liberation Mono"/>
-              </a:rPr>
-              <a:t>                .map(VolunteerAvailableDate::getVolunteerId) //</a:t>
-            </a:r>
-            <a:endParaRPr sz="1400" b="0" i="0" u="none" strike="noStrike" cap="none" spc="0">
-              <a:solidFill>
-                <a:schemeClr val="tx1"/>
-              </a:solidFill>
-              <a:latin typeface="Liberation Mono"/>
-              <a:cs typeface="Liberation Mono"/>
-            </a:endParaRPr>
-          </a:p>
-          <a:p>
-            <a:pPr>
-              <a:defRPr/>
-            </a:pPr>
-            <a:r>
-              <a:rPr lang="en" sz="1400" b="0" i="0" u="none" strike="noStrike" cap="none" spc="0">
-                <a:solidFill>
-                  <a:schemeClr val="tx1"/>
-                </a:solidFill>
-                <a:latin typeface="Liberation Mono"/>
-                <a:ea typeface="Liberation Mono"/>
-                <a:cs typeface="Liberation Mono"/>
-              </a:rPr>
-              <a:t>                .collect(Collectors.toList());</a:t>
-            </a:r>
-            <a:endParaRPr sz="1400" b="0" i="0" u="none" strike="noStrike" cap="none" spc="0">
-              <a:solidFill>
-                <a:schemeClr val="tx1"/>
-              </a:solidFill>
-              <a:latin typeface="Liberation Mono"/>
-              <a:cs typeface="Liberation Mono"/>
-            </a:endParaRPr>
-          </a:p>
-          <a:p>
-            <a:pPr>
-              <a:defRPr/>
-            </a:pPr>
-            <a:r>
-              <a:rPr lang="en" sz="1400" b="0" i="0" u="none" strike="noStrike" cap="none" spc="0">
-                <a:solidFill>
-                  <a:schemeClr val="tx1"/>
-                </a:solidFill>
-                <a:latin typeface="Liberation Mono"/>
-                <a:ea typeface="Liberation Mono"/>
-                <a:cs typeface="Liberation Mono"/>
-              </a:rPr>
-              <a:t>    }</a:t>
-            </a:r>
-            <a:endParaRPr sz="1800"/>
-          </a:p>
-        </p:txBody>
-      </p:sp>
-      <p:sp>
-        <p:nvSpPr>
-          <p:cNvPr id="1698375116" name="CasellaDiTesto 1698375115"/>
-          <p:cNvSpPr txBox="1"/>
-          <p:nvPr/>
-        </p:nvSpPr>
-        <p:spPr bwMode="auto">
-          <a:xfrm>
-            <a:off x="9679349" y="1269043"/>
-            <a:ext cx="1995238" cy="640440"/>
-          </a:xfrm>
-          <a:prstGeom prst="rect">
-            <a:avLst/>
-          </a:prstGeom>
-          <a:noFill/>
-        </p:spPr>
-        <p:txBody>
-          <a:bodyPr vertOverflow="overflow" horzOverflow="overflow" vert="horz" wrap="square" lIns="91440" tIns="45720" rIns="91440" bIns="45720" numCol="1" spcCol="0" rtlCol="0" fromWordArt="0" anchor="ctr" anchorCtr="0" forceAA="0" compatLnSpc="0">
-            <a:spAutoFit/>
-          </a:bodyPr>
-          <a:lstStyle/>
-          <a:p>
-            <a:pPr algn="ctr">
-              <a:defRPr/>
-            </a:pPr>
-            <a:r>
-              <a:rPr lang="en" sz="3600" b="1">
-                <a:ln w="6349">
-                  <a:solidFill>
-                    <a:srgbClr val="000000"/>
-                  </a:solidFill>
-                  <a:prstDash val="solid"/>
-                </a:ln>
-                <a:solidFill>
-                  <a:schemeClr val="accent2">
-                    <a:lumMod val="75000"/>
-                  </a:schemeClr>
-                </a:solidFill>
-                <a:latin typeface="Cantarell Extra Bold"/>
-                <a:ea typeface="Cantarell Extra Bold"/>
-                <a:cs typeface="Cantarell Extra Bold"/>
-              </a:rPr>
-              <a:t>PRIMA</a:t>
-            </a:r>
-            <a:endParaRPr>
-              <a:ln w="6349">
-                <a:solidFill>
-                  <a:schemeClr val="tx1"/>
-                </a:solidFill>
-                <a:prstDash val="solid"/>
-              </a:ln>
-            </a:endParaRPr>
-          </a:p>
-        </p:txBody>
-      </p:sp>
-      <p:sp>
-        <p:nvSpPr>
-          <p:cNvPr id="1482612164" name="CasellaDiTesto 1482612163"/>
-          <p:cNvSpPr txBox="1"/>
-          <p:nvPr/>
-        </p:nvSpPr>
-        <p:spPr bwMode="auto">
-          <a:xfrm>
-            <a:off x="9679349" y="3920157"/>
-            <a:ext cx="1998837" cy="640440"/>
-          </a:xfrm>
-          <a:prstGeom prst="rect">
-            <a:avLst/>
-          </a:prstGeom>
-          <a:noFill/>
-        </p:spPr>
-        <p:txBody>
-          <a:bodyPr vertOverflow="overflow" horzOverflow="overflow" vert="horz" wrap="square" lIns="91440" tIns="45720" rIns="91440" bIns="45720" numCol="1" spcCol="0" rtlCol="0" fromWordArt="0" anchor="ctr" anchorCtr="0" forceAA="0" compatLnSpc="0">
-            <a:spAutoFit/>
-          </a:bodyPr>
-          <a:lstStyle/>
-          <a:p>
-            <a:pPr algn="ctr">
-              <a:defRPr/>
-            </a:pPr>
-            <a:r>
-              <a:rPr lang="en" sz="3600" b="1">
-                <a:ln w="6349">
-                  <a:solidFill>
-                    <a:srgbClr val="000000"/>
-                  </a:solidFill>
-                  <a:prstDash val="solid"/>
-                </a:ln>
-                <a:solidFill>
-                  <a:srgbClr val="92D050"/>
-                </a:solidFill>
-                <a:latin typeface="Cantarell Extra Bold"/>
-                <a:ea typeface="Cantarell Extra Bold"/>
-                <a:cs typeface="Cantarell Extra Bold"/>
-              </a:rPr>
-              <a:t>DOPO</a:t>
-            </a:r>
-            <a:endParaRPr>
-              <a:ln w="6349">
-                <a:solidFill>
-                  <a:schemeClr val="tx1"/>
-                </a:solidFill>
-                <a:prstDash val="solid"/>
-              </a:ln>
-            </a:endParaRPr>
-          </a:p>
-        </p:txBody>
-      </p:sp>
-    </p:spTree>
-  </p:cSld>
-  <p:clrMapOvr>
-    <a:masterClrMapping/>
-  </p:clrMapOvr>
-</p:sld>
-</file>
-
 <file path=ppt/slides/slide24.xml><?xml version="1.0" encoding="utf-8"?>
 <p:sld xmlns:a="http://schemas.openxmlformats.org/drawingml/2006/main" xmlns:r="http://schemas.openxmlformats.org/officeDocument/2006/relationships" xmlns:p="http://schemas.openxmlformats.org/presentationml/2006/main" showMasterPhAnim="0">
   <p:cSld>
@@ -11583,7 +11039,7 @@
       </p:grpSpPr>
       <p:sp>
         <p:nvSpPr>
-          <p:cNvPr id="2068409532" name="Titolo 1"/>
+          <p:cNvPr id="59495650" name="Titolo 1"/>
           <p:cNvSpPr>
             <a:spLocks noGrp="1"/>
           </p:cNvSpPr>
@@ -11593,8 +11049,8 @@
         </p:nvSpPr>
         <p:spPr bwMode="auto">
           <a:xfrm>
-            <a:off x="838198" y="37802"/>
-            <a:ext cx="10515600" cy="1325562"/>
+            <a:off x="838198" y="365123"/>
+            <a:ext cx="5555216" cy="1325561"/>
           </a:xfrm>
         </p:spPr>
         <p:txBody>
@@ -11615,26 +11071,86 @@
               </a:rPr>
               <a:t>Refactoring</a:t>
             </a:r>
-            <a:endParaRPr b="1">
-              <a:solidFill>
-                <a:srgbClr val="0070C0"/>
-              </a:solidFill>
-              <a:latin typeface="Noto Sans"/>
-              <a:cs typeface="Noto Sans"/>
-            </a:endParaRPr>
-          </a:p>
-        </p:txBody>
-      </p:sp>
-      <p:sp>
-        <p:nvSpPr>
-          <p:cNvPr id="17675352" name="CasellaDiTesto 17675351"/>
+            <a:endParaRPr/>
+          </a:p>
+        </p:txBody>
+      </p:sp>
+      <p:sp>
+        <p:nvSpPr>
+          <p:cNvPr id="104998061" name="Segnaposto contenuto 2"/>
+          <p:cNvSpPr>
+            <a:spLocks noGrp="1"/>
+          </p:cNvSpPr>
+          <p:nvPr>
+            <p:ph idx="1"/>
+          </p:nvPr>
+        </p:nvSpPr>
+        <p:spPr bwMode="auto"/>
+        <p:txBody>
+          <a:bodyPr/>
+          <a:lstStyle/>
+          <a:p>
+            <a:pPr marL="0" indent="0">
+              <a:buFont typeface="Arial"/>
+              <a:buNone/>
+              <a:defRPr/>
+            </a:pPr>
+            <a:r>
+              <a:rPr lang="en"/>
+              <a:t>Il refactoring della classe VisitPlanService si é reso necessario perché:</a:t>
+            </a:r>
+          </a:p>
+          <a:p>
+            <a:pPr>
+              <a:defRPr/>
+            </a:pPr>
+            <a:r>
+              <a:rPr lang="en"/>
+              <a:t>contiene l’algoritmo fondamentale per il funzionamento del programma</a:t>
+            </a:r>
+          </a:p>
+          <a:p>
+            <a:pPr>
+              <a:defRPr/>
+            </a:pPr>
+            <a:r>
+              <a:rPr lang="en"/>
+              <a:t>é probabile che possa subire modifiche/aggiunte in futuro</a:t>
+            </a:r>
+          </a:p>
+          <a:p>
+            <a:pPr>
+              <a:defRPr/>
+            </a:pPr>
+            <a:r>
+              <a:rPr lang="en"/>
+              <a:t>combina molte informazioni diverse: visite, tipi di visite, date non disponibili, volontari e relative disponibilitá</a:t>
+            </a:r>
+          </a:p>
+          <a:p>
+            <a:pPr marL="0" indent="0">
+              <a:buFont typeface="Arial"/>
+              <a:buNone/>
+              <a:defRPr/>
+            </a:pPr>
+            <a:r>
+              <a:rPr lang="en"/>
+              <a:t>Di seguito i pattern di refactoring applicati</a:t>
+            </a:r>
+            <a:endParaRPr/>
+          </a:p>
+        </p:txBody>
+      </p:sp>
+      <p:sp>
+        <p:nvSpPr>
+          <p:cNvPr id="27321058" name="CasellaDiTesto 27321057"/>
           <p:cNvSpPr txBox="1"/>
           <p:nvPr/>
         </p:nvSpPr>
         <p:spPr bwMode="auto">
           <a:xfrm>
-            <a:off x="4383448" y="471802"/>
-            <a:ext cx="7416345" cy="457559"/>
+            <a:off x="5753406" y="844844"/>
+            <a:ext cx="5851705" cy="518519"/>
           </a:xfrm>
           <a:prstGeom prst="rect">
             <a:avLst/>
@@ -11651,7 +11167,7 @@
               <a:defRPr/>
             </a:pPr>
             <a:r>
-              <a:rPr lang="en" sz="2400" b="1">
+              <a:rPr lang="en" sz="2800" b="1">
                 <a:solidFill>
                   <a:srgbClr val="0070C0"/>
                 </a:solidFill>
@@ -11659,526 +11175,12 @@
                 <a:ea typeface="DejaVu Sans Condensed"/>
                 <a:cs typeface="DejaVu Sans Condensed"/>
               </a:rPr>
-              <a:t>Extract Method - 2 + semplificazione logica</a:t>
-            </a:r>
-            <a:endParaRPr sz="1400" b="1">
+              <a:t>Caso di VisitPlanService</a:t>
+            </a:r>
+            <a:endParaRPr b="1">
               <a:solidFill>
                 <a:srgbClr val="0070C0"/>
               </a:solidFill>
-            </a:endParaRPr>
-          </a:p>
-        </p:txBody>
-      </p:sp>
-      <p:sp>
-        <p:nvSpPr>
-          <p:cNvPr id="1873129134" name="CasellaDiTesto 1873129133"/>
-          <p:cNvSpPr txBox="1"/>
-          <p:nvPr/>
-        </p:nvSpPr>
-        <p:spPr bwMode="auto">
-          <a:xfrm>
-            <a:off x="457913" y="1160460"/>
-            <a:ext cx="11635248" cy="4291325"/>
-          </a:xfrm>
-          <a:prstGeom prst="roundRect">
-            <a:avLst>
-              <a:gd name="adj" fmla="val 5796"/>
-            </a:avLst>
-          </a:prstGeom>
-          <a:solidFill>
-            <a:schemeClr val="bg1">
-              <a:alpha val="49999"/>
-            </a:schemeClr>
-          </a:solidFill>
-          <a:ln w="12699">
-            <a:solidFill>
-              <a:schemeClr val="tx1"/>
-            </a:solidFill>
-            <a:prstDash val="solid"/>
-          </a:ln>
-        </p:spPr>
-        <p:txBody>
-          <a:bodyPr vertOverflow="overflow" horzOverflow="overflow" vert="horz" wrap="square" lIns="91440" tIns="45720" rIns="91440" bIns="45720" numCol="1" spcCol="0" rtlCol="0" fromWordArt="0" anchor="t" anchorCtr="0" forceAA="0" compatLnSpc="0">
-            <a:spAutoFit/>
-          </a:bodyPr>
-          <a:lstStyle/>
-          <a:p>
-            <a:pPr>
-              <a:defRPr/>
-            </a:pPr>
-            <a:r>
-              <a:rPr lang="it-IT" sz="1400" b="0" i="0" u="none" strike="noStrike" cap="none" spc="0">
-                <a:solidFill>
-                  <a:schemeClr val="tx1"/>
-                </a:solidFill>
-                <a:latin typeface="Liberation Mono"/>
-                <a:ea typeface="Liberation Mono"/>
-                <a:cs typeface="Liberation Mono"/>
-              </a:rPr>
-              <a:t>if (availableVolunteers.isEmpty()) {</a:t>
-            </a:r>
-            <a:endParaRPr sz="1400" b="0" i="0" u="none" strike="noStrike" cap="none" spc="0">
-              <a:solidFill>
-                <a:schemeClr val="tx1"/>
-              </a:solidFill>
-              <a:latin typeface="Liberation Mono"/>
-              <a:cs typeface="Liberation Mono"/>
-            </a:endParaRPr>
-          </a:p>
-          <a:p>
-            <a:pPr>
-              <a:defRPr/>
-            </a:pPr>
-            <a:r>
-              <a:rPr lang="it-IT" sz="1400" b="0" i="0" u="none" strike="noStrike" cap="none" spc="0">
-                <a:solidFill>
-                  <a:schemeClr val="tx1"/>
-                </a:solidFill>
-                <a:latin typeface="Liberation Mono"/>
-                <a:ea typeface="Liberation Mono"/>
-                <a:cs typeface="Liberation Mono"/>
-              </a:rPr>
-              <a:t>                visit.setVisitStatus(VisitStatus.CANCELLED);</a:t>
-            </a:r>
-            <a:endParaRPr sz="1400" b="0" i="0" u="none" strike="noStrike" cap="none" spc="0">
-              <a:solidFill>
-                <a:schemeClr val="tx1"/>
-              </a:solidFill>
-              <a:latin typeface="Liberation Mono"/>
-              <a:cs typeface="Liberation Mono"/>
-            </a:endParaRPr>
-          </a:p>
-          <a:p>
-            <a:pPr>
-              <a:defRPr/>
-            </a:pPr>
-            <a:r>
-              <a:rPr lang="it-IT" sz="1400" b="0" i="0" u="none" strike="noStrike" cap="none" spc="0">
-                <a:solidFill>
-                  <a:schemeClr val="tx1"/>
-                </a:solidFill>
-                <a:latin typeface="Liberation Mono"/>
-                <a:ea typeface="Liberation Mono"/>
-                <a:cs typeface="Liberation Mono"/>
-              </a:rPr>
-              <a:t>                visitRepository.save(visit);</a:t>
-            </a:r>
-            <a:endParaRPr sz="1400" b="0" i="0" u="none" strike="noStrike" cap="none" spc="0">
-              <a:solidFill>
-                <a:schemeClr val="tx1"/>
-              </a:solidFill>
-              <a:latin typeface="Liberation Mono"/>
-              <a:cs typeface="Liberation Mono"/>
-            </a:endParaRPr>
-          </a:p>
-          <a:p>
-            <a:pPr>
-              <a:defRPr/>
-            </a:pPr>
-            <a:r>
-              <a:rPr lang="it-IT" sz="1400" b="0" i="0" u="none" strike="noStrike" cap="none" spc="0">
-                <a:solidFill>
-                  <a:schemeClr val="tx1"/>
-                </a:solidFill>
-                <a:latin typeface="Liberation Mono"/>
-                <a:ea typeface="Liberation Mono"/>
-                <a:cs typeface="Liberation Mono"/>
-              </a:rPr>
-              <a:t>                continue; // passa alla visita successiva</a:t>
-            </a:r>
-            <a:endParaRPr sz="1400" b="0" i="0" u="none" strike="noStrike" cap="none" spc="0">
-              <a:solidFill>
-                <a:schemeClr val="tx1"/>
-              </a:solidFill>
-              <a:latin typeface="Liberation Mono"/>
-              <a:cs typeface="Liberation Mono"/>
-            </a:endParaRPr>
-          </a:p>
-          <a:p>
-            <a:pPr>
-              <a:defRPr/>
-            </a:pPr>
-            <a:r>
-              <a:rPr lang="it-IT" sz="1400" b="0" i="0" u="none" strike="noStrike" cap="none" spc="0">
-                <a:solidFill>
-                  <a:schemeClr val="tx1"/>
-                </a:solidFill>
-                <a:latin typeface="Liberation Mono"/>
-                <a:ea typeface="Liberation Mono"/>
-                <a:cs typeface="Liberation Mono"/>
-              </a:rPr>
-              <a:t>            } else if (availableVolunteers.size() == 1) {</a:t>
-            </a:r>
-            <a:endParaRPr sz="1400" b="0" i="0" u="none" strike="noStrike" cap="none" spc="0">
-              <a:solidFill>
-                <a:schemeClr val="tx1"/>
-              </a:solidFill>
-              <a:latin typeface="Liberation Mono"/>
-              <a:cs typeface="Liberation Mono"/>
-            </a:endParaRPr>
-          </a:p>
-          <a:p>
-            <a:pPr>
-              <a:defRPr/>
-            </a:pPr>
-            <a:r>
-              <a:rPr lang="it-IT" sz="1400" b="0" i="0" u="none" strike="noStrike" cap="none" spc="0">
-                <a:solidFill>
-                  <a:schemeClr val="tx1"/>
-                </a:solidFill>
-                <a:latin typeface="Liberation Mono"/>
-                <a:ea typeface="Liberation Mono"/>
-                <a:cs typeface="Liberation Mono"/>
-              </a:rPr>
-              <a:t>                User volunteer = availableVolunteers.getFirst();</a:t>
-            </a:r>
-            <a:endParaRPr sz="1400" b="0" i="0" u="none" strike="noStrike" cap="none" spc="0">
-              <a:solidFill>
-                <a:schemeClr val="tx1"/>
-              </a:solidFill>
-              <a:latin typeface="Liberation Mono"/>
-              <a:cs typeface="Liberation Mono"/>
-            </a:endParaRPr>
-          </a:p>
-          <a:p>
-            <a:pPr>
-              <a:defRPr/>
-            </a:pPr>
-            <a:r>
-              <a:rPr lang="it-IT" sz="1400" b="0" i="0" u="none" strike="noStrike" cap="none" spc="0">
-                <a:solidFill>
-                  <a:schemeClr val="tx1"/>
-                </a:solidFill>
-                <a:latin typeface="Liberation Mono"/>
-                <a:ea typeface="Liberation Mono"/>
-                <a:cs typeface="Liberation Mono"/>
-              </a:rPr>
-              <a:t>                if (canDoVisitType(volunteer, visit.getVisitType().getId()))</a:t>
-            </a:r>
-            <a:endParaRPr sz="1400" b="0" i="0" u="none" strike="noStrike" cap="none" spc="0">
-              <a:solidFill>
-                <a:schemeClr val="tx1"/>
-              </a:solidFill>
-              <a:latin typeface="Liberation Mono"/>
-              <a:cs typeface="Liberation Mono"/>
-            </a:endParaRPr>
-          </a:p>
-          <a:p>
-            <a:pPr>
-              <a:defRPr/>
-            </a:pPr>
-            <a:r>
-              <a:rPr lang="it-IT" sz="1400" b="0" i="0" u="none" strike="noStrike" cap="none" spc="0">
-                <a:solidFill>
-                  <a:schemeClr val="tx1"/>
-                </a:solidFill>
-                <a:latin typeface="Liberation Mono"/>
-                <a:ea typeface="Liberation Mono"/>
-                <a:cs typeface="Liberation Mono"/>
-              </a:rPr>
-              <a:t>                    assignVolunteerToVisit(volunteer, visit, monthAvailabilities, volunteerVisitCounts);</a:t>
-            </a:r>
-            <a:endParaRPr sz="1400" b="0" i="0" u="none" strike="noStrike" cap="none" spc="0">
-              <a:solidFill>
-                <a:schemeClr val="tx1"/>
-              </a:solidFill>
-              <a:latin typeface="Liberation Mono"/>
-              <a:cs typeface="Liberation Mono"/>
-            </a:endParaRPr>
-          </a:p>
-          <a:p>
-            <a:pPr>
-              <a:defRPr/>
-            </a:pPr>
-            <a:r>
-              <a:rPr lang="it-IT" sz="1400" b="0" i="0" u="none" strike="noStrike" cap="none" spc="0">
-                <a:solidFill>
-                  <a:schemeClr val="tx1"/>
-                </a:solidFill>
-                <a:latin typeface="Liberation Mono"/>
-                <a:ea typeface="Liberation Mono"/>
-                <a:cs typeface="Liberation Mono"/>
-              </a:rPr>
-              <a:t>                else {</a:t>
-            </a:r>
-            <a:endParaRPr sz="1400" b="0" i="0" u="none" strike="noStrike" cap="none" spc="0">
-              <a:solidFill>
-                <a:schemeClr val="tx1"/>
-              </a:solidFill>
-              <a:latin typeface="Liberation Mono"/>
-              <a:cs typeface="Liberation Mono"/>
-            </a:endParaRPr>
-          </a:p>
-          <a:p>
-            <a:pPr>
-              <a:defRPr/>
-            </a:pPr>
-            <a:r>
-              <a:rPr lang="it-IT" sz="1400" b="0" i="0" u="none" strike="noStrike" cap="none" spc="0">
-                <a:solidFill>
-                  <a:schemeClr val="tx1"/>
-                </a:solidFill>
-                <a:latin typeface="Liberation Mono"/>
-                <a:ea typeface="Liberation Mono"/>
-                <a:cs typeface="Liberation Mono"/>
-              </a:rPr>
-              <a:t>                    visit.setVisitStatus(VisitStatus.CANCELLED);</a:t>
-            </a:r>
-            <a:endParaRPr sz="1400" b="0" i="0" u="none" strike="noStrike" cap="none" spc="0">
-              <a:solidFill>
-                <a:schemeClr val="tx1"/>
-              </a:solidFill>
-              <a:latin typeface="Liberation Mono"/>
-              <a:cs typeface="Liberation Mono"/>
-            </a:endParaRPr>
-          </a:p>
-          <a:p>
-            <a:pPr>
-              <a:defRPr/>
-            </a:pPr>
-            <a:r>
-              <a:rPr lang="it-IT" sz="1400" b="0" i="0" u="none" strike="noStrike" cap="none" spc="0">
-                <a:solidFill>
-                  <a:schemeClr val="tx1"/>
-                </a:solidFill>
-                <a:latin typeface="Liberation Mono"/>
-                <a:ea typeface="Liberation Mono"/>
-                <a:cs typeface="Liberation Mono"/>
-              </a:rPr>
-              <a:t>                    visitRepository.save(visit);</a:t>
-            </a:r>
-            <a:endParaRPr sz="1400" b="0" i="0" u="none" strike="noStrike" cap="none" spc="0">
-              <a:solidFill>
-                <a:schemeClr val="tx1"/>
-              </a:solidFill>
-              <a:latin typeface="Liberation Mono"/>
-              <a:cs typeface="Liberation Mono"/>
-            </a:endParaRPr>
-          </a:p>
-          <a:p>
-            <a:pPr>
-              <a:defRPr/>
-            </a:pPr>
-            <a:r>
-              <a:rPr lang="it-IT" sz="1400" b="0" i="0" u="none" strike="noStrike" cap="none" spc="0">
-                <a:solidFill>
-                  <a:schemeClr val="tx1"/>
-                </a:solidFill>
-                <a:latin typeface="Liberation Mono"/>
-                <a:ea typeface="Liberation Mono"/>
-                <a:cs typeface="Liberation Mono"/>
-              </a:rPr>
-              <a:t>                }</a:t>
-            </a:r>
-            <a:endParaRPr sz="1400" b="0" i="0" u="none" strike="noStrike" cap="none" spc="0">
-              <a:solidFill>
-                <a:schemeClr val="tx1"/>
-              </a:solidFill>
-              <a:latin typeface="Liberation Mono"/>
-              <a:cs typeface="Liberation Mono"/>
-            </a:endParaRPr>
-          </a:p>
-          <a:p>
-            <a:pPr>
-              <a:defRPr/>
-            </a:pPr>
-            <a:r>
-              <a:rPr lang="it-IT" sz="1400" b="0" i="0" u="none" strike="noStrike" cap="none" spc="0">
-                <a:solidFill>
-                  <a:schemeClr val="tx1"/>
-                </a:solidFill>
-                <a:latin typeface="Liberation Mono"/>
-                <a:ea typeface="Liberation Mono"/>
-                <a:cs typeface="Liberation Mono"/>
-              </a:rPr>
-              <a:t>                continue; // passa alla visita successiva</a:t>
-            </a:r>
-            <a:endParaRPr sz="1400" b="0" i="0" u="none" strike="noStrike" cap="none" spc="0">
-              <a:solidFill>
-                <a:schemeClr val="tx1"/>
-              </a:solidFill>
-              <a:latin typeface="Liberation Mono"/>
-              <a:cs typeface="Liberation Mono"/>
-            </a:endParaRPr>
-          </a:p>
-          <a:p>
-            <a:pPr>
-              <a:defRPr/>
-            </a:pPr>
-            <a:r>
-              <a:rPr lang="it-IT" sz="1400" b="0" i="0" u="none" strike="noStrike" cap="none" spc="0">
-                <a:solidFill>
-                  <a:schemeClr val="tx1"/>
-                </a:solidFill>
-                <a:latin typeface="Liberation Mono"/>
-                <a:ea typeface="Liberation Mono"/>
-                <a:cs typeface="Liberation Mono"/>
-              </a:rPr>
-              <a:t>            }</a:t>
-            </a:r>
-            <a:endParaRPr sz="1400" b="0" i="0" u="none" strike="noStrike" cap="none" spc="0">
-              <a:solidFill>
-                <a:schemeClr val="tx1"/>
-              </a:solidFill>
-              <a:latin typeface="Liberation Mono"/>
-              <a:cs typeface="Liberation Mono"/>
-            </a:endParaRPr>
-          </a:p>
-          <a:p>
-            <a:pPr>
-              <a:defRPr/>
-            </a:pPr>
-            <a:r>
-              <a:rPr lang="it-IT" sz="1400" b="0" i="0" u="none" strike="noStrike" cap="none" spc="0">
-                <a:solidFill>
-                  <a:schemeClr val="tx1"/>
-                </a:solidFill>
-                <a:latin typeface="Liberation Mono"/>
-                <a:ea typeface="Liberation Mono"/>
-                <a:cs typeface="Liberation Mono"/>
-              </a:rPr>
-              <a:t>            // piú di 2 volontari con disponibilitá nel giorno considerato</a:t>
-            </a:r>
-            <a:endParaRPr sz="1400" b="0" i="0" u="none" strike="noStrike" cap="none" spc="0">
-              <a:solidFill>
-                <a:schemeClr val="tx1"/>
-              </a:solidFill>
-              <a:latin typeface="Liberation Mono"/>
-              <a:cs typeface="Liberation Mono"/>
-            </a:endParaRPr>
-          </a:p>
-          <a:p>
-            <a:pPr>
-              <a:defRPr/>
-            </a:pPr>
-            <a:r>
-              <a:rPr lang="it-IT" sz="1400" b="0" i="0" u="none" strike="noStrike" cap="none" spc="0">
-                <a:solidFill>
-                  <a:schemeClr val="tx1"/>
-                </a:solidFill>
-                <a:latin typeface="Liberation Mono"/>
-                <a:ea typeface="Liberation Mono"/>
-                <a:cs typeface="Liberation Mono"/>
-              </a:rPr>
-              <a:t>            User bestVolunteer = selectBestVolunteer(availableVolunteers, volunteerVisitCounts);</a:t>
-            </a:r>
-            <a:endParaRPr sz="1400" b="0" i="0" u="none" strike="noStrike" cap="none" spc="0">
-              <a:solidFill>
-                <a:schemeClr val="tx1"/>
-              </a:solidFill>
-              <a:latin typeface="Liberation Mono"/>
-              <a:cs typeface="Liberation Mono"/>
-            </a:endParaRPr>
-          </a:p>
-          <a:p>
-            <a:pPr>
-              <a:defRPr/>
-            </a:pPr>
-            <a:r>
-              <a:rPr lang="it-IT" sz="1400" b="0" i="0" u="none" strike="noStrike" cap="none" spc="0">
-                <a:solidFill>
-                  <a:schemeClr val="tx1"/>
-                </a:solidFill>
-                <a:latin typeface="Liberation Mono"/>
-                <a:ea typeface="Liberation Mono"/>
-                <a:cs typeface="Liberation Mono"/>
-              </a:rPr>
-              <a:t>            assignVolunteerToVisit(bestVolunteer, visit, monthAvailabilities, volunteerVisitCounts);</a:t>
-            </a:r>
-            <a:endParaRPr sz="1400" b="0" i="0" u="none" strike="noStrike" cap="none" spc="0">
-              <a:solidFill>
-                <a:schemeClr val="tx1"/>
-              </a:solidFill>
-              <a:latin typeface="Liberation Mono"/>
-              <a:cs typeface="Liberation Mono"/>
-            </a:endParaRPr>
-          </a:p>
-          <a:p>
-            <a:pPr>
-              <a:defRPr/>
-            </a:pPr>
-            <a:r>
-              <a:rPr lang="it-IT" sz="1400" b="0" i="0" u="none" strike="noStrike" cap="none" spc="0">
-                <a:solidFill>
-                  <a:schemeClr val="tx1"/>
-                </a:solidFill>
-                <a:latin typeface="Liberation Mono"/>
-                <a:ea typeface="Liberation Mono"/>
-                <a:cs typeface="Liberation Mono"/>
-              </a:rPr>
-              <a:t>        }</a:t>
-            </a:r>
-          </a:p>
-          <a:p>
-            <a:pPr>
-              <a:defRPr/>
-            </a:pPr>
-            <a:r>
-              <a:rPr lang="en" sz="1400" b="0" i="0" u="none" strike="noStrike" cap="none" spc="0">
-                <a:solidFill>
-                  <a:schemeClr val="tx1"/>
-                </a:solidFill>
-                <a:latin typeface="Liberation Mono"/>
-                <a:ea typeface="Liberation Mono"/>
-                <a:cs typeface="Liberation Mono"/>
-              </a:rPr>
-              <a:t>...</a:t>
-            </a:r>
-            <a:endParaRPr/>
-          </a:p>
-        </p:txBody>
-      </p:sp>
-      <p:sp>
-        <p:nvSpPr>
-          <p:cNvPr id="1625665772" name="CasellaDiTesto 1625665771"/>
-          <p:cNvSpPr txBox="1"/>
-          <p:nvPr/>
-        </p:nvSpPr>
-        <p:spPr bwMode="auto">
-          <a:xfrm>
-            <a:off x="9679349" y="1269223"/>
-            <a:ext cx="1995597" cy="640440"/>
-          </a:xfrm>
-          <a:prstGeom prst="rect">
-            <a:avLst/>
-          </a:prstGeom>
-          <a:noFill/>
-        </p:spPr>
-        <p:txBody>
-          <a:bodyPr vertOverflow="overflow" horzOverflow="overflow" vert="horz" wrap="square" lIns="91440" tIns="45720" rIns="91440" bIns="45720" numCol="1" spcCol="0" rtlCol="0" fromWordArt="0" anchor="ctr" anchorCtr="0" forceAA="0" compatLnSpc="0">
-            <a:spAutoFit/>
-          </a:bodyPr>
-          <a:lstStyle/>
-          <a:p>
-            <a:pPr algn="ctr">
-              <a:defRPr/>
-            </a:pPr>
-            <a:r>
-              <a:rPr lang="en" sz="3600" b="1">
-                <a:ln w="6349">
-                  <a:solidFill>
-                    <a:srgbClr val="000000"/>
-                  </a:solidFill>
-                  <a:prstDash val="solid"/>
-                </a:ln>
-                <a:solidFill>
-                  <a:schemeClr val="accent2">
-                    <a:lumMod val="75000"/>
-                  </a:schemeClr>
-                </a:solidFill>
-                <a:latin typeface="Cantarell Extra Bold"/>
-                <a:ea typeface="Cantarell Extra Bold"/>
-                <a:cs typeface="Cantarell Extra Bold"/>
-              </a:rPr>
-              <a:t>PRIMA</a:t>
-            </a:r>
-            <a:endParaRPr>
-              <a:ln w="6349">
-                <a:solidFill>
-                  <a:schemeClr val="tx1"/>
-                </a:solidFill>
-                <a:prstDash val="solid"/>
-              </a:ln>
             </a:endParaRPr>
           </a:p>
         </p:txBody>
@@ -12210,7 +11212,7 @@
       </p:grpSpPr>
       <p:sp>
         <p:nvSpPr>
-          <p:cNvPr id="449234049" name="Titolo 1"/>
+          <p:cNvPr id="149416002" name="Titolo 1"/>
           <p:cNvSpPr>
             <a:spLocks noGrp="1"/>
           </p:cNvSpPr>
@@ -12220,8 +11222,8 @@
         </p:nvSpPr>
         <p:spPr bwMode="auto">
           <a:xfrm>
-            <a:off x="838198" y="37801"/>
-            <a:ext cx="10515600" cy="1325561"/>
+            <a:off x="839459" y="37802"/>
+            <a:ext cx="10515600" cy="1325562"/>
           </a:xfrm>
         </p:spPr>
         <p:txBody>
@@ -12242,20 +11244,70 @@
               </a:rPr>
               <a:t>Refactoring</a:t>
             </a:r>
-            <a:endParaRPr/>
-          </a:p>
-        </p:txBody>
-      </p:sp>
-      <p:sp>
-        <p:nvSpPr>
-          <p:cNvPr id="1225781845" name="CasellaDiTesto 1225781844"/>
+            <a:endParaRPr b="1">
+              <a:solidFill>
+                <a:srgbClr val="0070C0"/>
+              </a:solidFill>
+              <a:latin typeface="Noto Sans"/>
+              <a:cs typeface="Noto Sans"/>
+            </a:endParaRPr>
+          </a:p>
+        </p:txBody>
+      </p:sp>
+      <p:sp>
+        <p:nvSpPr>
+          <p:cNvPr id="1040471417" name="CasellaDiTesto 1040471416"/>
           <p:cNvSpPr txBox="1"/>
           <p:nvPr/>
         </p:nvSpPr>
         <p:spPr bwMode="auto">
           <a:xfrm>
-            <a:off x="457913" y="1160460"/>
-            <a:ext cx="11637768" cy="3407891"/>
+            <a:off x="4915206" y="441324"/>
+            <a:ext cx="5860344" cy="518519"/>
+          </a:xfrm>
+          <a:prstGeom prst="rect">
+            <a:avLst/>
+          </a:prstGeom>
+          <a:noFill/>
+        </p:spPr>
+        <p:txBody>
+          <a:bodyPr vertOverflow="overflow" horzOverflow="overflow" vert="horz" wrap="square" lIns="91440" tIns="45720" rIns="91440" bIns="45720" numCol="1" spcCol="0" rtlCol="0" fromWordArt="0" anchor="t" anchorCtr="0" forceAA="0" compatLnSpc="0">
+            <a:spAutoFit/>
+          </a:bodyPr>
+          <a:lstStyle/>
+          <a:p>
+            <a:pPr algn="ctr">
+              <a:defRPr/>
+            </a:pPr>
+            <a:r>
+              <a:rPr lang="en" sz="2800" b="1">
+                <a:solidFill>
+                  <a:srgbClr val="0070C0"/>
+                </a:solidFill>
+                <a:latin typeface="DejaVu Sans Condensed"/>
+                <a:ea typeface="DejaVu Sans Condensed"/>
+                <a:cs typeface="DejaVu Sans Condensed"/>
+              </a:rPr>
+              <a:t>Extract Method - 1</a:t>
+            </a:r>
+            <a:endParaRPr b="1">
+              <a:solidFill>
+                <a:srgbClr val="0070C0"/>
+              </a:solidFill>
+            </a:endParaRPr>
+          </a:p>
+        </p:txBody>
+      </p:sp>
+      <p:sp>
+        <p:nvSpPr>
+          <p:cNvPr id="1689386774" name="CasellaDiTesto 1689386773"/>
+          <p:cNvSpPr txBox="1"/>
+          <p:nvPr/>
+        </p:nvSpPr>
+        <p:spPr bwMode="auto">
+          <a:xfrm>
+            <a:off x="457916" y="1160462"/>
+            <a:ext cx="11276167" cy="2524456"/>
           </a:xfrm>
           <a:prstGeom prst="roundRect">
             <a:avLst>
@@ -12292,8 +11344,15 @@
                 <a:ea typeface="Liberation Mono"/>
                 <a:cs typeface="Liberation Mono"/>
               </a:rPr>
-              <a:t>for (Visit visit : nextMonthSortedVisits) {</a:t>
-            </a:r>
+              <a:t>for (Visit visit : monthVisits) {</a:t>
+            </a:r>
+            <a:endParaRPr sz="1400" b="0" i="0" u="none" strike="noStrike" cap="none" spc="0">
+              <a:solidFill>
+                <a:schemeClr val="tx1"/>
+              </a:solidFill>
+              <a:latin typeface="Liberation Mono"/>
+              <a:cs typeface="Liberation Mono"/>
+            </a:endParaRPr>
           </a:p>
           <a:p>
             <a:pPr>
@@ -12308,7 +11367,7 @@
                 <a:ea typeface="Liberation Mono"/>
                 <a:cs typeface="Liberation Mono"/>
               </a:rPr>
-              <a:t>            List&lt;Integer&gt; availableVolunteerIds = getAvailableVolunteersForVisitDate(visit, volunteerAvailabilitiesNextMonth);</a:t>
+              <a:t>            LocalDate day = visit.getDate();</a:t>
             </a:r>
             <a:endParaRPr sz="1400" b="0" i="0" u="none" strike="noStrike" cap="none" spc="0">
               <a:solidFill>
@@ -12322,6 +11381,17 @@
             <a:pPr>
               <a:defRPr/>
             </a:pPr>
+            <a:r>
+              <a:rPr lang="it-IT" sz="1400" b="0" i="0" u="none" strike="noStrike" cap="none" spc="0">
+                <a:solidFill>
+                  <a:schemeClr val="tx1"/>
+                </a:solidFill>
+                <a:latin typeface="Liberation Mono"/>
+                <a:ea typeface="Liberation Mono"/>
+                <a:cs typeface="Liberation Mono"/>
+              </a:rPr>
+              <a:t>            List&lt;User&gt; availableVolunteers = new ArrayList&lt;&gt;();</a:t>
+            </a:r>
             <a:endParaRPr sz="1400" b="0" i="0" u="none" strike="noStrike" cap="none" spc="0">
               <a:solidFill>
                 <a:schemeClr val="tx1"/>
@@ -12334,6 +11404,18 @@
             <a:pPr>
               <a:defRPr/>
             </a:pPr>
+            <a:endParaRPr sz="1400" b="0" i="0" u="none" strike="noStrike" cap="none" spc="0">
+              <a:solidFill>
+                <a:schemeClr val="tx1"/>
+              </a:solidFill>
+              <a:latin typeface="Liberation Mono"/>
+              <a:cs typeface="Liberation Mono"/>
+            </a:endParaRPr>
+          </a:p>
+          <a:p>
+            <a:pPr>
+              <a:defRPr/>
+            </a:pPr>
             <a:r>
               <a:rPr lang="it-IT" sz="1400" b="0" i="0" u="none" strike="noStrike" cap="none" spc="0">
                 <a:solidFill>
@@ -12343,7 +11425,7 @@
                 <a:ea typeface="Liberation Mono"/>
                 <a:cs typeface="Liberation Mono"/>
               </a:rPr>
-              <a:t>            if (availableVolunteerIds.isEmpty()) {</a:t>
+              <a:t>            // aggiunge alla lista availableVolunteers tutti i volontari che hanno dato</a:t>
             </a:r>
             <a:endParaRPr sz="1400" b="0" i="0" u="none" strike="noStrike" cap="none" spc="0">
               <a:solidFill>
@@ -12366,7 +11448,7 @@
                 <a:ea typeface="Liberation Mono"/>
                 <a:cs typeface="Liberation Mono"/>
               </a:rPr>
-              <a:t>                setVisitStatusToCancelled(visit);</a:t>
+              <a:t>            // disponibilitá per il</a:t>
             </a:r>
             <a:endParaRPr sz="1400" b="0" i="0" u="none" strike="noStrike" cap="none" spc="0">
               <a:solidFill>
@@ -12389,7 +11471,7 @@
                 <a:ea typeface="Liberation Mono"/>
                 <a:cs typeface="Liberation Mono"/>
               </a:rPr>
-              <a:t>            } else if (availableVolunteerIds.size() == 1) {</a:t>
+              <a:t>            // giorno 'day'</a:t>
             </a:r>
             <a:endParaRPr sz="1400" b="0" i="0" u="none" strike="noStrike" cap="none" spc="0">
               <a:solidFill>
@@ -12412,7 +11494,7 @@
                 <a:ea typeface="Liberation Mono"/>
                 <a:cs typeface="Liberation Mono"/>
               </a:rPr>
-              <a:t>                assignAvailableVolunteerToVisitIfPossible(visit, availableVolunteerIds, volunteerAvailabilitiesNextMonth, volunteerIdWithVisitCounts);</a:t>
+              <a:t>            monthAvailabilities.stream().filter(av -&gt; av.getAvailableDate().equals(day)) //</a:t>
             </a:r>
             <a:endParaRPr sz="1400" b="0" i="0" u="none" strike="noStrike" cap="none" spc="0">
               <a:solidFill>
@@ -12435,7 +11517,7 @@
                 <a:ea typeface="Liberation Mono"/>
                 <a:cs typeface="Liberation Mono"/>
               </a:rPr>
-              <a:t>            } else {</a:t>
+              <a:t>                    // mappa le disponibilitá VolunteerAvailableDate con gli oggetti USER volontari</a:t>
             </a:r>
             <a:endParaRPr sz="1400" b="0" i="0" u="none" strike="noStrike" cap="none" spc="0">
               <a:solidFill>
@@ -12458,7 +11540,7 @@
                 <a:ea typeface="Liberation Mono"/>
                 <a:cs typeface="Liberation Mono"/>
               </a:rPr>
-              <a:t>                assignBestVolunteerAvailableToVisit(visit, availableVolunteerIds, volunteerIdWithVisitCounts, volunteerAvailabilitiesNextMonth);</a:t>
+              <a:t>                    .map(av -&gt; volunteerById(av.getVolunteerId(), volunteers)) //</a:t>
             </a:r>
             <a:endParaRPr sz="1400" b="0" i="0" u="none" strike="noStrike" cap="none" spc="0">
               <a:solidFill>
@@ -12481,74 +11563,284 @@
                 <a:ea typeface="Liberation Mono"/>
                 <a:cs typeface="Liberation Mono"/>
               </a:rPr>
-              <a:t>            }</a:t>
-            </a:r>
-            <a:endParaRPr sz="1400" b="0" i="0" u="none" strike="noStrike" cap="none" spc="0">
-              <a:solidFill>
-                <a:schemeClr val="tx1"/>
-              </a:solidFill>
-              <a:latin typeface="Liberation Mono"/>
-              <a:cs typeface="Liberation Mono"/>
-            </a:endParaRPr>
-          </a:p>
-          <a:p>
-            <a:pPr>
-              <a:defRPr/>
-            </a:pPr>
-            <a:r>
-              <a:rPr lang="it-IT" sz="1400" b="0" i="0" u="none" strike="noStrike" cap="none" spc="0">
-                <a:solidFill>
-                  <a:schemeClr val="tx1"/>
-                </a:solidFill>
-                <a:latin typeface="Liberation Mono"/>
-                <a:ea typeface="Liberation Mono"/>
-                <a:cs typeface="Liberation Mono"/>
-              </a:rPr>
-              <a:t>        }</a:t>
-            </a:r>
-            <a:endParaRPr sz="1400" b="0" i="0" u="none" strike="noStrike" cap="none" spc="0">
-              <a:solidFill>
-                <a:schemeClr val="tx1"/>
-              </a:solidFill>
-              <a:latin typeface="Liberation Mono"/>
-              <a:cs typeface="Liberation Mono"/>
-            </a:endParaRPr>
-          </a:p>
-          <a:p>
-            <a:pPr>
-              <a:defRPr/>
-            </a:pPr>
-            <a:r>
-              <a:rPr lang="en" sz="1400" b="0" i="0" u="none" strike="noStrike" cap="none" spc="0">
-                <a:solidFill>
-                  <a:schemeClr val="tx1"/>
-                </a:solidFill>
-                <a:latin typeface="Liberation Mono"/>
-                <a:ea typeface="Liberation Mono"/>
-                <a:cs typeface="Liberation Mono"/>
-              </a:rPr>
-              <a:t>...</a:t>
-            </a:r>
-            <a:endParaRPr sz="1400" b="0" i="0" u="none" strike="noStrike" cap="none" spc="0">
-              <a:solidFill>
-                <a:schemeClr val="tx1"/>
-              </a:solidFill>
-              <a:latin typeface="Liberation Mono"/>
-              <a:cs typeface="Liberation Mono"/>
-            </a:endParaRPr>
-          </a:p>
-        </p:txBody>
-      </p:sp>
-      <p:sp>
-        <p:nvSpPr>
-          <p:cNvPr id="1711987548" name="CasellaDiTesto 1711987547"/>
+              <a:t>                    .forEach(availableVolunteers::add);</a:t>
+            </a:r>
+            <a:endParaRPr/>
+          </a:p>
+        </p:txBody>
+      </p:sp>
+      <p:sp>
+        <p:nvSpPr>
+          <p:cNvPr id="58203512" name="CasellaDiTesto 58203511"/>
           <p:cNvSpPr txBox="1"/>
           <p:nvPr/>
         </p:nvSpPr>
         <p:spPr bwMode="auto">
           <a:xfrm>
-            <a:off x="4383448" y="471802"/>
-            <a:ext cx="7416703" cy="457559"/>
+            <a:off x="457916" y="3827462"/>
+            <a:ext cx="11278686" cy="2966174"/>
+          </a:xfrm>
+          <a:prstGeom prst="roundRect">
+            <a:avLst>
+              <a:gd name="adj" fmla="val 5796"/>
+            </a:avLst>
+          </a:prstGeom>
+          <a:solidFill>
+            <a:schemeClr val="bg1">
+              <a:alpha val="49999"/>
+            </a:schemeClr>
+          </a:solidFill>
+          <a:ln w="12699">
+            <a:solidFill>
+              <a:schemeClr val="tx1"/>
+            </a:solidFill>
+            <a:prstDash val="solid"/>
+          </a:ln>
+        </p:spPr>
+        <p:txBody>
+          <a:bodyPr vertOverflow="overflow" horzOverflow="overflow" vert="horz" wrap="square" lIns="91440" tIns="45720" rIns="91440" bIns="45720" numCol="1" spcCol="0" rtlCol="0" fromWordArt="0" anchor="t" anchorCtr="0" forceAA="0" compatLnSpc="0">
+            <a:spAutoFit/>
+          </a:bodyPr>
+          <a:lstStyle/>
+          <a:p>
+            <a:pPr>
+              <a:defRPr/>
+            </a:pPr>
+            <a:r>
+              <a:rPr lang="en" sz="1400" b="0" i="0" u="none" strike="noStrike" cap="none" spc="0">
+                <a:solidFill>
+                  <a:schemeClr val="tx1"/>
+                </a:solidFill>
+                <a:latin typeface="Liberation Mono"/>
+                <a:ea typeface="Liberation Mono"/>
+                <a:cs typeface="Liberation Mono"/>
+              </a:rPr>
+              <a:t>for (Visit visit : nextMonthSortedVisits) {</a:t>
+            </a:r>
+            <a:endParaRPr sz="1400" b="0" i="0" u="none" strike="noStrike" cap="none" spc="0">
+              <a:solidFill>
+                <a:schemeClr val="tx1"/>
+              </a:solidFill>
+              <a:latin typeface="Liberation Mono"/>
+              <a:cs typeface="Liberation Mono"/>
+            </a:endParaRPr>
+          </a:p>
+          <a:p>
+            <a:pPr>
+              <a:defRPr/>
+            </a:pPr>
+            <a:r>
+              <a:rPr lang="en" sz="1400" b="0" i="0" u="none" strike="noStrike" cap="none" spc="0">
+                <a:solidFill>
+                  <a:schemeClr val="tx1"/>
+                </a:solidFill>
+                <a:latin typeface="Liberation Mono"/>
+                <a:ea typeface="Liberation Mono"/>
+                <a:cs typeface="Liberation Mono"/>
+              </a:rPr>
+              <a:t>    List&lt;Integer&gt; availableVolunteerIds = </a:t>
+            </a:r>
+            <a:endParaRPr sz="1400" b="0" i="0" u="none" strike="noStrike" cap="none" spc="0">
+              <a:solidFill>
+                <a:schemeClr val="tx1"/>
+              </a:solidFill>
+              <a:latin typeface="Liberation Mono"/>
+              <a:cs typeface="Liberation Mono"/>
+            </a:endParaRPr>
+          </a:p>
+          <a:p>
+            <a:pPr>
+              <a:defRPr/>
+            </a:pPr>
+            <a:r>
+              <a:rPr lang="en" sz="1400" b="0" i="0" u="none" strike="noStrike" cap="none" spc="0">
+                <a:solidFill>
+                  <a:schemeClr val="tx1"/>
+                </a:solidFill>
+                <a:latin typeface="Liberation Mono"/>
+                <a:ea typeface="Liberation Mono"/>
+                <a:cs typeface="Liberation Mono"/>
+              </a:rPr>
+              <a:t>	getAvailableVolunteersForVisitDate(visit, volunteerAvailabilitiesNextMonth);</a:t>
+            </a:r>
+            <a:endParaRPr sz="1400">
+              <a:latin typeface="Liberation Mono"/>
+              <a:cs typeface="Liberation Mono"/>
+            </a:endParaRPr>
+          </a:p>
+          <a:p>
+            <a:pPr>
+              <a:defRPr/>
+            </a:pPr>
+            <a:r>
+              <a:rPr lang="en" sz="1400" b="0" i="0" u="none" strike="noStrike" cap="none" spc="0">
+                <a:solidFill>
+                  <a:schemeClr val="tx1"/>
+                </a:solidFill>
+                <a:latin typeface="Liberation Mono"/>
+                <a:ea typeface="Liberation Mono"/>
+                <a:cs typeface="Liberation Mono"/>
+              </a:rPr>
+              <a:t>...</a:t>
+            </a:r>
+            <a:endParaRPr sz="1400">
+              <a:latin typeface="Liberation Mono"/>
+              <a:cs typeface="Liberation Mono"/>
+            </a:endParaRPr>
+          </a:p>
+          <a:p>
+            <a:pPr>
+              <a:defRPr/>
+            </a:pPr>
+            <a:endParaRPr sz="1400">
+              <a:latin typeface="Liberation Mono"/>
+              <a:cs typeface="Liberation Mono"/>
+            </a:endParaRPr>
+          </a:p>
+          <a:p>
+            <a:pPr>
+              <a:defRPr/>
+            </a:pPr>
+            <a:r>
+              <a:rPr lang="en" sz="1400" b="0" i="0" u="none" strike="noStrike" cap="none" spc="0">
+                <a:solidFill>
+                  <a:schemeClr val="tx1"/>
+                </a:solidFill>
+                <a:latin typeface="Liberation Mono"/>
+                <a:ea typeface="Liberation Mono"/>
+                <a:cs typeface="Liberation Mono"/>
+              </a:rPr>
+              <a:t>private List&lt;Integer&gt; getAvailableVolunteersForVisitDate(Visit visit, List&lt;VolunteerAvailableDate&gt; volunteerAvailabilitiesNextMonth) {</a:t>
+            </a:r>
+            <a:endParaRPr sz="1400" b="0" i="0" u="none" strike="noStrike" cap="none" spc="0">
+              <a:solidFill>
+                <a:schemeClr val="tx1"/>
+              </a:solidFill>
+              <a:latin typeface="Liberation Mono"/>
+              <a:cs typeface="Liberation Mono"/>
+            </a:endParaRPr>
+          </a:p>
+          <a:p>
+            <a:pPr>
+              <a:defRPr/>
+            </a:pPr>
+            <a:r>
+              <a:rPr lang="en" sz="1400" b="0" i="0" u="none" strike="noStrike" cap="none" spc="0">
+                <a:solidFill>
+                  <a:schemeClr val="tx1"/>
+                </a:solidFill>
+                <a:latin typeface="Liberation Mono"/>
+                <a:ea typeface="Liberation Mono"/>
+                <a:cs typeface="Liberation Mono"/>
+              </a:rPr>
+              <a:t>        return volunteerAvailabilitiesNextMonth.stream() //</a:t>
+            </a:r>
+            <a:endParaRPr sz="1400" b="0" i="0" u="none" strike="noStrike" cap="none" spc="0">
+              <a:solidFill>
+                <a:schemeClr val="tx1"/>
+              </a:solidFill>
+              <a:latin typeface="Liberation Mono"/>
+              <a:cs typeface="Liberation Mono"/>
+            </a:endParaRPr>
+          </a:p>
+          <a:p>
+            <a:pPr>
+              <a:defRPr/>
+            </a:pPr>
+            <a:r>
+              <a:rPr lang="en" sz="1400" b="0" i="0" u="none" strike="noStrike" cap="none" spc="0">
+                <a:solidFill>
+                  <a:schemeClr val="tx1"/>
+                </a:solidFill>
+                <a:latin typeface="Liberation Mono"/>
+                <a:ea typeface="Liberation Mono"/>
+                <a:cs typeface="Liberation Mono"/>
+              </a:rPr>
+              <a:t>                .filter(volunteerAvailableDate -&gt; volunteerAvailableDate.getAvailableDate().equals(visit.getDate())) //</a:t>
+            </a:r>
+            <a:endParaRPr sz="1400" b="0" i="0" u="none" strike="noStrike" cap="none" spc="0">
+              <a:solidFill>
+                <a:schemeClr val="tx1"/>
+              </a:solidFill>
+              <a:latin typeface="Liberation Mono"/>
+              <a:cs typeface="Liberation Mono"/>
+            </a:endParaRPr>
+          </a:p>
+          <a:p>
+            <a:pPr>
+              <a:defRPr/>
+            </a:pPr>
+            <a:r>
+              <a:rPr lang="en" sz="1400" b="0" i="0" u="none" strike="noStrike" cap="none" spc="0">
+                <a:solidFill>
+                  <a:schemeClr val="tx1"/>
+                </a:solidFill>
+                <a:latin typeface="Liberation Mono"/>
+                <a:ea typeface="Liberation Mono"/>
+                <a:cs typeface="Liberation Mono"/>
+              </a:rPr>
+              <a:t>                .map(VolunteerAvailableDate::getVolunteerId) //</a:t>
+            </a:r>
+            <a:endParaRPr sz="1400" b="0" i="0" u="none" strike="noStrike" cap="none" spc="0">
+              <a:solidFill>
+                <a:schemeClr val="tx1"/>
+              </a:solidFill>
+              <a:latin typeface="Liberation Mono"/>
+              <a:cs typeface="Liberation Mono"/>
+            </a:endParaRPr>
+          </a:p>
+          <a:p>
+            <a:pPr>
+              <a:defRPr/>
+            </a:pPr>
+            <a:r>
+              <a:rPr lang="en" sz="1400" b="0" i="0" u="none" strike="noStrike" cap="none" spc="0">
+                <a:solidFill>
+                  <a:schemeClr val="tx1"/>
+                </a:solidFill>
+                <a:latin typeface="Liberation Mono"/>
+                <a:ea typeface="Liberation Mono"/>
+                <a:cs typeface="Liberation Mono"/>
+              </a:rPr>
+              <a:t>                .collect(Collectors.toList());</a:t>
+            </a:r>
+            <a:endParaRPr sz="1400" b="0" i="0" u="none" strike="noStrike" cap="none" spc="0">
+              <a:solidFill>
+                <a:schemeClr val="tx1"/>
+              </a:solidFill>
+              <a:latin typeface="Liberation Mono"/>
+              <a:cs typeface="Liberation Mono"/>
+            </a:endParaRPr>
+          </a:p>
+          <a:p>
+            <a:pPr>
+              <a:defRPr/>
+            </a:pPr>
+            <a:r>
+              <a:rPr lang="en" sz="1400" b="0" i="0" u="none" strike="noStrike" cap="none" spc="0">
+                <a:solidFill>
+                  <a:schemeClr val="tx1"/>
+                </a:solidFill>
+                <a:latin typeface="Liberation Mono"/>
+                <a:ea typeface="Liberation Mono"/>
+                <a:cs typeface="Liberation Mono"/>
+              </a:rPr>
+              <a:t>    }</a:t>
+            </a:r>
+            <a:endParaRPr sz="1800"/>
+          </a:p>
+        </p:txBody>
+      </p:sp>
+      <p:sp>
+        <p:nvSpPr>
+          <p:cNvPr id="1698375116" name="CasellaDiTesto 1698375115"/>
+          <p:cNvSpPr txBox="1"/>
+          <p:nvPr/>
+        </p:nvSpPr>
+        <p:spPr bwMode="auto">
+          <a:xfrm>
+            <a:off x="9679349" y="1269043"/>
+            <a:ext cx="1995238" cy="640440"/>
           </a:xfrm>
           <a:prstGeom prst="rect">
             <a:avLst/>
@@ -12556,7 +11848,7 @@
           <a:noFill/>
         </p:spPr>
         <p:txBody>
-          <a:bodyPr vertOverflow="overflow" horzOverflow="overflow" vert="horz" wrap="square" lIns="91440" tIns="45720" rIns="91440" bIns="45720" numCol="1" spcCol="0" rtlCol="0" fromWordArt="0" anchor="t" anchorCtr="0" forceAA="0" compatLnSpc="0">
+          <a:bodyPr vertOverflow="overflow" horzOverflow="overflow" vert="horz" wrap="square" lIns="91440" tIns="45720" rIns="91440" bIns="45720" numCol="1" spcCol="0" rtlCol="0" fromWordArt="0" anchor="ctr" anchorCtr="0" forceAA="0" compatLnSpc="0">
             <a:spAutoFit/>
           </a:bodyPr>
           <a:lstStyle/>
@@ -12565,34 +11857,45 @@
               <a:defRPr/>
             </a:pPr>
             <a:r>
-              <a:rPr lang="en" sz="2400" b="1">
-                <a:solidFill>
-                  <a:srgbClr val="0070C0"/>
-                </a:solidFill>
-                <a:latin typeface="DejaVu Sans Condensed"/>
-                <a:ea typeface="DejaVu Sans Condensed"/>
-                <a:cs typeface="DejaVu Sans Condensed"/>
-              </a:rPr>
-              <a:t>Extract Method - 2 + semplificazione logica</a:t>
-            </a:r>
-            <a:endParaRPr sz="1400" b="1">
-              <a:solidFill>
-                <a:srgbClr val="0070C0"/>
-              </a:solidFill>
-            </a:endParaRPr>
-          </a:p>
-        </p:txBody>
-      </p:sp>
-      <p:sp>
-        <p:nvSpPr>
-          <p:cNvPr id="23320965" name="CasellaDiTesto 23320964"/>
+              <a:rPr lang="en" sz="3600" b="1">
+                <a:ln w="6349">
+                  <a:solidFill>
+                    <a:srgbClr val="000000"/>
+                  </a:solidFill>
+                  <a:prstDash val="solid"/>
+                </a:ln>
+                <a:solidFill>
+                  <a:schemeClr val="accent2">
+                    <a:lumMod val="75000"/>
+                  </a:schemeClr>
+                </a:solidFill>
+                <a:latin typeface="Cantarell Extra Bold"/>
+                <a:ea typeface="Cantarell Extra Bold"/>
+                <a:cs typeface="Cantarell Extra Bold"/>
+              </a:rPr>
+              <a:t>PRIMA</a:t>
+            </a:r>
+            <a:endParaRPr>
+              <a:ln w="6349">
+                <a:solidFill>
+                  <a:schemeClr val="tx1"/>
+                </a:solidFill>
+                <a:prstDash val="solid"/>
+              </a:ln>
+            </a:endParaRPr>
+          </a:p>
+        </p:txBody>
+      </p:sp>
+      <p:sp>
+        <p:nvSpPr>
+          <p:cNvPr id="1482612164" name="CasellaDiTesto 1482612163"/>
           <p:cNvSpPr txBox="1"/>
           <p:nvPr/>
         </p:nvSpPr>
         <p:spPr bwMode="auto">
           <a:xfrm>
-            <a:off x="10039335" y="1839611"/>
-            <a:ext cx="1999196" cy="640440"/>
+            <a:off x="9679349" y="3920157"/>
+            <a:ext cx="1998837" cy="640440"/>
           </a:xfrm>
           <a:prstGeom prst="rect">
             <a:avLst/>
@@ -12663,6 +11966,1086 @@
       </p:grpSpPr>
       <p:sp>
         <p:nvSpPr>
+          <p:cNvPr id="2068409532" name="Titolo 1"/>
+          <p:cNvSpPr>
+            <a:spLocks noGrp="1"/>
+          </p:cNvSpPr>
+          <p:nvPr>
+            <p:ph type="title"/>
+          </p:nvPr>
+        </p:nvSpPr>
+        <p:spPr bwMode="auto">
+          <a:xfrm>
+            <a:off x="838198" y="37802"/>
+            <a:ext cx="10515600" cy="1325562"/>
+          </a:xfrm>
+        </p:spPr>
+        <p:txBody>
+          <a:bodyPr/>
+          <a:lstStyle/>
+          <a:p>
+            <a:pPr>
+              <a:defRPr/>
+            </a:pPr>
+            <a:r>
+              <a:rPr lang="en" b="1">
+                <a:solidFill>
+                  <a:srgbClr val="0070C0"/>
+                </a:solidFill>
+                <a:latin typeface="Noto Sans"/>
+                <a:ea typeface="Noto Sans"/>
+                <a:cs typeface="Noto Sans"/>
+              </a:rPr>
+              <a:t>Refactoring</a:t>
+            </a:r>
+            <a:endParaRPr b="1">
+              <a:solidFill>
+                <a:srgbClr val="0070C0"/>
+              </a:solidFill>
+              <a:latin typeface="Noto Sans"/>
+              <a:cs typeface="Noto Sans"/>
+            </a:endParaRPr>
+          </a:p>
+        </p:txBody>
+      </p:sp>
+      <p:sp>
+        <p:nvSpPr>
+          <p:cNvPr id="17675352" name="CasellaDiTesto 17675351"/>
+          <p:cNvSpPr txBox="1"/>
+          <p:nvPr/>
+        </p:nvSpPr>
+        <p:spPr bwMode="auto">
+          <a:xfrm>
+            <a:off x="4383448" y="471802"/>
+            <a:ext cx="7416345" cy="457559"/>
+          </a:xfrm>
+          <a:prstGeom prst="rect">
+            <a:avLst/>
+          </a:prstGeom>
+          <a:noFill/>
+        </p:spPr>
+        <p:txBody>
+          <a:bodyPr vertOverflow="overflow" horzOverflow="overflow" vert="horz" wrap="square" lIns="91440" tIns="45720" rIns="91440" bIns="45720" numCol="1" spcCol="0" rtlCol="0" fromWordArt="0" anchor="t" anchorCtr="0" forceAA="0" compatLnSpc="0">
+            <a:spAutoFit/>
+          </a:bodyPr>
+          <a:lstStyle/>
+          <a:p>
+            <a:pPr algn="ctr">
+              <a:defRPr/>
+            </a:pPr>
+            <a:r>
+              <a:rPr lang="en" sz="2400" b="1">
+                <a:solidFill>
+                  <a:srgbClr val="0070C0"/>
+                </a:solidFill>
+                <a:latin typeface="DejaVu Sans Condensed"/>
+                <a:ea typeface="DejaVu Sans Condensed"/>
+                <a:cs typeface="DejaVu Sans Condensed"/>
+              </a:rPr>
+              <a:t>Extract Method - 2 + semplificazione logica</a:t>
+            </a:r>
+            <a:endParaRPr sz="1400" b="1">
+              <a:solidFill>
+                <a:srgbClr val="0070C0"/>
+              </a:solidFill>
+            </a:endParaRPr>
+          </a:p>
+        </p:txBody>
+      </p:sp>
+      <p:sp>
+        <p:nvSpPr>
+          <p:cNvPr id="1873129134" name="CasellaDiTesto 1873129133"/>
+          <p:cNvSpPr txBox="1"/>
+          <p:nvPr/>
+        </p:nvSpPr>
+        <p:spPr bwMode="auto">
+          <a:xfrm>
+            <a:off x="457913" y="1160460"/>
+            <a:ext cx="11635248" cy="4291325"/>
+          </a:xfrm>
+          <a:prstGeom prst="roundRect">
+            <a:avLst>
+              <a:gd name="adj" fmla="val 5796"/>
+            </a:avLst>
+          </a:prstGeom>
+          <a:solidFill>
+            <a:schemeClr val="bg1">
+              <a:alpha val="49999"/>
+            </a:schemeClr>
+          </a:solidFill>
+          <a:ln w="12699">
+            <a:solidFill>
+              <a:schemeClr val="tx1"/>
+            </a:solidFill>
+            <a:prstDash val="solid"/>
+          </a:ln>
+        </p:spPr>
+        <p:txBody>
+          <a:bodyPr vertOverflow="overflow" horzOverflow="overflow" vert="horz" wrap="square" lIns="91440" tIns="45720" rIns="91440" bIns="45720" numCol="1" spcCol="0" rtlCol="0" fromWordArt="0" anchor="t" anchorCtr="0" forceAA="0" compatLnSpc="0">
+            <a:spAutoFit/>
+          </a:bodyPr>
+          <a:lstStyle/>
+          <a:p>
+            <a:pPr>
+              <a:defRPr/>
+            </a:pPr>
+            <a:r>
+              <a:rPr lang="it-IT" sz="1400" b="0" i="0" u="none" strike="noStrike" cap="none" spc="0">
+                <a:solidFill>
+                  <a:schemeClr val="tx1"/>
+                </a:solidFill>
+                <a:latin typeface="Liberation Mono"/>
+                <a:ea typeface="Liberation Mono"/>
+                <a:cs typeface="Liberation Mono"/>
+              </a:rPr>
+              <a:t>if (availableVolunteers.isEmpty()) {</a:t>
+            </a:r>
+            <a:endParaRPr sz="1400" b="0" i="0" u="none" strike="noStrike" cap="none" spc="0">
+              <a:solidFill>
+                <a:schemeClr val="tx1"/>
+              </a:solidFill>
+              <a:latin typeface="Liberation Mono"/>
+              <a:cs typeface="Liberation Mono"/>
+            </a:endParaRPr>
+          </a:p>
+          <a:p>
+            <a:pPr>
+              <a:defRPr/>
+            </a:pPr>
+            <a:r>
+              <a:rPr lang="it-IT" sz="1400" b="0" i="0" u="none" strike="noStrike" cap="none" spc="0">
+                <a:solidFill>
+                  <a:schemeClr val="tx1"/>
+                </a:solidFill>
+                <a:latin typeface="Liberation Mono"/>
+                <a:ea typeface="Liberation Mono"/>
+                <a:cs typeface="Liberation Mono"/>
+              </a:rPr>
+              <a:t>                visit.setVisitStatus(VisitStatus.CANCELLED);</a:t>
+            </a:r>
+            <a:endParaRPr sz="1400" b="0" i="0" u="none" strike="noStrike" cap="none" spc="0">
+              <a:solidFill>
+                <a:schemeClr val="tx1"/>
+              </a:solidFill>
+              <a:latin typeface="Liberation Mono"/>
+              <a:cs typeface="Liberation Mono"/>
+            </a:endParaRPr>
+          </a:p>
+          <a:p>
+            <a:pPr>
+              <a:defRPr/>
+            </a:pPr>
+            <a:r>
+              <a:rPr lang="it-IT" sz="1400" b="0" i="0" u="none" strike="noStrike" cap="none" spc="0">
+                <a:solidFill>
+                  <a:schemeClr val="tx1"/>
+                </a:solidFill>
+                <a:latin typeface="Liberation Mono"/>
+                <a:ea typeface="Liberation Mono"/>
+                <a:cs typeface="Liberation Mono"/>
+              </a:rPr>
+              <a:t>                visitRepository.save(visit);</a:t>
+            </a:r>
+            <a:endParaRPr sz="1400" b="0" i="0" u="none" strike="noStrike" cap="none" spc="0">
+              <a:solidFill>
+                <a:schemeClr val="tx1"/>
+              </a:solidFill>
+              <a:latin typeface="Liberation Mono"/>
+              <a:cs typeface="Liberation Mono"/>
+            </a:endParaRPr>
+          </a:p>
+          <a:p>
+            <a:pPr>
+              <a:defRPr/>
+            </a:pPr>
+            <a:r>
+              <a:rPr lang="it-IT" sz="1400" b="0" i="0" u="none" strike="noStrike" cap="none" spc="0">
+                <a:solidFill>
+                  <a:schemeClr val="tx1"/>
+                </a:solidFill>
+                <a:latin typeface="Liberation Mono"/>
+                <a:ea typeface="Liberation Mono"/>
+                <a:cs typeface="Liberation Mono"/>
+              </a:rPr>
+              <a:t>                continue; // passa alla visita successiva</a:t>
+            </a:r>
+            <a:endParaRPr sz="1400" b="0" i="0" u="none" strike="noStrike" cap="none" spc="0">
+              <a:solidFill>
+                <a:schemeClr val="tx1"/>
+              </a:solidFill>
+              <a:latin typeface="Liberation Mono"/>
+              <a:cs typeface="Liberation Mono"/>
+            </a:endParaRPr>
+          </a:p>
+          <a:p>
+            <a:pPr>
+              <a:defRPr/>
+            </a:pPr>
+            <a:r>
+              <a:rPr lang="it-IT" sz="1400" b="0" i="0" u="none" strike="noStrike" cap="none" spc="0">
+                <a:solidFill>
+                  <a:schemeClr val="tx1"/>
+                </a:solidFill>
+                <a:latin typeface="Liberation Mono"/>
+                <a:ea typeface="Liberation Mono"/>
+                <a:cs typeface="Liberation Mono"/>
+              </a:rPr>
+              <a:t>            } else if (availableVolunteers.size() == 1) {</a:t>
+            </a:r>
+            <a:endParaRPr sz="1400" b="0" i="0" u="none" strike="noStrike" cap="none" spc="0">
+              <a:solidFill>
+                <a:schemeClr val="tx1"/>
+              </a:solidFill>
+              <a:latin typeface="Liberation Mono"/>
+              <a:cs typeface="Liberation Mono"/>
+            </a:endParaRPr>
+          </a:p>
+          <a:p>
+            <a:pPr>
+              <a:defRPr/>
+            </a:pPr>
+            <a:r>
+              <a:rPr lang="it-IT" sz="1400" b="0" i="0" u="none" strike="noStrike" cap="none" spc="0">
+                <a:solidFill>
+                  <a:schemeClr val="tx1"/>
+                </a:solidFill>
+                <a:latin typeface="Liberation Mono"/>
+                <a:ea typeface="Liberation Mono"/>
+                <a:cs typeface="Liberation Mono"/>
+              </a:rPr>
+              <a:t>                User volunteer = availableVolunteers.getFirst();</a:t>
+            </a:r>
+            <a:endParaRPr sz="1400" b="0" i="0" u="none" strike="noStrike" cap="none" spc="0">
+              <a:solidFill>
+                <a:schemeClr val="tx1"/>
+              </a:solidFill>
+              <a:latin typeface="Liberation Mono"/>
+              <a:cs typeface="Liberation Mono"/>
+            </a:endParaRPr>
+          </a:p>
+          <a:p>
+            <a:pPr>
+              <a:defRPr/>
+            </a:pPr>
+            <a:r>
+              <a:rPr lang="it-IT" sz="1400" b="0" i="0" u="none" strike="noStrike" cap="none" spc="0">
+                <a:solidFill>
+                  <a:schemeClr val="tx1"/>
+                </a:solidFill>
+                <a:latin typeface="Liberation Mono"/>
+                <a:ea typeface="Liberation Mono"/>
+                <a:cs typeface="Liberation Mono"/>
+              </a:rPr>
+              <a:t>                if (canDoVisitType(volunteer, visit.getVisitType().getId()))</a:t>
+            </a:r>
+            <a:endParaRPr sz="1400" b="0" i="0" u="none" strike="noStrike" cap="none" spc="0">
+              <a:solidFill>
+                <a:schemeClr val="tx1"/>
+              </a:solidFill>
+              <a:latin typeface="Liberation Mono"/>
+              <a:cs typeface="Liberation Mono"/>
+            </a:endParaRPr>
+          </a:p>
+          <a:p>
+            <a:pPr>
+              <a:defRPr/>
+            </a:pPr>
+            <a:r>
+              <a:rPr lang="it-IT" sz="1400" b="0" i="0" u="none" strike="noStrike" cap="none" spc="0">
+                <a:solidFill>
+                  <a:schemeClr val="tx1"/>
+                </a:solidFill>
+                <a:latin typeface="Liberation Mono"/>
+                <a:ea typeface="Liberation Mono"/>
+                <a:cs typeface="Liberation Mono"/>
+              </a:rPr>
+              <a:t>                    assignVolunteerToVisit(volunteer, visit, monthAvailabilities, volunteerVisitCounts);</a:t>
+            </a:r>
+            <a:endParaRPr sz="1400" b="0" i="0" u="none" strike="noStrike" cap="none" spc="0">
+              <a:solidFill>
+                <a:schemeClr val="tx1"/>
+              </a:solidFill>
+              <a:latin typeface="Liberation Mono"/>
+              <a:cs typeface="Liberation Mono"/>
+            </a:endParaRPr>
+          </a:p>
+          <a:p>
+            <a:pPr>
+              <a:defRPr/>
+            </a:pPr>
+            <a:r>
+              <a:rPr lang="it-IT" sz="1400" b="0" i="0" u="none" strike="noStrike" cap="none" spc="0">
+                <a:solidFill>
+                  <a:schemeClr val="tx1"/>
+                </a:solidFill>
+                <a:latin typeface="Liberation Mono"/>
+                <a:ea typeface="Liberation Mono"/>
+                <a:cs typeface="Liberation Mono"/>
+              </a:rPr>
+              <a:t>                else {</a:t>
+            </a:r>
+            <a:endParaRPr sz="1400" b="0" i="0" u="none" strike="noStrike" cap="none" spc="0">
+              <a:solidFill>
+                <a:schemeClr val="tx1"/>
+              </a:solidFill>
+              <a:latin typeface="Liberation Mono"/>
+              <a:cs typeface="Liberation Mono"/>
+            </a:endParaRPr>
+          </a:p>
+          <a:p>
+            <a:pPr>
+              <a:defRPr/>
+            </a:pPr>
+            <a:r>
+              <a:rPr lang="it-IT" sz="1400" b="0" i="0" u="none" strike="noStrike" cap="none" spc="0">
+                <a:solidFill>
+                  <a:schemeClr val="tx1"/>
+                </a:solidFill>
+                <a:latin typeface="Liberation Mono"/>
+                <a:ea typeface="Liberation Mono"/>
+                <a:cs typeface="Liberation Mono"/>
+              </a:rPr>
+              <a:t>                    visit.setVisitStatus(VisitStatus.CANCELLED);</a:t>
+            </a:r>
+            <a:endParaRPr sz="1400" b="0" i="0" u="none" strike="noStrike" cap="none" spc="0">
+              <a:solidFill>
+                <a:schemeClr val="tx1"/>
+              </a:solidFill>
+              <a:latin typeface="Liberation Mono"/>
+              <a:cs typeface="Liberation Mono"/>
+            </a:endParaRPr>
+          </a:p>
+          <a:p>
+            <a:pPr>
+              <a:defRPr/>
+            </a:pPr>
+            <a:r>
+              <a:rPr lang="it-IT" sz="1400" b="0" i="0" u="none" strike="noStrike" cap="none" spc="0">
+                <a:solidFill>
+                  <a:schemeClr val="tx1"/>
+                </a:solidFill>
+                <a:latin typeface="Liberation Mono"/>
+                <a:ea typeface="Liberation Mono"/>
+                <a:cs typeface="Liberation Mono"/>
+              </a:rPr>
+              <a:t>                    visitRepository.save(visit);</a:t>
+            </a:r>
+            <a:endParaRPr sz="1400" b="0" i="0" u="none" strike="noStrike" cap="none" spc="0">
+              <a:solidFill>
+                <a:schemeClr val="tx1"/>
+              </a:solidFill>
+              <a:latin typeface="Liberation Mono"/>
+              <a:cs typeface="Liberation Mono"/>
+            </a:endParaRPr>
+          </a:p>
+          <a:p>
+            <a:pPr>
+              <a:defRPr/>
+            </a:pPr>
+            <a:r>
+              <a:rPr lang="it-IT" sz="1400" b="0" i="0" u="none" strike="noStrike" cap="none" spc="0">
+                <a:solidFill>
+                  <a:schemeClr val="tx1"/>
+                </a:solidFill>
+                <a:latin typeface="Liberation Mono"/>
+                <a:ea typeface="Liberation Mono"/>
+                <a:cs typeface="Liberation Mono"/>
+              </a:rPr>
+              <a:t>                }</a:t>
+            </a:r>
+            <a:endParaRPr sz="1400" b="0" i="0" u="none" strike="noStrike" cap="none" spc="0">
+              <a:solidFill>
+                <a:schemeClr val="tx1"/>
+              </a:solidFill>
+              <a:latin typeface="Liberation Mono"/>
+              <a:cs typeface="Liberation Mono"/>
+            </a:endParaRPr>
+          </a:p>
+          <a:p>
+            <a:pPr>
+              <a:defRPr/>
+            </a:pPr>
+            <a:r>
+              <a:rPr lang="it-IT" sz="1400" b="0" i="0" u="none" strike="noStrike" cap="none" spc="0">
+                <a:solidFill>
+                  <a:schemeClr val="tx1"/>
+                </a:solidFill>
+                <a:latin typeface="Liberation Mono"/>
+                <a:ea typeface="Liberation Mono"/>
+                <a:cs typeface="Liberation Mono"/>
+              </a:rPr>
+              <a:t>                continue; // passa alla visita successiva</a:t>
+            </a:r>
+            <a:endParaRPr sz="1400" b="0" i="0" u="none" strike="noStrike" cap="none" spc="0">
+              <a:solidFill>
+                <a:schemeClr val="tx1"/>
+              </a:solidFill>
+              <a:latin typeface="Liberation Mono"/>
+              <a:cs typeface="Liberation Mono"/>
+            </a:endParaRPr>
+          </a:p>
+          <a:p>
+            <a:pPr>
+              <a:defRPr/>
+            </a:pPr>
+            <a:r>
+              <a:rPr lang="it-IT" sz="1400" b="0" i="0" u="none" strike="noStrike" cap="none" spc="0">
+                <a:solidFill>
+                  <a:schemeClr val="tx1"/>
+                </a:solidFill>
+                <a:latin typeface="Liberation Mono"/>
+                <a:ea typeface="Liberation Mono"/>
+                <a:cs typeface="Liberation Mono"/>
+              </a:rPr>
+              <a:t>            }</a:t>
+            </a:r>
+            <a:endParaRPr sz="1400" b="0" i="0" u="none" strike="noStrike" cap="none" spc="0">
+              <a:solidFill>
+                <a:schemeClr val="tx1"/>
+              </a:solidFill>
+              <a:latin typeface="Liberation Mono"/>
+              <a:cs typeface="Liberation Mono"/>
+            </a:endParaRPr>
+          </a:p>
+          <a:p>
+            <a:pPr>
+              <a:defRPr/>
+            </a:pPr>
+            <a:r>
+              <a:rPr lang="it-IT" sz="1400" b="0" i="0" u="none" strike="noStrike" cap="none" spc="0">
+                <a:solidFill>
+                  <a:schemeClr val="tx1"/>
+                </a:solidFill>
+                <a:latin typeface="Liberation Mono"/>
+                <a:ea typeface="Liberation Mono"/>
+                <a:cs typeface="Liberation Mono"/>
+              </a:rPr>
+              <a:t>            // piú di 2 volontari con disponibilitá nel giorno considerato</a:t>
+            </a:r>
+            <a:endParaRPr sz="1400" b="0" i="0" u="none" strike="noStrike" cap="none" spc="0">
+              <a:solidFill>
+                <a:schemeClr val="tx1"/>
+              </a:solidFill>
+              <a:latin typeface="Liberation Mono"/>
+              <a:cs typeface="Liberation Mono"/>
+            </a:endParaRPr>
+          </a:p>
+          <a:p>
+            <a:pPr>
+              <a:defRPr/>
+            </a:pPr>
+            <a:r>
+              <a:rPr lang="it-IT" sz="1400" b="0" i="0" u="none" strike="noStrike" cap="none" spc="0">
+                <a:solidFill>
+                  <a:schemeClr val="tx1"/>
+                </a:solidFill>
+                <a:latin typeface="Liberation Mono"/>
+                <a:ea typeface="Liberation Mono"/>
+                <a:cs typeface="Liberation Mono"/>
+              </a:rPr>
+              <a:t>            User bestVolunteer = selectBestVolunteer(availableVolunteers, volunteerVisitCounts);</a:t>
+            </a:r>
+            <a:endParaRPr sz="1400" b="0" i="0" u="none" strike="noStrike" cap="none" spc="0">
+              <a:solidFill>
+                <a:schemeClr val="tx1"/>
+              </a:solidFill>
+              <a:latin typeface="Liberation Mono"/>
+              <a:cs typeface="Liberation Mono"/>
+            </a:endParaRPr>
+          </a:p>
+          <a:p>
+            <a:pPr>
+              <a:defRPr/>
+            </a:pPr>
+            <a:r>
+              <a:rPr lang="it-IT" sz="1400" b="0" i="0" u="none" strike="noStrike" cap="none" spc="0">
+                <a:solidFill>
+                  <a:schemeClr val="tx1"/>
+                </a:solidFill>
+                <a:latin typeface="Liberation Mono"/>
+                <a:ea typeface="Liberation Mono"/>
+                <a:cs typeface="Liberation Mono"/>
+              </a:rPr>
+              <a:t>            assignVolunteerToVisit(bestVolunteer, visit, monthAvailabilities, volunteerVisitCounts);</a:t>
+            </a:r>
+            <a:endParaRPr sz="1400" b="0" i="0" u="none" strike="noStrike" cap="none" spc="0">
+              <a:solidFill>
+                <a:schemeClr val="tx1"/>
+              </a:solidFill>
+              <a:latin typeface="Liberation Mono"/>
+              <a:cs typeface="Liberation Mono"/>
+            </a:endParaRPr>
+          </a:p>
+          <a:p>
+            <a:pPr>
+              <a:defRPr/>
+            </a:pPr>
+            <a:r>
+              <a:rPr lang="it-IT" sz="1400" b="0" i="0" u="none" strike="noStrike" cap="none" spc="0">
+                <a:solidFill>
+                  <a:schemeClr val="tx1"/>
+                </a:solidFill>
+                <a:latin typeface="Liberation Mono"/>
+                <a:ea typeface="Liberation Mono"/>
+                <a:cs typeface="Liberation Mono"/>
+              </a:rPr>
+              <a:t>        }</a:t>
+            </a:r>
+          </a:p>
+          <a:p>
+            <a:pPr>
+              <a:defRPr/>
+            </a:pPr>
+            <a:r>
+              <a:rPr lang="en" sz="1400" b="0" i="0" u="none" strike="noStrike" cap="none" spc="0">
+                <a:solidFill>
+                  <a:schemeClr val="tx1"/>
+                </a:solidFill>
+                <a:latin typeface="Liberation Mono"/>
+                <a:ea typeface="Liberation Mono"/>
+                <a:cs typeface="Liberation Mono"/>
+              </a:rPr>
+              <a:t>...</a:t>
+            </a:r>
+            <a:endParaRPr/>
+          </a:p>
+        </p:txBody>
+      </p:sp>
+      <p:sp>
+        <p:nvSpPr>
+          <p:cNvPr id="1625665772" name="CasellaDiTesto 1625665771"/>
+          <p:cNvSpPr txBox="1"/>
+          <p:nvPr/>
+        </p:nvSpPr>
+        <p:spPr bwMode="auto">
+          <a:xfrm>
+            <a:off x="9679349" y="1269223"/>
+            <a:ext cx="1995597" cy="640440"/>
+          </a:xfrm>
+          <a:prstGeom prst="rect">
+            <a:avLst/>
+          </a:prstGeom>
+          <a:noFill/>
+        </p:spPr>
+        <p:txBody>
+          <a:bodyPr vertOverflow="overflow" horzOverflow="overflow" vert="horz" wrap="square" lIns="91440" tIns="45720" rIns="91440" bIns="45720" numCol="1" spcCol="0" rtlCol="0" fromWordArt="0" anchor="ctr" anchorCtr="0" forceAA="0" compatLnSpc="0">
+            <a:spAutoFit/>
+          </a:bodyPr>
+          <a:lstStyle/>
+          <a:p>
+            <a:pPr algn="ctr">
+              <a:defRPr/>
+            </a:pPr>
+            <a:r>
+              <a:rPr lang="en" sz="3600" b="1">
+                <a:ln w="6349">
+                  <a:solidFill>
+                    <a:srgbClr val="000000"/>
+                  </a:solidFill>
+                  <a:prstDash val="solid"/>
+                </a:ln>
+                <a:solidFill>
+                  <a:schemeClr val="accent2">
+                    <a:lumMod val="75000"/>
+                  </a:schemeClr>
+                </a:solidFill>
+                <a:latin typeface="Cantarell Extra Bold"/>
+                <a:ea typeface="Cantarell Extra Bold"/>
+                <a:cs typeface="Cantarell Extra Bold"/>
+              </a:rPr>
+              <a:t>PRIMA</a:t>
+            </a:r>
+            <a:endParaRPr>
+              <a:ln w="6349">
+                <a:solidFill>
+                  <a:schemeClr val="tx1"/>
+                </a:solidFill>
+                <a:prstDash val="solid"/>
+              </a:ln>
+            </a:endParaRPr>
+          </a:p>
+        </p:txBody>
+      </p:sp>
+    </p:spTree>
+  </p:cSld>
+  <p:clrMapOvr>
+    <a:masterClrMapping/>
+  </p:clrMapOvr>
+</p:sld>
+</file>
+
+<file path=ppt/slides/slide27.xml><?xml version="1.0" encoding="utf-8"?>
+<p:sld xmlns:a="http://schemas.openxmlformats.org/drawingml/2006/main" xmlns:r="http://schemas.openxmlformats.org/officeDocument/2006/relationships" xmlns:p="http://schemas.openxmlformats.org/presentationml/2006/main" showMasterPhAnim="0">
+  <p:cSld>
+    <p:spTree>
+      <p:nvGrpSpPr>
+        <p:cNvPr id="1" name=""/>
+        <p:cNvGrpSpPr/>
+        <p:nvPr/>
+      </p:nvGrpSpPr>
+      <p:grpSpPr bwMode="auto">
+        <a:xfrm>
+          <a:off x="0" y="0"/>
+          <a:ext cx="0" cy="0"/>
+          <a:chOff x="0" y="0"/>
+          <a:chExt cx="0" cy="0"/>
+        </a:xfrm>
+      </p:grpSpPr>
+      <p:sp>
+        <p:nvSpPr>
+          <p:cNvPr id="449234049" name="Titolo 1"/>
+          <p:cNvSpPr>
+            <a:spLocks noGrp="1"/>
+          </p:cNvSpPr>
+          <p:nvPr>
+            <p:ph type="title"/>
+          </p:nvPr>
+        </p:nvSpPr>
+        <p:spPr bwMode="auto">
+          <a:xfrm>
+            <a:off x="838198" y="37801"/>
+            <a:ext cx="10515600" cy="1325561"/>
+          </a:xfrm>
+        </p:spPr>
+        <p:txBody>
+          <a:bodyPr/>
+          <a:lstStyle/>
+          <a:p>
+            <a:pPr>
+              <a:defRPr/>
+            </a:pPr>
+            <a:r>
+              <a:rPr lang="en" b="1">
+                <a:solidFill>
+                  <a:srgbClr val="0070C0"/>
+                </a:solidFill>
+                <a:latin typeface="Noto Sans"/>
+                <a:ea typeface="Noto Sans"/>
+                <a:cs typeface="Noto Sans"/>
+              </a:rPr>
+              <a:t>Refactoring</a:t>
+            </a:r>
+            <a:endParaRPr/>
+          </a:p>
+        </p:txBody>
+      </p:sp>
+      <p:sp>
+        <p:nvSpPr>
+          <p:cNvPr id="1225781845" name="CasellaDiTesto 1225781844"/>
+          <p:cNvSpPr txBox="1"/>
+          <p:nvPr/>
+        </p:nvSpPr>
+        <p:spPr bwMode="auto">
+          <a:xfrm>
+            <a:off x="457913" y="1160460"/>
+            <a:ext cx="11637768" cy="3407891"/>
+          </a:xfrm>
+          <a:prstGeom prst="roundRect">
+            <a:avLst>
+              <a:gd name="adj" fmla="val 5796"/>
+            </a:avLst>
+          </a:prstGeom>
+          <a:solidFill>
+            <a:schemeClr val="bg1">
+              <a:alpha val="49999"/>
+            </a:schemeClr>
+          </a:solidFill>
+          <a:ln w="12699">
+            <a:solidFill>
+              <a:schemeClr val="tx1"/>
+            </a:solidFill>
+            <a:prstDash val="solid"/>
+          </a:ln>
+        </p:spPr>
+        <p:txBody>
+          <a:bodyPr vertOverflow="overflow" horzOverflow="overflow" vert="horz" wrap="square" lIns="91440" tIns="45720" rIns="91440" bIns="45720" numCol="1" spcCol="0" rtlCol="0" fromWordArt="0" anchor="t" anchorCtr="0" forceAA="0" compatLnSpc="0">
+            <a:spAutoFit/>
+          </a:bodyPr>
+          <a:lstStyle/>
+          <a:p>
+            <a:pPr>
+              <a:defRPr/>
+            </a:pPr>
+            <a:r>
+              <a:rPr lang="it-IT" sz="1400" b="0" i="0" u="none" strike="noStrike" cap="none" spc="0">
+                <a:solidFill>
+                  <a:schemeClr val="tx1"/>
+                </a:solidFill>
+                <a:latin typeface="Liberation Mono"/>
+                <a:ea typeface="Liberation Mono"/>
+                <a:cs typeface="Liberation Mono"/>
+              </a:rPr>
+              <a:t>for (Visit visit : nextMonthSortedVisits) {</a:t>
+            </a:r>
+          </a:p>
+          <a:p>
+            <a:pPr>
+              <a:defRPr/>
+            </a:pPr>
+            <a:r>
+              <a:rPr lang="it-IT" sz="1400" b="0" i="0" u="none" strike="noStrike" cap="none" spc="0">
+                <a:solidFill>
+                  <a:schemeClr val="tx1"/>
+                </a:solidFill>
+                <a:latin typeface="Liberation Mono"/>
+                <a:ea typeface="Liberation Mono"/>
+                <a:cs typeface="Liberation Mono"/>
+              </a:rPr>
+              <a:t>            List&lt;Integer&gt; availableVolunteerIds = getAvailableVolunteersForVisitDate(visit, volunteerAvailabilitiesNextMonth);</a:t>
+            </a:r>
+            <a:endParaRPr sz="1400" b="0" i="0" u="none" strike="noStrike" cap="none" spc="0">
+              <a:solidFill>
+                <a:schemeClr val="tx1"/>
+              </a:solidFill>
+              <a:latin typeface="Liberation Mono"/>
+              <a:cs typeface="Liberation Mono"/>
+            </a:endParaRPr>
+          </a:p>
+          <a:p>
+            <a:pPr>
+              <a:defRPr/>
+            </a:pPr>
+            <a:endParaRPr sz="1400" b="0" i="0" u="none" strike="noStrike" cap="none" spc="0">
+              <a:solidFill>
+                <a:schemeClr val="tx1"/>
+              </a:solidFill>
+              <a:latin typeface="Liberation Mono"/>
+              <a:cs typeface="Liberation Mono"/>
+            </a:endParaRPr>
+          </a:p>
+          <a:p>
+            <a:pPr>
+              <a:defRPr/>
+            </a:pPr>
+            <a:r>
+              <a:rPr lang="it-IT" sz="1400" b="0" i="0" u="none" strike="noStrike" cap="none" spc="0">
+                <a:solidFill>
+                  <a:schemeClr val="tx1"/>
+                </a:solidFill>
+                <a:latin typeface="Liberation Mono"/>
+                <a:ea typeface="Liberation Mono"/>
+                <a:cs typeface="Liberation Mono"/>
+              </a:rPr>
+              <a:t>            if (availableVolunteerIds.isEmpty()) {</a:t>
+            </a:r>
+            <a:endParaRPr sz="1400" b="0" i="0" u="none" strike="noStrike" cap="none" spc="0">
+              <a:solidFill>
+                <a:schemeClr val="tx1"/>
+              </a:solidFill>
+              <a:latin typeface="Liberation Mono"/>
+              <a:cs typeface="Liberation Mono"/>
+            </a:endParaRPr>
+          </a:p>
+          <a:p>
+            <a:pPr>
+              <a:defRPr/>
+            </a:pPr>
+            <a:r>
+              <a:rPr lang="it-IT" sz="1400" b="0" i="0" u="none" strike="noStrike" cap="none" spc="0">
+                <a:solidFill>
+                  <a:schemeClr val="tx1"/>
+                </a:solidFill>
+                <a:latin typeface="Liberation Mono"/>
+                <a:ea typeface="Liberation Mono"/>
+                <a:cs typeface="Liberation Mono"/>
+              </a:rPr>
+              <a:t>                setVisitStatusToCancelled(visit);</a:t>
+            </a:r>
+            <a:endParaRPr sz="1400" b="0" i="0" u="none" strike="noStrike" cap="none" spc="0">
+              <a:solidFill>
+                <a:schemeClr val="tx1"/>
+              </a:solidFill>
+              <a:latin typeface="Liberation Mono"/>
+              <a:cs typeface="Liberation Mono"/>
+            </a:endParaRPr>
+          </a:p>
+          <a:p>
+            <a:pPr>
+              <a:defRPr/>
+            </a:pPr>
+            <a:r>
+              <a:rPr lang="it-IT" sz="1400" b="0" i="0" u="none" strike="noStrike" cap="none" spc="0">
+                <a:solidFill>
+                  <a:schemeClr val="tx1"/>
+                </a:solidFill>
+                <a:latin typeface="Liberation Mono"/>
+                <a:ea typeface="Liberation Mono"/>
+                <a:cs typeface="Liberation Mono"/>
+              </a:rPr>
+              <a:t>            } else if (availableVolunteerIds.size() == 1) {</a:t>
+            </a:r>
+            <a:endParaRPr sz="1400" b="0" i="0" u="none" strike="noStrike" cap="none" spc="0">
+              <a:solidFill>
+                <a:schemeClr val="tx1"/>
+              </a:solidFill>
+              <a:latin typeface="Liberation Mono"/>
+              <a:cs typeface="Liberation Mono"/>
+            </a:endParaRPr>
+          </a:p>
+          <a:p>
+            <a:pPr>
+              <a:defRPr/>
+            </a:pPr>
+            <a:r>
+              <a:rPr lang="it-IT" sz="1400" b="0" i="0" u="none" strike="noStrike" cap="none" spc="0">
+                <a:solidFill>
+                  <a:schemeClr val="tx1"/>
+                </a:solidFill>
+                <a:latin typeface="Liberation Mono"/>
+                <a:ea typeface="Liberation Mono"/>
+                <a:cs typeface="Liberation Mono"/>
+              </a:rPr>
+              <a:t>                assignAvailableVolunteerToVisitIfPossible(visit, availableVolunteerIds, volunteerAvailabilitiesNextMonth, volunteerIdWithVisitCounts);</a:t>
+            </a:r>
+            <a:endParaRPr sz="1400" b="0" i="0" u="none" strike="noStrike" cap="none" spc="0">
+              <a:solidFill>
+                <a:schemeClr val="tx1"/>
+              </a:solidFill>
+              <a:latin typeface="Liberation Mono"/>
+              <a:cs typeface="Liberation Mono"/>
+            </a:endParaRPr>
+          </a:p>
+          <a:p>
+            <a:pPr>
+              <a:defRPr/>
+            </a:pPr>
+            <a:r>
+              <a:rPr lang="it-IT" sz="1400" b="0" i="0" u="none" strike="noStrike" cap="none" spc="0">
+                <a:solidFill>
+                  <a:schemeClr val="tx1"/>
+                </a:solidFill>
+                <a:latin typeface="Liberation Mono"/>
+                <a:ea typeface="Liberation Mono"/>
+                <a:cs typeface="Liberation Mono"/>
+              </a:rPr>
+              <a:t>            } else {</a:t>
+            </a:r>
+            <a:endParaRPr sz="1400" b="0" i="0" u="none" strike="noStrike" cap="none" spc="0">
+              <a:solidFill>
+                <a:schemeClr val="tx1"/>
+              </a:solidFill>
+              <a:latin typeface="Liberation Mono"/>
+              <a:cs typeface="Liberation Mono"/>
+            </a:endParaRPr>
+          </a:p>
+          <a:p>
+            <a:pPr>
+              <a:defRPr/>
+            </a:pPr>
+            <a:r>
+              <a:rPr lang="it-IT" sz="1400" b="0" i="0" u="none" strike="noStrike" cap="none" spc="0">
+                <a:solidFill>
+                  <a:schemeClr val="tx1"/>
+                </a:solidFill>
+                <a:latin typeface="Liberation Mono"/>
+                <a:ea typeface="Liberation Mono"/>
+                <a:cs typeface="Liberation Mono"/>
+              </a:rPr>
+              <a:t>                assignBestVolunteerAvailableToVisit(visit, availableVolunteerIds, volunteerIdWithVisitCounts, volunteerAvailabilitiesNextMonth);</a:t>
+            </a:r>
+            <a:endParaRPr sz="1400" b="0" i="0" u="none" strike="noStrike" cap="none" spc="0">
+              <a:solidFill>
+                <a:schemeClr val="tx1"/>
+              </a:solidFill>
+              <a:latin typeface="Liberation Mono"/>
+              <a:cs typeface="Liberation Mono"/>
+            </a:endParaRPr>
+          </a:p>
+          <a:p>
+            <a:pPr>
+              <a:defRPr/>
+            </a:pPr>
+            <a:r>
+              <a:rPr lang="it-IT" sz="1400" b="0" i="0" u="none" strike="noStrike" cap="none" spc="0">
+                <a:solidFill>
+                  <a:schemeClr val="tx1"/>
+                </a:solidFill>
+                <a:latin typeface="Liberation Mono"/>
+                <a:ea typeface="Liberation Mono"/>
+                <a:cs typeface="Liberation Mono"/>
+              </a:rPr>
+              <a:t>            }</a:t>
+            </a:r>
+            <a:endParaRPr sz="1400" b="0" i="0" u="none" strike="noStrike" cap="none" spc="0">
+              <a:solidFill>
+                <a:schemeClr val="tx1"/>
+              </a:solidFill>
+              <a:latin typeface="Liberation Mono"/>
+              <a:cs typeface="Liberation Mono"/>
+            </a:endParaRPr>
+          </a:p>
+          <a:p>
+            <a:pPr>
+              <a:defRPr/>
+            </a:pPr>
+            <a:r>
+              <a:rPr lang="it-IT" sz="1400" b="0" i="0" u="none" strike="noStrike" cap="none" spc="0">
+                <a:solidFill>
+                  <a:schemeClr val="tx1"/>
+                </a:solidFill>
+                <a:latin typeface="Liberation Mono"/>
+                <a:ea typeface="Liberation Mono"/>
+                <a:cs typeface="Liberation Mono"/>
+              </a:rPr>
+              <a:t>        }</a:t>
+            </a:r>
+            <a:endParaRPr sz="1400" b="0" i="0" u="none" strike="noStrike" cap="none" spc="0">
+              <a:solidFill>
+                <a:schemeClr val="tx1"/>
+              </a:solidFill>
+              <a:latin typeface="Liberation Mono"/>
+              <a:cs typeface="Liberation Mono"/>
+            </a:endParaRPr>
+          </a:p>
+          <a:p>
+            <a:pPr>
+              <a:defRPr/>
+            </a:pPr>
+            <a:r>
+              <a:rPr lang="en" sz="1400" b="0" i="0" u="none" strike="noStrike" cap="none" spc="0">
+                <a:solidFill>
+                  <a:schemeClr val="tx1"/>
+                </a:solidFill>
+                <a:latin typeface="Liberation Mono"/>
+                <a:ea typeface="Liberation Mono"/>
+                <a:cs typeface="Liberation Mono"/>
+              </a:rPr>
+              <a:t>...</a:t>
+            </a:r>
+            <a:endParaRPr sz="1400" b="0" i="0" u="none" strike="noStrike" cap="none" spc="0">
+              <a:solidFill>
+                <a:schemeClr val="tx1"/>
+              </a:solidFill>
+              <a:latin typeface="Liberation Mono"/>
+              <a:cs typeface="Liberation Mono"/>
+            </a:endParaRPr>
+          </a:p>
+        </p:txBody>
+      </p:sp>
+      <p:sp>
+        <p:nvSpPr>
+          <p:cNvPr id="1711987548" name="CasellaDiTesto 1711987547"/>
+          <p:cNvSpPr txBox="1"/>
+          <p:nvPr/>
+        </p:nvSpPr>
+        <p:spPr bwMode="auto">
+          <a:xfrm>
+            <a:off x="4383448" y="471802"/>
+            <a:ext cx="7416703" cy="457559"/>
+          </a:xfrm>
+          <a:prstGeom prst="rect">
+            <a:avLst/>
+          </a:prstGeom>
+          <a:noFill/>
+        </p:spPr>
+        <p:txBody>
+          <a:bodyPr vertOverflow="overflow" horzOverflow="overflow" vert="horz" wrap="square" lIns="91440" tIns="45720" rIns="91440" bIns="45720" numCol="1" spcCol="0" rtlCol="0" fromWordArt="0" anchor="t" anchorCtr="0" forceAA="0" compatLnSpc="0">
+            <a:spAutoFit/>
+          </a:bodyPr>
+          <a:lstStyle/>
+          <a:p>
+            <a:pPr algn="ctr">
+              <a:defRPr/>
+            </a:pPr>
+            <a:r>
+              <a:rPr lang="en" sz="2400" b="1">
+                <a:solidFill>
+                  <a:srgbClr val="0070C0"/>
+                </a:solidFill>
+                <a:latin typeface="DejaVu Sans Condensed"/>
+                <a:ea typeface="DejaVu Sans Condensed"/>
+                <a:cs typeface="DejaVu Sans Condensed"/>
+              </a:rPr>
+              <a:t>Extract Method - 2 + semplificazione logica</a:t>
+            </a:r>
+            <a:endParaRPr sz="1400" b="1">
+              <a:solidFill>
+                <a:srgbClr val="0070C0"/>
+              </a:solidFill>
+            </a:endParaRPr>
+          </a:p>
+        </p:txBody>
+      </p:sp>
+      <p:sp>
+        <p:nvSpPr>
+          <p:cNvPr id="23320965" name="CasellaDiTesto 23320964"/>
+          <p:cNvSpPr txBox="1"/>
+          <p:nvPr/>
+        </p:nvSpPr>
+        <p:spPr bwMode="auto">
+          <a:xfrm>
+            <a:off x="10039335" y="1839611"/>
+            <a:ext cx="1999196" cy="640440"/>
+          </a:xfrm>
+          <a:prstGeom prst="rect">
+            <a:avLst/>
+          </a:prstGeom>
+          <a:noFill/>
+        </p:spPr>
+        <p:txBody>
+          <a:bodyPr vertOverflow="overflow" horzOverflow="overflow" vert="horz" wrap="square" lIns="91440" tIns="45720" rIns="91440" bIns="45720" numCol="1" spcCol="0" rtlCol="0" fromWordArt="0" anchor="ctr" anchorCtr="0" forceAA="0" compatLnSpc="0">
+            <a:spAutoFit/>
+          </a:bodyPr>
+          <a:lstStyle/>
+          <a:p>
+            <a:pPr algn="ctr">
+              <a:defRPr/>
+            </a:pPr>
+            <a:r>
+              <a:rPr lang="en" sz="3600" b="1">
+                <a:ln w="6349">
+                  <a:solidFill>
+                    <a:srgbClr val="000000"/>
+                  </a:solidFill>
+                  <a:prstDash val="solid"/>
+                </a:ln>
+                <a:solidFill>
+                  <a:srgbClr val="92D050"/>
+                </a:solidFill>
+                <a:latin typeface="Cantarell Extra Bold"/>
+                <a:ea typeface="Cantarell Extra Bold"/>
+                <a:cs typeface="Cantarell Extra Bold"/>
+              </a:rPr>
+              <a:t>DOPO</a:t>
+            </a:r>
+            <a:endParaRPr>
+              <a:ln w="6349">
+                <a:solidFill>
+                  <a:schemeClr val="tx1"/>
+                </a:solidFill>
+                <a:prstDash val="solid"/>
+              </a:ln>
+            </a:endParaRPr>
+          </a:p>
+        </p:txBody>
+      </p:sp>
+    </p:spTree>
+  </p:cSld>
+  <p:clrMapOvr>
+    <a:masterClrMapping/>
+  </p:clrMapOvr>
+</p:sld>
+</file>
+
+<file path=ppt/slides/slide28.xml><?xml version="1.0" encoding="utf-8"?>
+<p:sld xmlns:a="http://schemas.openxmlformats.org/drawingml/2006/main" xmlns:r="http://schemas.openxmlformats.org/officeDocument/2006/relationships" xmlns:p="http://schemas.openxmlformats.org/presentationml/2006/main" showMasterPhAnim="0">
+  <p:cSld>
+    <p:spTree>
+      <p:nvGrpSpPr>
+        <p:cNvPr id="1" name=""/>
+        <p:cNvGrpSpPr/>
+        <p:nvPr/>
+      </p:nvGrpSpPr>
+      <p:grpSpPr bwMode="auto">
+        <a:xfrm>
+          <a:off x="0" y="0"/>
+          <a:ext cx="0" cy="0"/>
+          <a:chOff x="0" y="0"/>
+          <a:chExt cx="0" cy="0"/>
+        </a:xfrm>
+      </p:grpSpPr>
+      <p:sp>
+        <p:nvSpPr>
           <p:cNvPr id="1068862128" name="Titolo 1"/>
           <p:cNvSpPr>
             <a:spLocks noGrp="1"/>
@@ -13184,7 +13567,7 @@
 </p:sld>
 </file>
 
-<file path=ppt/slides/slide27.xml><?xml version="1.0" encoding="utf-8"?>
+<file path=ppt/slides/slide29.xml><?xml version="1.0" encoding="utf-8"?>
 <p:sld xmlns:a="http://schemas.openxmlformats.org/drawingml/2006/main" xmlns:r="http://schemas.openxmlformats.org/officeDocument/2006/relationships" xmlns:p="http://schemas.openxmlformats.org/presentationml/2006/main" showMasterPhAnim="0">
   <p:cSld>
     <p:spTree>

</xml_diff>

<commit_message>
migliorato parte MVC powerpoint
</commit_message>
<xml_diff>
--- a/doc/Presentazione/Presentazione_ingsw_parteB.pptx
+++ b/doc/Presentazione/Presentazione_ingsw_parteB.pptx
@@ -14492,7 +14492,9 @@
         </p:nvSpPr>
         <p:spPr bwMode="auto"/>
         <p:txBody>
-          <a:bodyPr/>
+          <a:bodyPr>
+            <a:normAutofit lnSpcReduction="10000"/>
+          </a:bodyPr>
           <a:lstStyle/>
           <a:p>
             <a:pPr marL="0" indent="0">
@@ -14536,8 +14538,29 @@
             </a:r>
             <a:r>
               <a:rPr lang="en" dirty="0"/>
-              <a:t> sono i REST controller, utilizzati per fornire le API per recuperare/inviare dati dal backend.</a:t>
-            </a:r>
+              <a:t> </a:t>
+            </a:r>
+            <a:r>
+              <a:rPr lang="it-IT" dirty="0"/>
+              <a:t>comprendono sia i </a:t>
+            </a:r>
+            <a:r>
+              <a:rPr lang="it-IT" dirty="0" err="1"/>
+              <a:t>View</a:t>
+            </a:r>
+            <a:r>
+              <a:rPr lang="it-IT" dirty="0"/>
+              <a:t> Controller (per la parte di interfaccia) sia i REST Controller, che espongono le API per l’invio e il recupero dei dati dal </a:t>
+            </a:r>
+            <a:r>
+              <a:rPr lang="it-IT" dirty="0" err="1"/>
+              <a:t>backend</a:t>
+            </a:r>
+            <a:r>
+              <a:rPr lang="it-IT" dirty="0"/>
+              <a:t>.</a:t>
+            </a:r>
+            <a:endParaRPr lang="en" dirty="0"/>
           </a:p>
           <a:p>
             <a:pPr lvl="0">
@@ -14553,7 +14576,7 @@
             </a:r>
             <a:r>
               <a:rPr lang="en" dirty="0"/>
-              <a:t>consiste nei service che svolgono la logica di business.</a:t>
+              <a:t>è costituitodai Service che svolgono la logica di business, dal layer di persistence che si interfaccia con il DB tramite le repository, e dagli oggetti di dominio come entity, che vengono poi trasformati dagli adapter in domain objects per essere utilizzati nei service. </a:t>
             </a:r>
           </a:p>
         </p:txBody>

</xml_diff>

<commit_message>
Modifica del diagramma di sequenza
</commit_message>
<xml_diff>
--- a/doc/Presentazione/Presentazione_ingsw_parteB.pptx
+++ b/doc/Presentazione/Presentazione_ingsw_parteB.pptx
@@ -241,7 +241,7 @@
             </a:pPr>
             <a:fld id="{3632E96E-41F7-40C5-8419-297958CC00FA}" type="datetimeFigureOut">
               <a:rPr lang="it-IT"/>
-              <a:t>25/10/2025</a:t>
+              <a:t>26/10/2025</a:t>
             </a:fld>
             <a:endParaRPr lang="it-IT"/>
           </a:p>
@@ -2571,7 +2571,7 @@
             </a:pPr>
             <a:fld id="{BCC18F51-09EC-435C-A3BA-64A766E099C0}" type="datetimeFigureOut">
               <a:rPr lang="it-IT"/>
-              <a:t>25/10/2025</a:t>
+              <a:t>26/10/2025</a:t>
             </a:fld>
             <a:endParaRPr lang="it-IT"/>
           </a:p>
@@ -2760,7 +2760,7 @@
             </a:pPr>
             <a:fld id="{BCC18F51-09EC-435C-A3BA-64A766E099C0}" type="datetimeFigureOut">
               <a:rPr lang="it-IT"/>
-              <a:t>25/10/2025</a:t>
+              <a:t>26/10/2025</a:t>
             </a:fld>
             <a:endParaRPr lang="it-IT"/>
           </a:p>
@@ -2959,7 +2959,7 @@
             </a:pPr>
             <a:fld id="{BCC18F51-09EC-435C-A3BA-64A766E099C0}" type="datetimeFigureOut">
               <a:rPr lang="it-IT"/>
-              <a:t>25/10/2025</a:t>
+              <a:t>26/10/2025</a:t>
             </a:fld>
             <a:endParaRPr lang="it-IT"/>
           </a:p>
@@ -3148,7 +3148,7 @@
             </a:pPr>
             <a:fld id="{BCC18F51-09EC-435C-A3BA-64A766E099C0}" type="datetimeFigureOut">
               <a:rPr lang="it-IT"/>
-              <a:t>25/10/2025</a:t>
+              <a:t>26/10/2025</a:t>
             </a:fld>
             <a:endParaRPr lang="it-IT"/>
           </a:p>
@@ -3403,7 +3403,7 @@
             </a:pPr>
             <a:fld id="{BCC18F51-09EC-435C-A3BA-64A766E099C0}" type="datetimeFigureOut">
               <a:rPr lang="it-IT"/>
-              <a:t>25/10/2025</a:t>
+              <a:t>26/10/2025</a:t>
             </a:fld>
             <a:endParaRPr lang="it-IT"/>
           </a:p>
@@ -3667,7 +3667,7 @@
             </a:pPr>
             <a:fld id="{BCC18F51-09EC-435C-A3BA-64A766E099C0}" type="datetimeFigureOut">
               <a:rPr lang="it-IT"/>
-              <a:t>25/10/2025</a:t>
+              <a:t>26/10/2025</a:t>
             </a:fld>
             <a:endParaRPr lang="it-IT"/>
           </a:p>
@@ -4072,7 +4072,7 @@
             </a:pPr>
             <a:fld id="{BCC18F51-09EC-435C-A3BA-64A766E099C0}" type="datetimeFigureOut">
               <a:rPr lang="it-IT"/>
-              <a:t>25/10/2025</a:t>
+              <a:t>26/10/2025</a:t>
             </a:fld>
             <a:endParaRPr lang="it-IT"/>
           </a:p>
@@ -4196,7 +4196,7 @@
             </a:pPr>
             <a:fld id="{BCC18F51-09EC-435C-A3BA-64A766E099C0}" type="datetimeFigureOut">
               <a:rPr lang="it-IT"/>
-              <a:t>25/10/2025</a:t>
+              <a:t>26/10/2025</a:t>
             </a:fld>
             <a:endParaRPr lang="it-IT"/>
           </a:p>
@@ -4295,7 +4295,7 @@
             </a:pPr>
             <a:fld id="{BCC18F51-09EC-435C-A3BA-64A766E099C0}" type="datetimeFigureOut">
               <a:rPr lang="it-IT"/>
-              <a:t>25/10/2025</a:t>
+              <a:t>26/10/2025</a:t>
             </a:fld>
             <a:endParaRPr lang="it-IT"/>
           </a:p>
@@ -4594,7 +4594,7 @@
             </a:pPr>
             <a:fld id="{BCC18F51-09EC-435C-A3BA-64A766E099C0}" type="datetimeFigureOut">
               <a:rPr lang="it-IT"/>
-              <a:t>25/10/2025</a:t>
+              <a:t>26/10/2025</a:t>
             </a:fld>
             <a:endParaRPr lang="it-IT"/>
           </a:p>
@@ -4862,7 +4862,7 @@
             </a:pPr>
             <a:fld id="{BCC18F51-09EC-435C-A3BA-64A766E099C0}" type="datetimeFigureOut">
               <a:rPr lang="it-IT"/>
-              <a:t>25/10/2025</a:t>
+              <a:t>26/10/2025</a:t>
             </a:fld>
             <a:endParaRPr lang="it-IT"/>
           </a:p>
@@ -5118,7 +5118,7 @@
             </a:pPr>
             <a:fld id="{BCC18F51-09EC-435C-A3BA-64A766E099C0}" type="datetimeFigureOut">
               <a:rPr lang="it-IT"/>
-              <a:t>25/10/2025</a:t>
+              <a:t>26/10/2025</a:t>
             </a:fld>
             <a:endParaRPr lang="it-IT"/>
           </a:p>
@@ -5667,7 +5667,7 @@
                 <a:ea typeface="DejaVu Sans Condensed"/>
                 <a:cs typeface="DejaVu Sans Condensed"/>
               </a:rPr>
-              <a:t>Khater Abdelaziz	</a:t>
+              <a:t>Khater Abdelaziz		</a:t>
             </a:r>
             <a:r>
               <a:rPr lang="en" sz="1800" b="0" i="0" u="none" strike="noStrike" cap="none" spc="0" dirty="0">
@@ -8618,7 +8618,7 @@
                 <a:ea typeface="DejaVu Sans Condensed"/>
                 <a:cs typeface="DejaVu Sans Condensed"/>
               </a:rPr>
-              <a:t>SOLID 1 – Dependency Inversion 		11</a:t>
+              <a:t>SOLID 1 – Dependency Inversion 			11</a:t>
             </a:r>
             <a:endParaRPr sz="1800" dirty="0">
               <a:latin typeface="DejaVu Sans Condensed"/>
@@ -8665,7 +8665,7 @@
                 <a:latin typeface="DejaVu Sans Condensed"/>
                 <a:cs typeface="DejaVu Sans Condensed"/>
               </a:rPr>
-              <a:t>GoF 1 – Strategy				13-15</a:t>
+              <a:t>GoF 1 – Strategy					13-15</a:t>
             </a:r>
           </a:p>
           <a:p>
@@ -8717,7 +8717,7 @@
                 <a:ea typeface="DejaVu Sans Condensed"/>
                 <a:cs typeface="DejaVu Sans Condensed"/>
               </a:rPr>
-              <a:t>Esempi di refactoring				24-28</a:t>
+              <a:t>Esempi di refactoring					24-28</a:t>
             </a:r>
             <a:endParaRPr sz="1800" dirty="0">
               <a:latin typeface="Cantarell"/>
@@ -14576,7 +14576,7 @@
             </a:r>
             <a:r>
               <a:rPr lang="en" dirty="0"/>
-              <a:t>è costituitodai Service che svolgono la logica di business, dal layer di persistence che si interfaccia con il DB tramite le repository, e dagli oggetti di dominio come entity, che vengono poi trasformati dagli adapter in domain objects per essere utilizzati nei service. </a:t>
+              <a:t>è costituito dai Service che svolgono la logica di business, dal layer di persistence che si interfaccia con il DB tramite le repository, e dagli oggetti di dominio come entity, che vengono poi trasformati dagli adapter in domain objects per essere utilizzati nei service. </a:t>
             </a:r>
           </a:p>
         </p:txBody>
@@ -14715,14 +14715,13 @@
               </a:ext>
             </a:extLst>
           </a:blip>
-          <a:stretch>
-            <a:fillRect/>
-          </a:stretch>
+          <a:srcRect/>
+          <a:stretch/>
         </p:blipFill>
         <p:spPr>
           <a:xfrm>
-            <a:off x="107950" y="1634304"/>
-            <a:ext cx="11976100" cy="4525557"/>
+            <a:off x="316668" y="1634304"/>
+            <a:ext cx="11558664" cy="4525557"/>
           </a:xfrm>
           <a:prstGeom prst="rect">
             <a:avLst/>

</xml_diff>